<commit_message>
Update Slide 2 to show 2 founders layout
</commit_message>
<xml_diff>
--- a/CoalOmIT_Pitch_Deck.pptx
+++ b/CoalOmIT_Pitch_Deck.pptx
@@ -6416,8 +6416,8 @@
         </p:nvSpPr>
         <p:spPr>
           <a:xfrm>
-            <a:off x="731520" y="1463040"/>
-            <a:ext cx="3383280" cy="2011680"/>
+            <a:off x="1371600" y="1463040"/>
+            <a:ext cx="4389120" cy="2103120"/>
           </a:xfrm>
           <a:prstGeom prst="roundRect">
             <a:avLst/>
@@ -6470,8 +6470,8 @@
         </p:nvSpPr>
         <p:spPr>
           <a:xfrm>
-            <a:off x="731520" y="3566160"/>
-            <a:ext cx="3383280" cy="2560320"/>
+            <a:off x="1371600" y="3657600"/>
+            <a:ext cx="4389120" cy="2468880"/>
           </a:xfrm>
           <a:prstGeom prst="rect">
             <a:avLst/>
@@ -6485,46 +6485,42 @@
           <a:lstStyle/>
           <a:p>
             <a:pPr>
-              <a:defRPr b="1" sz="1600">
+              <a:defRPr b="1" sz="1800">
                 <a:solidFill>
                   <a:srgbClr val="FFFFFF"/>
                 </a:solidFill>
               </a:defRPr>
             </a:pPr>
             <a:r>
-              <a:t>Founder / Executive Name 1</a:t>
+              <a:t>Founder 1 Name</a:t>
             </a:r>
           </a:p>
           <a:p>
             <a:pPr>
-              <a:defRPr b="1" sz="1200">
+              <a:defRPr b="1" sz="1300">
                 <a:solidFill>
                   <a:srgbClr val="00FF88"/>
                 </a:solidFill>
               </a:defRPr>
             </a:pPr>
             <a:r>
-              <a:t>Title &amp; Role (e.g. Co-Founder &amp; CEO / CTO)</a:t>
+              <a:t>Co-Founder &amp; Lead Engineer</a:t>
             </a:r>
           </a:p>
           <a:p>
             <a:pPr>
-              <a:defRPr sz="1100">
+              <a:defRPr sz="1200">
                 <a:solidFill>
                   <a:srgbClr val="E8E8F0"/>
                 </a:solidFill>
               </a:defRPr>
             </a:pPr>
             <a:r>
-              <a:t>• Background: Alumnus / Ex-Senior ML Engineer at Top Tech</a:t>
+              <a:t>• Undergraduate Student Engineer</a:t>
             </a:r>
             <a:br/>
             <a:r>
-              <a:t>• Domain expertise in AI Infrastructure &amp; Sustainability</a:t>
-            </a:r>
-            <a:br/>
-            <a:r>
-              <a:t>• Built &amp; scaled previous engineering initiatives</a:t>
+              <a:t>• Core Architecture &amp; AI Tooling Lead</a:t>
             </a:r>
           </a:p>
         </p:txBody>
@@ -6537,8 +6533,8 @@
         </p:nvSpPr>
         <p:spPr>
           <a:xfrm>
-            <a:off x="4389120" y="1463040"/>
-            <a:ext cx="3383280" cy="2011680"/>
+            <a:off x="6400800" y="1463040"/>
+            <a:ext cx="4389120" cy="2103120"/>
           </a:xfrm>
           <a:prstGeom prst="roundRect">
             <a:avLst/>
@@ -6591,8 +6587,8 @@
         </p:nvSpPr>
         <p:spPr>
           <a:xfrm>
-            <a:off x="4389120" y="3566160"/>
-            <a:ext cx="3383280" cy="2560320"/>
+            <a:off x="6400800" y="3657600"/>
+            <a:ext cx="4389120" cy="2468880"/>
           </a:xfrm>
           <a:prstGeom prst="rect">
             <a:avLst/>
@@ -6606,167 +6602,42 @@
           <a:lstStyle/>
           <a:p>
             <a:pPr>
-              <a:defRPr b="1" sz="1600">
+              <a:defRPr b="1" sz="1800">
                 <a:solidFill>
                   <a:srgbClr val="FFFFFF"/>
                 </a:solidFill>
               </a:defRPr>
             </a:pPr>
             <a:r>
-              <a:t>Founder / Executive Name 2</a:t>
+              <a:t>Founder 2 Name</a:t>
             </a:r>
           </a:p>
           <a:p>
             <a:pPr>
-              <a:defRPr b="1" sz="1200">
+              <a:defRPr b="1" sz="1300">
                 <a:solidFill>
                   <a:srgbClr val="00FF88"/>
                 </a:solidFill>
               </a:defRPr>
             </a:pPr>
             <a:r>
-              <a:t>Title &amp; Role (e.g. Co-Founder &amp; CEO / CTO)</a:t>
+              <a:t>Co-Founder &amp; Systems Lead</a:t>
             </a:r>
           </a:p>
           <a:p>
             <a:pPr>
-              <a:defRPr sz="1100">
+              <a:defRPr sz="1200">
                 <a:solidFill>
                   <a:srgbClr val="E8E8F0"/>
                 </a:solidFill>
               </a:defRPr>
             </a:pPr>
             <a:r>
-              <a:t>• Background: Alumnus / Ex-Senior ML Engineer at Top Tech</a:t>
+              <a:t>• Undergraduate Student Engineer</a:t>
             </a:r>
             <a:br/>
             <a:r>
-              <a:t>• Domain expertise in AI Infrastructure &amp; Sustainability</a:t>
-            </a:r>
-            <a:br/>
-            <a:r>
-              <a:t>• Built &amp; scaled previous engineering initiatives</a:t>
-            </a:r>
-          </a:p>
-        </p:txBody>
-      </p:sp>
-      <p:sp>
-        <p:nvSpPr>
-          <p:cNvPr id="11" name="Rounded Rectangle 10"/>
-          <p:cNvSpPr/>
-          <p:nvPr/>
-        </p:nvSpPr>
-        <p:spPr>
-          <a:xfrm>
-            <a:off x="8046720" y="1463040"/>
-            <a:ext cx="3383280" cy="2011680"/>
-          </a:xfrm>
-          <a:prstGeom prst="roundRect">
-            <a:avLst/>
-          </a:prstGeom>
-          <a:solidFill>
-            <a:srgbClr val="0D0D1A"/>
-          </a:solidFill>
-          <a:ln w="12700">
-            <a:solidFill>
-              <a:srgbClr val="00D4FF"/>
-            </a:solidFill>
-          </a:ln>
-        </p:spPr>
-        <p:style>
-          <a:lnRef idx="1">
-            <a:schemeClr val="accent1"/>
-          </a:lnRef>
-          <a:fillRef idx="3">
-            <a:schemeClr val="accent1"/>
-          </a:fillRef>
-          <a:effectRef idx="2">
-            <a:schemeClr val="accent1"/>
-          </a:effectRef>
-          <a:fontRef idx="minor">
-            <a:schemeClr val="lt1"/>
-          </a:fontRef>
-        </p:style>
-        <p:txBody>
-          <a:bodyPr rtlCol="0" anchor="ctr"/>
-          <a:lstStyle/>
-          <a:p>
-            <a:pPr algn="ctr">
-              <a:defRPr sz="1400">
-                <a:solidFill>
-                  <a:srgbClr val="8C91A0"/>
-                </a:solidFill>
-              </a:defRPr>
-            </a:pPr>
-            <a:r>
-              <a:t>[ Insert Founder 3 Photo ]</a:t>
-            </a:r>
-          </a:p>
-        </p:txBody>
-      </p:sp>
-      <p:sp>
-        <p:nvSpPr>
-          <p:cNvPr id="12" name="TextBox 11"/>
-          <p:cNvSpPr txBox="1"/>
-          <p:nvPr/>
-        </p:nvSpPr>
-        <p:spPr>
-          <a:xfrm>
-            <a:off x="8046720" y="3566160"/>
-            <a:ext cx="3383280" cy="2560320"/>
-          </a:xfrm>
-          <a:prstGeom prst="rect">
-            <a:avLst/>
-          </a:prstGeom>
-          <a:noFill/>
-        </p:spPr>
-        <p:txBody>
-          <a:bodyPr wrap="square">
-            <a:spAutoFit/>
-          </a:bodyPr>
-          <a:lstStyle/>
-          <a:p>
-            <a:pPr>
-              <a:defRPr b="1" sz="1600">
-                <a:solidFill>
-                  <a:srgbClr val="FFFFFF"/>
-                </a:solidFill>
-              </a:defRPr>
-            </a:pPr>
-            <a:r>
-              <a:t>Founder / Executive Name 3</a:t>
-            </a:r>
-          </a:p>
-          <a:p>
-            <a:pPr>
-              <a:defRPr b="1" sz="1200">
-                <a:solidFill>
-                  <a:srgbClr val="00FF88"/>
-                </a:solidFill>
-              </a:defRPr>
-            </a:pPr>
-            <a:r>
-              <a:t>Title &amp; Role (e.g. Co-Founder &amp; CEO / CTO)</a:t>
-            </a:r>
-          </a:p>
-          <a:p>
-            <a:pPr>
-              <a:defRPr sz="1100">
-                <a:solidFill>
-                  <a:srgbClr val="E8E8F0"/>
-                </a:solidFill>
-              </a:defRPr>
-            </a:pPr>
-            <a:r>
-              <a:t>• Background: Alumnus / Ex-Senior ML Engineer at Top Tech</a:t>
-            </a:r>
-            <a:br/>
-            <a:r>
-              <a:t>• Domain expertise in AI Infrastructure &amp; Sustainability</a:t>
-            </a:r>
-            <a:br/>
-            <a:r>
-              <a:t>• Built &amp; scaled previous engineering initiatives</a:t>
+              <a:t>• Systems Architecture &amp; CI/CD Lead</a:t>
             </a:r>
           </a:p>
         </p:txBody>

</xml_diff>

<commit_message>
Update pitch deck theme to match CoalØmit amber orange screenshot
</commit_message>
<xml_diff>
--- a/CoalOmIT_Pitch_Deck.pptx
+++ b/CoalOmIT_Pitch_Deck.pptx
@@ -3115,7 +3115,7 @@
             <a:avLst/>
           </a:prstGeom>
           <a:solidFill>
-            <a:srgbClr val="060610"/>
+            <a:srgbClr val="121212"/>
           </a:solidFill>
           <a:ln>
             <a:noFill/>
@@ -3158,11 +3158,11 @@
             <a:avLst/>
           </a:prstGeom>
           <a:solidFill>
-            <a:srgbClr val="060610"/>
+            <a:srgbClr val="121212"/>
           </a:solidFill>
           <a:ln w="25400">
             <a:solidFill>
-              <a:srgbClr val="00FF88"/>
+              <a:srgbClr val="FF6E00"/>
             </a:solidFill>
           </a:ln>
         </p:spPr>
@@ -3196,8 +3196,8 @@
         </p:nvSpPr>
         <p:spPr>
           <a:xfrm>
-            <a:off x="731520" y="457200"/>
-            <a:ext cx="10728655" cy="1097280"/>
+            <a:off x="731520" y="365760"/>
+            <a:ext cx="10728655" cy="1188720"/>
           </a:xfrm>
           <a:prstGeom prst="rect">
             <a:avLst/>
@@ -3211,14 +3211,26 @@
           <a:lstStyle/>
           <a:p>
             <a:pPr algn="ctr">
-              <a:defRPr b="1" sz="4800">
-                <a:solidFill>
-                  <a:srgbClr val="00FF88"/>
-                </a:solidFill>
-              </a:defRPr>
-            </a:pPr>
-            <a:r>
-              <a:t>Cø CoalOmIT</a:t>
+              <a:defRPr b="1" sz="5400">
+                <a:solidFill>
+                  <a:srgbClr val="FF6E00"/>
+                </a:solidFill>
+              </a:defRPr>
+            </a:pPr>
+            <a:r>
+              <a:t>CoalØmit</a:t>
+            </a:r>
+          </a:p>
+          <a:p>
+            <a:pPr algn="ctr">
+              <a:defRPr b="1" sz="1600">
+                <a:solidFill>
+                  <a:srgbClr val="E5E5E5"/>
+                </a:solidFill>
+              </a:defRPr>
+            </a:pPr>
+            <a:r>
+              <a:t>REDUCE NOW SUSTAIN FOREVER</a:t>
             </a:r>
           </a:p>
         </p:txBody>
@@ -3231,7 +3243,7 @@
         </p:nvSpPr>
         <p:spPr>
           <a:xfrm>
-            <a:off x="914400" y="2743200"/>
+            <a:off x="914400" y="2926080"/>
             <a:ext cx="10362895" cy="2560320"/>
           </a:xfrm>
           <a:prstGeom prst="rect">
@@ -3246,26 +3258,26 @@
           <a:lstStyle/>
           <a:p>
             <a:pPr algn="ctr">
-              <a:defRPr b="1" sz="4000">
+              <a:defRPr b="1" sz="3800">
                 <a:solidFill>
                   <a:srgbClr val="FFFFFF"/>
                 </a:solidFill>
               </a:defRPr>
             </a:pPr>
             <a:r>
-              <a:t>Eliminate the Carbon Cost of Your AI Models</a:t>
+              <a:t>Green AI &amp; Carbon-Aware Compression 2.0</a:t>
             </a:r>
           </a:p>
           <a:p>
             <a:pPr algn="ctr">
               <a:defRPr sz="1800">
                 <a:solidFill>
-                  <a:srgbClr val="E8E8F0"/>
-                </a:solidFill>
-              </a:defRPr>
-            </a:pPr>
-            <a:r>
-              <a:t>CoalOmIT is an open-source toolkit that quantifies the energy and CO₂ trade-offs of AI model compression — in seconds, right inside your existing workflow.</a:t>
+                  <a:srgbClr val="D97706"/>
+                </a:solidFill>
+              </a:defRPr>
+            </a:pPr>
+            <a:r>
+              <a:t>Quantify, Compare &amp; Eliminate the Carbon Footprint of AI Models in Seconds</a:t>
             </a:r>
           </a:p>
         </p:txBody>
@@ -3285,7 +3297,7 @@
             <a:avLst/>
           </a:prstGeom>
           <a:solidFill>
-            <a:srgbClr val="060610"/>
+            <a:srgbClr val="121212"/>
           </a:solidFill>
           <a:ln>
             <a:noFill/>
@@ -3312,7 +3324,7 @@
             <a:pPr algn="r">
               <a:defRPr sz="1100">
                 <a:solidFill>
-                  <a:srgbClr val="00FF88"/>
+                  <a:srgbClr val="FF6E00"/>
                 </a:solidFill>
               </a:defRPr>
             </a:pPr>
@@ -3355,7 +3367,7 @@
             <a:avLst/>
           </a:prstGeom>
           <a:solidFill>
-            <a:srgbClr val="060610"/>
+            <a:srgbClr val="121212"/>
           </a:solidFill>
           <a:ln>
             <a:noFill/>
@@ -3398,11 +3410,11 @@
             <a:avLst/>
           </a:prstGeom>
           <a:solidFill>
-            <a:srgbClr val="060610"/>
+            <a:srgbClr val="121212"/>
           </a:solidFill>
           <a:ln w="19050">
             <a:solidFill>
-              <a:srgbClr val="00FF88"/>
+              <a:srgbClr val="FF6E00"/>
             </a:solidFill>
           </a:ln>
         </p:spPr>
@@ -3443,7 +3455,7 @@
             <a:avLst/>
           </a:prstGeom>
           <a:solidFill>
-            <a:srgbClr val="00FF88"/>
+            <a:srgbClr val="FF6E00"/>
           </a:solidFill>
           <a:ln>
             <a:noFill/>
@@ -3470,12 +3482,12 @@
             <a:pPr algn="ctr">
               <a:defRPr b="1" sz="2200">
                 <a:solidFill>
-                  <a:srgbClr val="060610"/>
-                </a:solidFill>
-              </a:defRPr>
-            </a:pPr>
-            <a:r>
-              <a:t>Cø</a:t>
+                  <a:srgbClr val="121212"/>
+                </a:solidFill>
+              </a:defRPr>
+            </a:pPr>
+            <a:r>
+              <a:t>CØ</a:t>
             </a:r>
           </a:p>
         </p:txBody>
@@ -3505,12 +3517,12 @@
             <a:pPr>
               <a:defRPr b="1" sz="1400">
                 <a:solidFill>
-                  <a:srgbClr val="00FF88"/>
-                </a:solidFill>
-              </a:defRPr>
-            </a:pPr>
-            <a:r>
-              <a:t>CoalOmIT</a:t>
+                  <a:srgbClr val="FF6E00"/>
+                </a:solidFill>
+              </a:defRPr>
+            </a:pPr>
+            <a:r>
+              <a:t>CoalØmit</a:t>
             </a:r>
           </a:p>
           <a:p>
@@ -3542,7 +3554,7 @@
             <a:avLst/>
           </a:prstGeom>
           <a:solidFill>
-            <a:srgbClr val="060610"/>
+            <a:srgbClr val="121212"/>
           </a:solidFill>
           <a:ln>
             <a:noFill/>
@@ -3569,12 +3581,12 @@
             <a:pPr algn="r">
               <a:defRPr sz="1000">
                 <a:solidFill>
-                  <a:srgbClr val="8C91A0"/>
-                </a:solidFill>
-              </a:defRPr>
-            </a:pPr>
-            <a:r>
-              <a:t>CoalOmIT — Green AI Platform  |  Confidential Pitch Deck</a:t>
+                  <a:srgbClr val="D97706"/>
+                </a:solidFill>
+              </a:defRPr>
+            </a:pPr>
+            <a:r>
+              <a:t>CoalØmit — REDUCE NOW SUSTAIN FOREVER  |  REDUCE NOW SUSTAIN FOREVER</a:t>
             </a:r>
           </a:p>
         </p:txBody>
@@ -3594,11 +3606,11 @@
             <a:avLst/>
           </a:prstGeom>
           <a:solidFill>
-            <a:srgbClr val="0D0D1A"/>
+            <a:srgbClr val="1A1A1A"/>
           </a:solidFill>
           <a:ln w="19050">
             <a:solidFill>
-              <a:srgbClr val="00FF88"/>
+              <a:srgbClr val="FF6E00"/>
             </a:solidFill>
           </a:ln>
         </p:spPr>
@@ -3623,7 +3635,7 @@
             <a:pPr algn="ctr">
               <a:defRPr b="1" sz="3800">
                 <a:solidFill>
-                  <a:srgbClr val="00FF88"/>
+                  <a:srgbClr val="FF6E00"/>
                 </a:solidFill>
               </a:defRPr>
             </a:pPr>
@@ -3647,7 +3659,7 @@
             <a:pPr algn="ctr">
               <a:defRPr sz="1100">
                 <a:solidFill>
-                  <a:srgbClr val="8C91A0"/>
+                  <a:srgbClr val="D97706"/>
                 </a:solidFill>
               </a:defRPr>
             </a:pPr>
@@ -3672,11 +3684,11 @@
             <a:avLst/>
           </a:prstGeom>
           <a:solidFill>
-            <a:srgbClr val="0D0D1A"/>
+            <a:srgbClr val="1A1A1A"/>
           </a:solidFill>
           <a:ln w="19050">
             <a:solidFill>
-              <a:srgbClr val="00FF88"/>
+              <a:srgbClr val="FF6E00"/>
             </a:solidFill>
           </a:ln>
         </p:spPr>
@@ -3701,7 +3713,7 @@
             <a:pPr algn="ctr">
               <a:defRPr b="1" sz="3800">
                 <a:solidFill>
-                  <a:srgbClr val="00FF88"/>
+                  <a:srgbClr val="FF6E00"/>
                 </a:solidFill>
               </a:defRPr>
             </a:pPr>
@@ -3725,7 +3737,7 @@
             <a:pPr algn="ctr">
               <a:defRPr sz="1100">
                 <a:solidFill>
-                  <a:srgbClr val="8C91A0"/>
+                  <a:srgbClr val="D97706"/>
                 </a:solidFill>
               </a:defRPr>
             </a:pPr>
@@ -3750,11 +3762,11 @@
             <a:avLst/>
           </a:prstGeom>
           <a:solidFill>
-            <a:srgbClr val="0D0D1A"/>
+            <a:srgbClr val="1A1A1A"/>
           </a:solidFill>
           <a:ln w="19050">
             <a:solidFill>
-              <a:srgbClr val="00FF88"/>
+              <a:srgbClr val="FF6E00"/>
             </a:solidFill>
           </a:ln>
         </p:spPr>
@@ -3779,7 +3791,7 @@
             <a:pPr algn="ctr">
               <a:defRPr b="1" sz="3800">
                 <a:solidFill>
-                  <a:srgbClr val="00FF88"/>
+                  <a:srgbClr val="FF6E00"/>
                 </a:solidFill>
               </a:defRPr>
             </a:pPr>
@@ -3803,7 +3815,7 @@
             <a:pPr algn="ctr">
               <a:defRPr sz="1100">
                 <a:solidFill>
-                  <a:srgbClr val="8C91A0"/>
+                  <a:srgbClr val="D97706"/>
                 </a:solidFill>
               </a:defRPr>
             </a:pPr>
@@ -3828,11 +3840,11 @@
             <a:avLst/>
           </a:prstGeom>
           <a:solidFill>
-            <a:srgbClr val="0D0D1A"/>
+            <a:srgbClr val="1A1A1A"/>
           </a:solidFill>
           <a:ln w="19050">
             <a:solidFill>
-              <a:srgbClr val="00FF88"/>
+              <a:srgbClr val="FF6E00"/>
             </a:solidFill>
           </a:ln>
         </p:spPr>
@@ -3857,7 +3869,7 @@
             <a:pPr algn="ctr">
               <a:defRPr b="1" sz="3800">
                 <a:solidFill>
-                  <a:srgbClr val="00FF88"/>
+                  <a:srgbClr val="FF6E00"/>
                 </a:solidFill>
               </a:defRPr>
             </a:pPr>
@@ -3881,7 +3893,7 @@
             <a:pPr algn="ctr">
               <a:defRPr sz="1100">
                 <a:solidFill>
-                  <a:srgbClr val="8C91A0"/>
+                  <a:srgbClr val="D97706"/>
                 </a:solidFill>
               </a:defRPr>
             </a:pPr>
@@ -3924,7 +3936,7 @@
             <a:avLst/>
           </a:prstGeom>
           <a:solidFill>
-            <a:srgbClr val="060610"/>
+            <a:srgbClr val="121212"/>
           </a:solidFill>
           <a:ln>
             <a:noFill/>
@@ -3967,11 +3979,11 @@
             <a:avLst/>
           </a:prstGeom>
           <a:solidFill>
-            <a:srgbClr val="060610"/>
+            <a:srgbClr val="121212"/>
           </a:solidFill>
           <a:ln w="19050">
             <a:solidFill>
-              <a:srgbClr val="00FF88"/>
+              <a:srgbClr val="FF6E00"/>
             </a:solidFill>
           </a:ln>
         </p:spPr>
@@ -4012,7 +4024,7 @@
             <a:avLst/>
           </a:prstGeom>
           <a:solidFill>
-            <a:srgbClr val="00FF88"/>
+            <a:srgbClr val="FF6E00"/>
           </a:solidFill>
           <a:ln>
             <a:noFill/>
@@ -4039,12 +4051,12 @@
             <a:pPr algn="ctr">
               <a:defRPr b="1" sz="2200">
                 <a:solidFill>
-                  <a:srgbClr val="060610"/>
-                </a:solidFill>
-              </a:defRPr>
-            </a:pPr>
-            <a:r>
-              <a:t>Cø</a:t>
+                  <a:srgbClr val="121212"/>
+                </a:solidFill>
+              </a:defRPr>
+            </a:pPr>
+            <a:r>
+              <a:t>CØ</a:t>
             </a:r>
           </a:p>
         </p:txBody>
@@ -4074,12 +4086,12 @@
             <a:pPr>
               <a:defRPr b="1" sz="1400">
                 <a:solidFill>
-                  <a:srgbClr val="00FF88"/>
-                </a:solidFill>
-              </a:defRPr>
-            </a:pPr>
-            <a:r>
-              <a:t>CoalOmIT</a:t>
+                  <a:srgbClr val="FF6E00"/>
+                </a:solidFill>
+              </a:defRPr>
+            </a:pPr>
+            <a:r>
+              <a:t>CoalØmit</a:t>
             </a:r>
           </a:p>
           <a:p>
@@ -4111,7 +4123,7 @@
             <a:avLst/>
           </a:prstGeom>
           <a:solidFill>
-            <a:srgbClr val="060610"/>
+            <a:srgbClr val="121212"/>
           </a:solidFill>
           <a:ln>
             <a:noFill/>
@@ -4138,12 +4150,12 @@
             <a:pPr algn="r">
               <a:defRPr sz="1000">
                 <a:solidFill>
-                  <a:srgbClr val="8C91A0"/>
-                </a:solidFill>
-              </a:defRPr>
-            </a:pPr>
-            <a:r>
-              <a:t>CoalOmIT — Green AI Platform  |  Confidential Pitch Deck</a:t>
+                  <a:srgbClr val="D97706"/>
+                </a:solidFill>
+              </a:defRPr>
+            </a:pPr>
+            <a:r>
+              <a:t>CoalØmit — REDUCE NOW SUSTAIN FOREVER  |  REDUCE NOW SUSTAIN FOREVER</a:t>
             </a:r>
           </a:p>
         </p:txBody>
@@ -4182,7 +4194,7 @@
                       <a:pPr algn="ctr">
                         <a:defRPr b="1" sz="1200">
                           <a:solidFill>
-                            <a:srgbClr val="00FF88"/>
+                            <a:srgbClr val="FF6E00"/>
                           </a:solidFill>
                         </a:defRPr>
                       </a:pPr>
@@ -4193,7 +4205,7 @@
                   </a:txBody>
                   <a:tcPr>
                     <a:solidFill>
-                      <a:srgbClr val="141428"/>
+                      <a:srgbClr val="222222"/>
                     </a:solidFill>
                   </a:tcPr>
                 </a:tc>
@@ -4205,7 +4217,7 @@
                       <a:pPr algn="ctr">
                         <a:defRPr b="1" sz="1200">
                           <a:solidFill>
-                            <a:srgbClr val="00FF88"/>
+                            <a:srgbClr val="FF6E00"/>
                           </a:solidFill>
                         </a:defRPr>
                       </a:pPr>
@@ -4216,7 +4228,7 @@
                   </a:txBody>
                   <a:tcPr>
                     <a:solidFill>
-                      <a:srgbClr val="141428"/>
+                      <a:srgbClr val="222222"/>
                     </a:solidFill>
                   </a:tcPr>
                 </a:tc>
@@ -4228,7 +4240,7 @@
                       <a:pPr algn="ctr">
                         <a:defRPr b="1" sz="1200">
                           <a:solidFill>
-                            <a:srgbClr val="00FF88"/>
+                            <a:srgbClr val="FF6E00"/>
                           </a:solidFill>
                         </a:defRPr>
                       </a:pPr>
@@ -4239,7 +4251,7 @@
                   </a:txBody>
                   <a:tcPr>
                     <a:solidFill>
-                      <a:srgbClr val="141428"/>
+                      <a:srgbClr val="222222"/>
                     </a:solidFill>
                   </a:tcPr>
                 </a:tc>
@@ -4251,7 +4263,7 @@
                       <a:pPr algn="ctr">
                         <a:defRPr b="1" sz="1200">
                           <a:solidFill>
-                            <a:srgbClr val="00FF88"/>
+                            <a:srgbClr val="FF6E00"/>
                           </a:solidFill>
                         </a:defRPr>
                       </a:pPr>
@@ -4262,7 +4274,7 @@
                   </a:txBody>
                   <a:tcPr>
                     <a:solidFill>
-                      <a:srgbClr val="141428"/>
+                      <a:srgbClr val="222222"/>
                     </a:solidFill>
                   </a:tcPr>
                 </a:tc>
@@ -4274,7 +4286,7 @@
                       <a:pPr algn="ctr">
                         <a:defRPr b="1" sz="1200">
                           <a:solidFill>
-                            <a:srgbClr val="00FF88"/>
+                            <a:srgbClr val="FF6E00"/>
                           </a:solidFill>
                         </a:defRPr>
                       </a:pPr>
@@ -4285,7 +4297,7 @@
                   </a:txBody>
                   <a:tcPr>
                     <a:solidFill>
-                      <a:srgbClr val="141428"/>
+                      <a:srgbClr val="222222"/>
                     </a:solidFill>
                   </a:tcPr>
                 </a:tc>
@@ -4299,7 +4311,7 @@
                       <a:pPr algn="ctr">
                         <a:defRPr sz="1100">
                           <a:solidFill>
-                            <a:srgbClr val="E8E8F0"/>
+                            <a:srgbClr val="E5E5E5"/>
                           </a:solidFill>
                         </a:defRPr>
                       </a:pPr>
@@ -4310,7 +4322,7 @@
                   </a:txBody>
                   <a:tcPr>
                     <a:solidFill>
-                      <a:srgbClr val="0D0D1A"/>
+                      <a:srgbClr val="1A1A1A"/>
                     </a:solidFill>
                   </a:tcPr>
                 </a:tc>
@@ -4322,7 +4334,7 @@
                       <a:pPr algn="ctr">
                         <a:defRPr sz="1100">
                           <a:solidFill>
-                            <a:srgbClr val="E8E8F0"/>
+                            <a:srgbClr val="E5E5E5"/>
                           </a:solidFill>
                         </a:defRPr>
                       </a:pPr>
@@ -4333,7 +4345,7 @@
                   </a:txBody>
                   <a:tcPr>
                     <a:solidFill>
-                      <a:srgbClr val="0D0D1A"/>
+                      <a:srgbClr val="1A1A1A"/>
                     </a:solidFill>
                   </a:tcPr>
                 </a:tc>
@@ -4345,7 +4357,7 @@
                       <a:pPr algn="ctr">
                         <a:defRPr sz="1100">
                           <a:solidFill>
-                            <a:srgbClr val="E8E8F0"/>
+                            <a:srgbClr val="E5E5E5"/>
                           </a:solidFill>
                         </a:defRPr>
                       </a:pPr>
@@ -4356,7 +4368,7 @@
                   </a:txBody>
                   <a:tcPr>
                     <a:solidFill>
-                      <a:srgbClr val="0D0D1A"/>
+                      <a:srgbClr val="1A1A1A"/>
                     </a:solidFill>
                   </a:tcPr>
                 </a:tc>
@@ -4368,7 +4380,7 @@
                       <a:pPr algn="ctr">
                         <a:defRPr sz="1100">
                           <a:solidFill>
-                            <a:srgbClr val="E8E8F0"/>
+                            <a:srgbClr val="E5E5E5"/>
                           </a:solidFill>
                         </a:defRPr>
                       </a:pPr>
@@ -4379,7 +4391,7 @@
                   </a:txBody>
                   <a:tcPr>
                     <a:solidFill>
-                      <a:srgbClr val="0D0D1A"/>
+                      <a:srgbClr val="1A1A1A"/>
                     </a:solidFill>
                   </a:tcPr>
                 </a:tc>
@@ -4391,7 +4403,7 @@
                       <a:pPr algn="ctr">
                         <a:defRPr sz="1100">
                           <a:solidFill>
-                            <a:srgbClr val="E8E8F0"/>
+                            <a:srgbClr val="E5E5E5"/>
                           </a:solidFill>
                         </a:defRPr>
                       </a:pPr>
@@ -4402,7 +4414,7 @@
                   </a:txBody>
                   <a:tcPr>
                     <a:solidFill>
-                      <a:srgbClr val="0D0D1A"/>
+                      <a:srgbClr val="1A1A1A"/>
                     </a:solidFill>
                   </a:tcPr>
                 </a:tc>
@@ -4416,7 +4428,7 @@
                       <a:pPr algn="ctr">
                         <a:defRPr sz="1100">
                           <a:solidFill>
-                            <a:srgbClr val="E8E8F0"/>
+                            <a:srgbClr val="E5E5E5"/>
                           </a:solidFill>
                         </a:defRPr>
                       </a:pPr>
@@ -4427,7 +4439,7 @@
                   </a:txBody>
                   <a:tcPr>
                     <a:solidFill>
-                      <a:srgbClr val="060610"/>
+                      <a:srgbClr val="121212"/>
                     </a:solidFill>
                   </a:tcPr>
                 </a:tc>
@@ -4439,7 +4451,7 @@
                       <a:pPr algn="ctr">
                         <a:defRPr sz="1100">
                           <a:solidFill>
-                            <a:srgbClr val="E8E8F0"/>
+                            <a:srgbClr val="E5E5E5"/>
                           </a:solidFill>
                         </a:defRPr>
                       </a:pPr>
@@ -4450,7 +4462,7 @@
                   </a:txBody>
                   <a:tcPr>
                     <a:solidFill>
-                      <a:srgbClr val="060610"/>
+                      <a:srgbClr val="121212"/>
                     </a:solidFill>
                   </a:tcPr>
                 </a:tc>
@@ -4462,7 +4474,7 @@
                       <a:pPr algn="ctr">
                         <a:defRPr sz="1100">
                           <a:solidFill>
-                            <a:srgbClr val="E8E8F0"/>
+                            <a:srgbClr val="E5E5E5"/>
                           </a:solidFill>
                         </a:defRPr>
                       </a:pPr>
@@ -4473,7 +4485,7 @@
                   </a:txBody>
                   <a:tcPr>
                     <a:solidFill>
-                      <a:srgbClr val="060610"/>
+                      <a:srgbClr val="121212"/>
                     </a:solidFill>
                   </a:tcPr>
                 </a:tc>
@@ -4485,7 +4497,7 @@
                       <a:pPr algn="ctr">
                         <a:defRPr sz="1100">
                           <a:solidFill>
-                            <a:srgbClr val="E8E8F0"/>
+                            <a:srgbClr val="E5E5E5"/>
                           </a:solidFill>
                         </a:defRPr>
                       </a:pPr>
@@ -4496,7 +4508,7 @@
                   </a:txBody>
                   <a:tcPr>
                     <a:solidFill>
-                      <a:srgbClr val="060610"/>
+                      <a:srgbClr val="121212"/>
                     </a:solidFill>
                   </a:tcPr>
                 </a:tc>
@@ -4508,7 +4520,7 @@
                       <a:pPr algn="ctr">
                         <a:defRPr sz="1100">
                           <a:solidFill>
-                            <a:srgbClr val="E8E8F0"/>
+                            <a:srgbClr val="E5E5E5"/>
                           </a:solidFill>
                         </a:defRPr>
                       </a:pPr>
@@ -4519,7 +4531,7 @@
                   </a:txBody>
                   <a:tcPr>
                     <a:solidFill>
-                      <a:srgbClr val="060610"/>
+                      <a:srgbClr val="121212"/>
                     </a:solidFill>
                   </a:tcPr>
                 </a:tc>
@@ -4533,7 +4545,7 @@
                       <a:pPr algn="ctr">
                         <a:defRPr sz="1100">
                           <a:solidFill>
-                            <a:srgbClr val="E8E8F0"/>
+                            <a:srgbClr val="E5E5E5"/>
                           </a:solidFill>
                         </a:defRPr>
                       </a:pPr>
@@ -4544,7 +4556,7 @@
                   </a:txBody>
                   <a:tcPr>
                     <a:solidFill>
-                      <a:srgbClr val="0D0D1A"/>
+                      <a:srgbClr val="1A1A1A"/>
                     </a:solidFill>
                   </a:tcPr>
                 </a:tc>
@@ -4556,7 +4568,7 @@
                       <a:pPr algn="ctr">
                         <a:defRPr sz="1100">
                           <a:solidFill>
-                            <a:srgbClr val="E8E8F0"/>
+                            <a:srgbClr val="E5E5E5"/>
                           </a:solidFill>
                         </a:defRPr>
                       </a:pPr>
@@ -4567,7 +4579,7 @@
                   </a:txBody>
                   <a:tcPr>
                     <a:solidFill>
-                      <a:srgbClr val="0D0D1A"/>
+                      <a:srgbClr val="1A1A1A"/>
                     </a:solidFill>
                   </a:tcPr>
                 </a:tc>
@@ -4579,7 +4591,7 @@
                       <a:pPr algn="ctr">
                         <a:defRPr sz="1100">
                           <a:solidFill>
-                            <a:srgbClr val="E8E8F0"/>
+                            <a:srgbClr val="E5E5E5"/>
                           </a:solidFill>
                         </a:defRPr>
                       </a:pPr>
@@ -4590,7 +4602,7 @@
                   </a:txBody>
                   <a:tcPr>
                     <a:solidFill>
-                      <a:srgbClr val="0D0D1A"/>
+                      <a:srgbClr val="1A1A1A"/>
                     </a:solidFill>
                   </a:tcPr>
                 </a:tc>
@@ -4602,7 +4614,7 @@
                       <a:pPr algn="ctr">
                         <a:defRPr sz="1100">
                           <a:solidFill>
-                            <a:srgbClr val="E8E8F0"/>
+                            <a:srgbClr val="E5E5E5"/>
                           </a:solidFill>
                         </a:defRPr>
                       </a:pPr>
@@ -4613,7 +4625,7 @@
                   </a:txBody>
                   <a:tcPr>
                     <a:solidFill>
-                      <a:srgbClr val="0D0D1A"/>
+                      <a:srgbClr val="1A1A1A"/>
                     </a:solidFill>
                   </a:tcPr>
                 </a:tc>
@@ -4625,7 +4637,7 @@
                       <a:pPr algn="ctr">
                         <a:defRPr sz="1100">
                           <a:solidFill>
-                            <a:srgbClr val="E8E8F0"/>
+                            <a:srgbClr val="E5E5E5"/>
                           </a:solidFill>
                         </a:defRPr>
                       </a:pPr>
@@ -4636,7 +4648,7 @@
                   </a:txBody>
                   <a:tcPr>
                     <a:solidFill>
-                      <a:srgbClr val="0D0D1A"/>
+                      <a:srgbClr val="1A1A1A"/>
                     </a:solidFill>
                   </a:tcPr>
                 </a:tc>
@@ -4650,7 +4662,7 @@
                       <a:pPr algn="ctr">
                         <a:defRPr sz="1100">
                           <a:solidFill>
-                            <a:srgbClr val="E8E8F0"/>
+                            <a:srgbClr val="E5E5E5"/>
                           </a:solidFill>
                         </a:defRPr>
                       </a:pPr>
@@ -4661,7 +4673,7 @@
                   </a:txBody>
                   <a:tcPr>
                     <a:solidFill>
-                      <a:srgbClr val="060610"/>
+                      <a:srgbClr val="121212"/>
                     </a:solidFill>
                   </a:tcPr>
                 </a:tc>
@@ -4673,7 +4685,7 @@
                       <a:pPr algn="ctr">
                         <a:defRPr sz="1100">
                           <a:solidFill>
-                            <a:srgbClr val="E8E8F0"/>
+                            <a:srgbClr val="E5E5E5"/>
                           </a:solidFill>
                         </a:defRPr>
                       </a:pPr>
@@ -4684,7 +4696,7 @@
                   </a:txBody>
                   <a:tcPr>
                     <a:solidFill>
-                      <a:srgbClr val="060610"/>
+                      <a:srgbClr val="121212"/>
                     </a:solidFill>
                   </a:tcPr>
                 </a:tc>
@@ -4696,7 +4708,7 @@
                       <a:pPr algn="ctr">
                         <a:defRPr sz="1100">
                           <a:solidFill>
-                            <a:srgbClr val="E8E8F0"/>
+                            <a:srgbClr val="E5E5E5"/>
                           </a:solidFill>
                         </a:defRPr>
                       </a:pPr>
@@ -4707,7 +4719,7 @@
                   </a:txBody>
                   <a:tcPr>
                     <a:solidFill>
-                      <a:srgbClr val="060610"/>
+                      <a:srgbClr val="121212"/>
                     </a:solidFill>
                   </a:tcPr>
                 </a:tc>
@@ -4719,7 +4731,7 @@
                       <a:pPr algn="ctr">
                         <a:defRPr sz="1100">
                           <a:solidFill>
-                            <a:srgbClr val="E8E8F0"/>
+                            <a:srgbClr val="E5E5E5"/>
                           </a:solidFill>
                         </a:defRPr>
                       </a:pPr>
@@ -4730,7 +4742,7 @@
                   </a:txBody>
                   <a:tcPr>
                     <a:solidFill>
-                      <a:srgbClr val="060610"/>
+                      <a:srgbClr val="121212"/>
                     </a:solidFill>
                   </a:tcPr>
                 </a:tc>
@@ -4742,7 +4754,7 @@
                       <a:pPr algn="ctr">
                         <a:defRPr sz="1100">
                           <a:solidFill>
-                            <a:srgbClr val="E8E8F0"/>
+                            <a:srgbClr val="E5E5E5"/>
                           </a:solidFill>
                         </a:defRPr>
                       </a:pPr>
@@ -4753,7 +4765,7 @@
                   </a:txBody>
                   <a:tcPr>
                     <a:solidFill>
-                      <a:srgbClr val="060610"/>
+                      <a:srgbClr val="121212"/>
                     </a:solidFill>
                   </a:tcPr>
                 </a:tc>
@@ -4787,7 +4799,7 @@
             <a:pPr>
               <a:defRPr b="1" sz="1800">
                 <a:solidFill>
-                  <a:srgbClr val="00FF88"/>
+                  <a:srgbClr val="FF6E00"/>
                 </a:solidFill>
               </a:defRPr>
             </a:pPr>
@@ -4799,7 +4811,7 @@
             <a:pPr>
               <a:defRPr b="1" sz="1800">
                 <a:solidFill>
-                  <a:srgbClr val="00FF88"/>
+                  <a:srgbClr val="FF6E00"/>
                 </a:solidFill>
               </a:defRPr>
             </a:pPr>
@@ -4842,7 +4854,7 @@
             <a:avLst/>
           </a:prstGeom>
           <a:solidFill>
-            <a:srgbClr val="060610"/>
+            <a:srgbClr val="121212"/>
           </a:solidFill>
           <a:ln>
             <a:noFill/>
@@ -4885,11 +4897,11 @@
             <a:avLst/>
           </a:prstGeom>
           <a:solidFill>
-            <a:srgbClr val="060610"/>
+            <a:srgbClr val="121212"/>
           </a:solidFill>
           <a:ln w="19050">
             <a:solidFill>
-              <a:srgbClr val="00FF88"/>
+              <a:srgbClr val="FF6E00"/>
             </a:solidFill>
           </a:ln>
         </p:spPr>
@@ -4930,7 +4942,7 @@
             <a:avLst/>
           </a:prstGeom>
           <a:solidFill>
-            <a:srgbClr val="00FF88"/>
+            <a:srgbClr val="FF6E00"/>
           </a:solidFill>
           <a:ln>
             <a:noFill/>
@@ -4957,12 +4969,12 @@
             <a:pPr algn="ctr">
               <a:defRPr b="1" sz="2200">
                 <a:solidFill>
-                  <a:srgbClr val="060610"/>
-                </a:solidFill>
-              </a:defRPr>
-            </a:pPr>
-            <a:r>
-              <a:t>Cø</a:t>
+                  <a:srgbClr val="121212"/>
+                </a:solidFill>
+              </a:defRPr>
+            </a:pPr>
+            <a:r>
+              <a:t>CØ</a:t>
             </a:r>
           </a:p>
         </p:txBody>
@@ -4992,12 +5004,12 @@
             <a:pPr>
               <a:defRPr b="1" sz="1400">
                 <a:solidFill>
-                  <a:srgbClr val="00FF88"/>
-                </a:solidFill>
-              </a:defRPr>
-            </a:pPr>
-            <a:r>
-              <a:t>CoalOmIT</a:t>
+                  <a:srgbClr val="FF6E00"/>
+                </a:solidFill>
+              </a:defRPr>
+            </a:pPr>
+            <a:r>
+              <a:t>CoalØmit</a:t>
             </a:r>
           </a:p>
           <a:p>
@@ -5029,7 +5041,7 @@
             <a:avLst/>
           </a:prstGeom>
           <a:solidFill>
-            <a:srgbClr val="060610"/>
+            <a:srgbClr val="121212"/>
           </a:solidFill>
           <a:ln>
             <a:noFill/>
@@ -5056,12 +5068,12 @@
             <a:pPr algn="r">
               <a:defRPr sz="1000">
                 <a:solidFill>
-                  <a:srgbClr val="8C91A0"/>
-                </a:solidFill>
-              </a:defRPr>
-            </a:pPr>
-            <a:r>
-              <a:t>CoalOmIT — Green AI Platform  |  Confidential Pitch Deck</a:t>
+                  <a:srgbClr val="D97706"/>
+                </a:solidFill>
+              </a:defRPr>
+            </a:pPr>
+            <a:r>
+              <a:t>CoalØmit — REDUCE NOW SUSTAIN FOREVER  |  REDUCE NOW SUSTAIN FOREVER</a:t>
             </a:r>
           </a:p>
         </p:txBody>
@@ -5098,7 +5110,7 @@
                       <a:pPr algn="ctr">
                         <a:defRPr b="1" sz="1300">
                           <a:solidFill>
-                            <a:srgbClr val="00FF88"/>
+                            <a:srgbClr val="FF6E00"/>
                           </a:solidFill>
                         </a:defRPr>
                       </a:pPr>
@@ -5109,7 +5121,7 @@
                   </a:txBody>
                   <a:tcPr>
                     <a:solidFill>
-                      <a:srgbClr val="141428"/>
+                      <a:srgbClr val="222222"/>
                     </a:solidFill>
                   </a:tcPr>
                 </a:tc>
@@ -5121,7 +5133,7 @@
                       <a:pPr algn="ctr">
                         <a:defRPr b="1" sz="1300">
                           <a:solidFill>
-                            <a:srgbClr val="00FF88"/>
+                            <a:srgbClr val="FF6E00"/>
                           </a:solidFill>
                         </a:defRPr>
                       </a:pPr>
@@ -5132,7 +5144,7 @@
                   </a:txBody>
                   <a:tcPr>
                     <a:solidFill>
-                      <a:srgbClr val="141428"/>
+                      <a:srgbClr val="222222"/>
                     </a:solidFill>
                   </a:tcPr>
                 </a:tc>
@@ -5144,18 +5156,18 @@
                       <a:pPr algn="ctr">
                         <a:defRPr b="1" sz="1300">
                           <a:solidFill>
-                            <a:srgbClr val="00FF88"/>
+                            <a:srgbClr val="FF6E00"/>
                           </a:solidFill>
                         </a:defRPr>
                       </a:pPr>
                       <a:r>
-                        <a:t>CoalOmIT Advantage</a:t>
+                        <a:t>CoalØmit Advantage</a:t>
                       </a:r>
                     </a:p>
                   </a:txBody>
                   <a:tcPr>
                     <a:solidFill>
-                      <a:srgbClr val="141428"/>
+                      <a:srgbClr val="222222"/>
                     </a:solidFill>
                   </a:tcPr>
                 </a:tc>
@@ -5169,7 +5181,7 @@
                       <a:pPr>
                         <a:defRPr sz="1100">
                           <a:solidFill>
-                            <a:srgbClr val="00FF88"/>
+                            <a:srgbClr val="FF6E00"/>
                           </a:solidFill>
                         </a:defRPr>
                       </a:pPr>
@@ -5185,7 +5197,7 @@
                   </a:txBody>
                   <a:tcPr>
                     <a:solidFill>
-                      <a:srgbClr val="0D0D1A"/>
+                      <a:srgbClr val="1A1A1A"/>
                     </a:solidFill>
                   </a:tcPr>
                 </a:tc>
@@ -5197,7 +5209,7 @@
                       <a:pPr>
                         <a:defRPr sz="1100">
                           <a:solidFill>
-                            <a:srgbClr val="00FF88"/>
+                            <a:srgbClr val="FF6E00"/>
                           </a:solidFill>
                         </a:defRPr>
                       </a:pPr>
@@ -5218,7 +5230,7 @@
                   </a:txBody>
                   <a:tcPr>
                     <a:solidFill>
-                      <a:srgbClr val="0D0D1A"/>
+                      <a:srgbClr val="1A1A1A"/>
                     </a:solidFill>
                   </a:tcPr>
                 </a:tc>
@@ -5230,7 +5242,7 @@
                       <a:pPr>
                         <a:defRPr sz="1100">
                           <a:solidFill>
-                            <a:srgbClr val="00FF88"/>
+                            <a:srgbClr val="FF6E00"/>
                           </a:solidFill>
                         </a:defRPr>
                       </a:pPr>
@@ -5251,7 +5263,7 @@
                   </a:txBody>
                   <a:tcPr>
                     <a:solidFill>
-                      <a:srgbClr val="0D0D1A"/>
+                      <a:srgbClr val="1A1A1A"/>
                     </a:solidFill>
                   </a:tcPr>
                 </a:tc>
@@ -5265,7 +5277,7 @@
                       <a:pPr>
                         <a:defRPr sz="1100">
                           <a:solidFill>
-                            <a:srgbClr val="00FF88"/>
+                            <a:srgbClr val="FF6E00"/>
                           </a:solidFill>
                         </a:defRPr>
                       </a:pPr>
@@ -5281,7 +5293,7 @@
                   </a:txBody>
                   <a:tcPr>
                     <a:solidFill>
-                      <a:srgbClr val="060610"/>
+                      <a:srgbClr val="121212"/>
                     </a:solidFill>
                   </a:tcPr>
                 </a:tc>
@@ -5293,7 +5305,7 @@
                       <a:pPr>
                         <a:defRPr sz="1100">
                           <a:solidFill>
-                            <a:srgbClr val="00FF88"/>
+                            <a:srgbClr val="FF6E00"/>
                           </a:solidFill>
                         </a:defRPr>
                       </a:pPr>
@@ -5314,7 +5326,7 @@
                   </a:txBody>
                   <a:tcPr>
                     <a:solidFill>
-                      <a:srgbClr val="060610"/>
+                      <a:srgbClr val="121212"/>
                     </a:solidFill>
                   </a:tcPr>
                 </a:tc>
@@ -5326,7 +5338,7 @@
                       <a:pPr>
                         <a:defRPr sz="1100">
                           <a:solidFill>
-                            <a:srgbClr val="00FF88"/>
+                            <a:srgbClr val="FF6E00"/>
                           </a:solidFill>
                         </a:defRPr>
                       </a:pPr>
@@ -5347,7 +5359,7 @@
                   </a:txBody>
                   <a:tcPr>
                     <a:solidFill>
-                      <a:srgbClr val="060610"/>
+                      <a:srgbClr val="121212"/>
                     </a:solidFill>
                   </a:tcPr>
                 </a:tc>
@@ -5361,7 +5373,7 @@
                       <a:pPr>
                         <a:defRPr sz="1100">
                           <a:solidFill>
-                            <a:srgbClr val="00FF88"/>
+                            <a:srgbClr val="FF6E00"/>
                           </a:solidFill>
                         </a:defRPr>
                       </a:pPr>
@@ -5377,7 +5389,7 @@
                   </a:txBody>
                   <a:tcPr>
                     <a:solidFill>
-                      <a:srgbClr val="0D0D1A"/>
+                      <a:srgbClr val="1A1A1A"/>
                     </a:solidFill>
                   </a:tcPr>
                 </a:tc>
@@ -5389,7 +5401,7 @@
                       <a:pPr>
                         <a:defRPr sz="1100">
                           <a:solidFill>
-                            <a:srgbClr val="00FF88"/>
+                            <a:srgbClr val="FF6E00"/>
                           </a:solidFill>
                         </a:defRPr>
                       </a:pPr>
@@ -5410,7 +5422,7 @@
                   </a:txBody>
                   <a:tcPr>
                     <a:solidFill>
-                      <a:srgbClr val="0D0D1A"/>
+                      <a:srgbClr val="1A1A1A"/>
                     </a:solidFill>
                   </a:tcPr>
                 </a:tc>
@@ -5422,7 +5434,7 @@
                       <a:pPr>
                         <a:defRPr sz="1100">
                           <a:solidFill>
-                            <a:srgbClr val="00FF88"/>
+                            <a:srgbClr val="FF6E00"/>
                           </a:solidFill>
                         </a:defRPr>
                       </a:pPr>
@@ -5443,7 +5455,7 @@
                   </a:txBody>
                   <a:tcPr>
                     <a:solidFill>
-                      <a:srgbClr val="0D0D1A"/>
+                      <a:srgbClr val="1A1A1A"/>
                     </a:solidFill>
                   </a:tcPr>
                 </a:tc>
@@ -5485,7 +5497,7 @@
             <a:avLst/>
           </a:prstGeom>
           <a:solidFill>
-            <a:srgbClr val="060610"/>
+            <a:srgbClr val="121212"/>
           </a:solidFill>
           <a:ln>
             <a:noFill/>
@@ -5528,11 +5540,11 @@
             <a:avLst/>
           </a:prstGeom>
           <a:solidFill>
-            <a:srgbClr val="060610"/>
+            <a:srgbClr val="121212"/>
           </a:solidFill>
           <a:ln w="19050">
             <a:solidFill>
-              <a:srgbClr val="00FF88"/>
+              <a:srgbClr val="FF6E00"/>
             </a:solidFill>
           </a:ln>
         </p:spPr>
@@ -5573,7 +5585,7 @@
             <a:avLst/>
           </a:prstGeom>
           <a:solidFill>
-            <a:srgbClr val="00FF88"/>
+            <a:srgbClr val="FF6E00"/>
           </a:solidFill>
           <a:ln>
             <a:noFill/>
@@ -5600,12 +5612,12 @@
             <a:pPr algn="ctr">
               <a:defRPr b="1" sz="2200">
                 <a:solidFill>
-                  <a:srgbClr val="060610"/>
-                </a:solidFill>
-              </a:defRPr>
-            </a:pPr>
-            <a:r>
-              <a:t>Cø</a:t>
+                  <a:srgbClr val="121212"/>
+                </a:solidFill>
+              </a:defRPr>
+            </a:pPr>
+            <a:r>
+              <a:t>CØ</a:t>
             </a:r>
           </a:p>
         </p:txBody>
@@ -5635,12 +5647,12 @@
             <a:pPr>
               <a:defRPr b="1" sz="1400">
                 <a:solidFill>
-                  <a:srgbClr val="00FF88"/>
-                </a:solidFill>
-              </a:defRPr>
-            </a:pPr>
-            <a:r>
-              <a:t>CoalOmIT</a:t>
+                  <a:srgbClr val="FF6E00"/>
+                </a:solidFill>
+              </a:defRPr>
+            </a:pPr>
+            <a:r>
+              <a:t>CoalØmit</a:t>
             </a:r>
           </a:p>
           <a:p>
@@ -5672,7 +5684,7 @@
             <a:avLst/>
           </a:prstGeom>
           <a:solidFill>
-            <a:srgbClr val="060610"/>
+            <a:srgbClr val="121212"/>
           </a:solidFill>
           <a:ln>
             <a:noFill/>
@@ -5699,12 +5711,12 @@
             <a:pPr algn="r">
               <a:defRPr sz="1000">
                 <a:solidFill>
-                  <a:srgbClr val="8C91A0"/>
-                </a:solidFill>
-              </a:defRPr>
-            </a:pPr>
-            <a:r>
-              <a:t>CoalOmIT — Green AI Platform  |  Confidential Pitch Deck</a:t>
+                  <a:srgbClr val="D97706"/>
+                </a:solidFill>
+              </a:defRPr>
+            </a:pPr>
+            <a:r>
+              <a:t>CoalØmit — REDUCE NOW SUSTAIN FOREVER  |  REDUCE NOW SUSTAIN FOREVER</a:t>
             </a:r>
           </a:p>
         </p:txBody>
@@ -5741,7 +5753,7 @@
                       <a:pPr algn="ctr">
                         <a:defRPr b="1" sz="1300">
                           <a:solidFill>
-                            <a:srgbClr val="00FF88"/>
+                            <a:srgbClr val="FF6E00"/>
                           </a:solidFill>
                         </a:defRPr>
                       </a:pPr>
@@ -5752,7 +5764,7 @@
                   </a:txBody>
                   <a:tcPr>
                     <a:solidFill>
-                      <a:srgbClr val="141428"/>
+                      <a:srgbClr val="222222"/>
                     </a:solidFill>
                   </a:tcPr>
                 </a:tc>
@@ -5764,7 +5776,7 @@
                       <a:pPr algn="ctr">
                         <a:defRPr b="1" sz="1300">
                           <a:solidFill>
-                            <a:srgbClr val="00FF88"/>
+                            <a:srgbClr val="FF6E00"/>
                           </a:solidFill>
                         </a:defRPr>
                       </a:pPr>
@@ -5775,7 +5787,7 @@
                   </a:txBody>
                   <a:tcPr>
                     <a:solidFill>
-                      <a:srgbClr val="141428"/>
+                      <a:srgbClr val="222222"/>
                     </a:solidFill>
                   </a:tcPr>
                 </a:tc>
@@ -5787,7 +5799,7 @@
                       <a:pPr algn="ctr">
                         <a:defRPr b="1" sz="1300">
                           <a:solidFill>
-                            <a:srgbClr val="00FF88"/>
+                            <a:srgbClr val="FF6E00"/>
                           </a:solidFill>
                         </a:defRPr>
                       </a:pPr>
@@ -5798,7 +5810,7 @@
                   </a:txBody>
                   <a:tcPr>
                     <a:solidFill>
-                      <a:srgbClr val="141428"/>
+                      <a:srgbClr val="222222"/>
                     </a:solidFill>
                   </a:tcPr>
                 </a:tc>
@@ -5812,7 +5824,7 @@
                       <a:pPr>
                         <a:defRPr sz="1100">
                           <a:solidFill>
-                            <a:srgbClr val="E8E8F0"/>
+                            <a:srgbClr val="E5E5E5"/>
                           </a:solidFill>
                         </a:defRPr>
                       </a:pPr>
@@ -5823,7 +5835,7 @@
                   </a:txBody>
                   <a:tcPr>
                     <a:solidFill>
-                      <a:srgbClr val="0D0D1A"/>
+                      <a:srgbClr val="1A1A1A"/>
                     </a:solidFill>
                   </a:tcPr>
                 </a:tc>
@@ -5835,7 +5847,7 @@
                       <a:pPr>
                         <a:defRPr sz="1100">
                           <a:solidFill>
-                            <a:srgbClr val="E8E8F0"/>
+                            <a:srgbClr val="E5E5E5"/>
                           </a:solidFill>
                         </a:defRPr>
                       </a:pPr>
@@ -5856,7 +5868,7 @@
                   </a:txBody>
                   <a:tcPr>
                     <a:solidFill>
-                      <a:srgbClr val="0D0D1A"/>
+                      <a:srgbClr val="1A1A1A"/>
                     </a:solidFill>
                   </a:tcPr>
                 </a:tc>
@@ -5868,7 +5880,7 @@
                       <a:pPr>
                         <a:defRPr sz="1100">
                           <a:solidFill>
-                            <a:srgbClr val="E8E8F0"/>
+                            <a:srgbClr val="E5E5E5"/>
                           </a:solidFill>
                         </a:defRPr>
                       </a:pPr>
@@ -5884,7 +5896,7 @@
                   </a:txBody>
                   <a:tcPr>
                     <a:solidFill>
-                      <a:srgbClr val="0D0D1A"/>
+                      <a:srgbClr val="1A1A1A"/>
                     </a:solidFill>
                   </a:tcPr>
                 </a:tc>
@@ -5898,7 +5910,7 @@
                       <a:pPr>
                         <a:defRPr sz="1100">
                           <a:solidFill>
-                            <a:srgbClr val="E8E8F0"/>
+                            <a:srgbClr val="E5E5E5"/>
                           </a:solidFill>
                         </a:defRPr>
                       </a:pPr>
@@ -5909,7 +5921,7 @@
                   </a:txBody>
                   <a:tcPr>
                     <a:solidFill>
-                      <a:srgbClr val="060610"/>
+                      <a:srgbClr val="121212"/>
                     </a:solidFill>
                   </a:tcPr>
                 </a:tc>
@@ -5921,7 +5933,7 @@
                       <a:pPr>
                         <a:defRPr sz="1100">
                           <a:solidFill>
-                            <a:srgbClr val="E8E8F0"/>
+                            <a:srgbClr val="E5E5E5"/>
                           </a:solidFill>
                         </a:defRPr>
                       </a:pPr>
@@ -5942,7 +5954,7 @@
                   </a:txBody>
                   <a:tcPr>
                     <a:solidFill>
-                      <a:srgbClr val="060610"/>
+                      <a:srgbClr val="121212"/>
                     </a:solidFill>
                   </a:tcPr>
                 </a:tc>
@@ -5954,7 +5966,7 @@
                       <a:pPr>
                         <a:defRPr sz="1100">
                           <a:solidFill>
-                            <a:srgbClr val="E8E8F0"/>
+                            <a:srgbClr val="E5E5E5"/>
                           </a:solidFill>
                         </a:defRPr>
                       </a:pPr>
@@ -5970,7 +5982,7 @@
                   </a:txBody>
                   <a:tcPr>
                     <a:solidFill>
-                      <a:srgbClr val="060610"/>
+                      <a:srgbClr val="121212"/>
                     </a:solidFill>
                   </a:tcPr>
                 </a:tc>
@@ -5984,7 +5996,7 @@
                       <a:pPr>
                         <a:defRPr sz="1100">
                           <a:solidFill>
-                            <a:srgbClr val="E8E8F0"/>
+                            <a:srgbClr val="E5E5E5"/>
                           </a:solidFill>
                         </a:defRPr>
                       </a:pPr>
@@ -5995,7 +6007,7 @@
                   </a:txBody>
                   <a:tcPr>
                     <a:solidFill>
-                      <a:srgbClr val="0D0D1A"/>
+                      <a:srgbClr val="1A1A1A"/>
                     </a:solidFill>
                   </a:tcPr>
                 </a:tc>
@@ -6007,7 +6019,7 @@
                       <a:pPr>
                         <a:defRPr sz="1100">
                           <a:solidFill>
-                            <a:srgbClr val="E8E8F0"/>
+                            <a:srgbClr val="E5E5E5"/>
                           </a:solidFill>
                         </a:defRPr>
                       </a:pPr>
@@ -6028,7 +6040,7 @@
                   </a:txBody>
                   <a:tcPr>
                     <a:solidFill>
-                      <a:srgbClr val="0D0D1A"/>
+                      <a:srgbClr val="1A1A1A"/>
                     </a:solidFill>
                   </a:tcPr>
                 </a:tc>
@@ -6040,7 +6052,7 @@
                       <a:pPr>
                         <a:defRPr sz="1100">
                           <a:solidFill>
-                            <a:srgbClr val="E8E8F0"/>
+                            <a:srgbClr val="E5E5E5"/>
                           </a:solidFill>
                         </a:defRPr>
                       </a:pPr>
@@ -6056,7 +6068,7 @@
                   </a:txBody>
                   <a:tcPr>
                     <a:solidFill>
-                      <a:srgbClr val="0D0D1A"/>
+                      <a:srgbClr val="1A1A1A"/>
                     </a:solidFill>
                   </a:tcPr>
                 </a:tc>
@@ -6070,7 +6082,7 @@
                       <a:pPr>
                         <a:defRPr sz="1100">
                           <a:solidFill>
-                            <a:srgbClr val="E8E8F0"/>
+                            <a:srgbClr val="E5E5E5"/>
                           </a:solidFill>
                         </a:defRPr>
                       </a:pPr>
@@ -6081,7 +6093,7 @@
                   </a:txBody>
                   <a:tcPr>
                     <a:solidFill>
-                      <a:srgbClr val="060610"/>
+                      <a:srgbClr val="121212"/>
                     </a:solidFill>
                   </a:tcPr>
                 </a:tc>
@@ -6093,7 +6105,7 @@
                       <a:pPr>
                         <a:defRPr sz="1100">
                           <a:solidFill>
-                            <a:srgbClr val="E8E8F0"/>
+                            <a:srgbClr val="E5E5E5"/>
                           </a:solidFill>
                         </a:defRPr>
                       </a:pPr>
@@ -6114,7 +6126,7 @@
                   </a:txBody>
                   <a:tcPr>
                     <a:solidFill>
-                      <a:srgbClr val="060610"/>
+                      <a:srgbClr val="121212"/>
                     </a:solidFill>
                   </a:tcPr>
                 </a:tc>
@@ -6126,7 +6138,7 @@
                       <a:pPr>
                         <a:defRPr sz="1100">
                           <a:solidFill>
-                            <a:srgbClr val="E8E8F0"/>
+                            <a:srgbClr val="E5E5E5"/>
                           </a:solidFill>
                         </a:defRPr>
                       </a:pPr>
@@ -6142,7 +6154,7 @@
                   </a:txBody>
                   <a:tcPr>
                     <a:solidFill>
-                      <a:srgbClr val="060610"/>
+                      <a:srgbClr val="121212"/>
                     </a:solidFill>
                   </a:tcPr>
                 </a:tc>
@@ -6184,7 +6196,7 @@
             <a:avLst/>
           </a:prstGeom>
           <a:solidFill>
-            <a:srgbClr val="060610"/>
+            <a:srgbClr val="121212"/>
           </a:solidFill>
           <a:ln>
             <a:noFill/>
@@ -6227,11 +6239,11 @@
             <a:avLst/>
           </a:prstGeom>
           <a:solidFill>
-            <a:srgbClr val="060610"/>
+            <a:srgbClr val="121212"/>
           </a:solidFill>
           <a:ln w="19050">
             <a:solidFill>
-              <a:srgbClr val="00FF88"/>
+              <a:srgbClr val="FF6E00"/>
             </a:solidFill>
           </a:ln>
         </p:spPr>
@@ -6272,7 +6284,7 @@
             <a:avLst/>
           </a:prstGeom>
           <a:solidFill>
-            <a:srgbClr val="00FF88"/>
+            <a:srgbClr val="FF6E00"/>
           </a:solidFill>
           <a:ln>
             <a:noFill/>
@@ -6299,12 +6311,12 @@
             <a:pPr algn="ctr">
               <a:defRPr b="1" sz="2200">
                 <a:solidFill>
-                  <a:srgbClr val="060610"/>
-                </a:solidFill>
-              </a:defRPr>
-            </a:pPr>
-            <a:r>
-              <a:t>Cø</a:t>
+                  <a:srgbClr val="121212"/>
+                </a:solidFill>
+              </a:defRPr>
+            </a:pPr>
+            <a:r>
+              <a:t>CØ</a:t>
             </a:r>
           </a:p>
         </p:txBody>
@@ -6334,12 +6346,12 @@
             <a:pPr>
               <a:defRPr b="1" sz="1400">
                 <a:solidFill>
-                  <a:srgbClr val="00FF88"/>
-                </a:solidFill>
-              </a:defRPr>
-            </a:pPr>
-            <a:r>
-              <a:t>CoalOmIT</a:t>
+                  <a:srgbClr val="FF6E00"/>
+                </a:solidFill>
+              </a:defRPr>
+            </a:pPr>
+            <a:r>
+              <a:t>CoalØmit</a:t>
             </a:r>
           </a:p>
           <a:p>
@@ -6371,7 +6383,7 @@
             <a:avLst/>
           </a:prstGeom>
           <a:solidFill>
-            <a:srgbClr val="060610"/>
+            <a:srgbClr val="121212"/>
           </a:solidFill>
           <a:ln>
             <a:noFill/>
@@ -6398,12 +6410,12 @@
             <a:pPr algn="r">
               <a:defRPr sz="1000">
                 <a:solidFill>
-                  <a:srgbClr val="8C91A0"/>
-                </a:solidFill>
-              </a:defRPr>
-            </a:pPr>
-            <a:r>
-              <a:t>CoalOmIT — Green AI Platform  |  Confidential Pitch Deck</a:t>
+                  <a:srgbClr val="D97706"/>
+                </a:solidFill>
+              </a:defRPr>
+            </a:pPr>
+            <a:r>
+              <a:t>CoalØmit — REDUCE NOW SUSTAIN FOREVER  |  REDUCE NOW SUSTAIN FOREVER</a:t>
             </a:r>
           </a:p>
         </p:txBody>
@@ -6423,11 +6435,11 @@
             <a:avLst/>
           </a:prstGeom>
           <a:solidFill>
-            <a:srgbClr val="0D0D1A"/>
+            <a:srgbClr val="1A1A1A"/>
           </a:solidFill>
           <a:ln w="12700">
             <a:solidFill>
-              <a:srgbClr val="00D4FF"/>
+              <a:srgbClr val="FF6E00"/>
             </a:solidFill>
           </a:ln>
         </p:spPr>
@@ -6452,7 +6464,7 @@
             <a:pPr algn="ctr">
               <a:defRPr sz="1400">
                 <a:solidFill>
-                  <a:srgbClr val="8C91A0"/>
+                  <a:srgbClr val="A0A0A0"/>
                 </a:solidFill>
               </a:defRPr>
             </a:pPr>
@@ -6499,7 +6511,7 @@
             <a:pPr>
               <a:defRPr b="1" sz="1300">
                 <a:solidFill>
-                  <a:srgbClr val="00FF88"/>
+                  <a:srgbClr val="FF6E00"/>
                 </a:solidFill>
               </a:defRPr>
             </a:pPr>
@@ -6511,7 +6523,7 @@
             <a:pPr>
               <a:defRPr sz="1200">
                 <a:solidFill>
-                  <a:srgbClr val="E8E8F0"/>
+                  <a:srgbClr val="E5E5E5"/>
                 </a:solidFill>
               </a:defRPr>
             </a:pPr>
@@ -6540,11 +6552,11 @@
             <a:avLst/>
           </a:prstGeom>
           <a:solidFill>
-            <a:srgbClr val="0D0D1A"/>
+            <a:srgbClr val="1A1A1A"/>
           </a:solidFill>
           <a:ln w="12700">
             <a:solidFill>
-              <a:srgbClr val="00D4FF"/>
+              <a:srgbClr val="FF6E00"/>
             </a:solidFill>
           </a:ln>
         </p:spPr>
@@ -6569,7 +6581,7 @@
             <a:pPr algn="ctr">
               <a:defRPr sz="1400">
                 <a:solidFill>
-                  <a:srgbClr val="8C91A0"/>
+                  <a:srgbClr val="A0A0A0"/>
                 </a:solidFill>
               </a:defRPr>
             </a:pPr>
@@ -6616,7 +6628,7 @@
             <a:pPr>
               <a:defRPr b="1" sz="1300">
                 <a:solidFill>
-                  <a:srgbClr val="00FF88"/>
+                  <a:srgbClr val="FF6E00"/>
                 </a:solidFill>
               </a:defRPr>
             </a:pPr>
@@ -6628,7 +6640,7 @@
             <a:pPr>
               <a:defRPr sz="1200">
                 <a:solidFill>
-                  <a:srgbClr val="E8E8F0"/>
+                  <a:srgbClr val="E5E5E5"/>
                 </a:solidFill>
               </a:defRPr>
             </a:pPr>
@@ -6675,7 +6687,7 @@
             <a:avLst/>
           </a:prstGeom>
           <a:solidFill>
-            <a:srgbClr val="060610"/>
+            <a:srgbClr val="121212"/>
           </a:solidFill>
           <a:ln>
             <a:noFill/>
@@ -6718,11 +6730,11 @@
             <a:avLst/>
           </a:prstGeom>
           <a:solidFill>
-            <a:srgbClr val="060610"/>
+            <a:srgbClr val="121212"/>
           </a:solidFill>
           <a:ln w="19050">
             <a:solidFill>
-              <a:srgbClr val="00FF88"/>
+              <a:srgbClr val="FF6E00"/>
             </a:solidFill>
           </a:ln>
         </p:spPr>
@@ -6763,7 +6775,7 @@
             <a:avLst/>
           </a:prstGeom>
           <a:solidFill>
-            <a:srgbClr val="00FF88"/>
+            <a:srgbClr val="FF6E00"/>
           </a:solidFill>
           <a:ln>
             <a:noFill/>
@@ -6790,12 +6802,12 @@
             <a:pPr algn="ctr">
               <a:defRPr b="1" sz="2200">
                 <a:solidFill>
-                  <a:srgbClr val="060610"/>
-                </a:solidFill>
-              </a:defRPr>
-            </a:pPr>
-            <a:r>
-              <a:t>Cø</a:t>
+                  <a:srgbClr val="121212"/>
+                </a:solidFill>
+              </a:defRPr>
+            </a:pPr>
+            <a:r>
+              <a:t>CØ</a:t>
             </a:r>
           </a:p>
         </p:txBody>
@@ -6825,12 +6837,12 @@
             <a:pPr>
               <a:defRPr b="1" sz="1400">
                 <a:solidFill>
-                  <a:srgbClr val="00FF88"/>
-                </a:solidFill>
-              </a:defRPr>
-            </a:pPr>
-            <a:r>
-              <a:t>CoalOmIT</a:t>
+                  <a:srgbClr val="FF6E00"/>
+                </a:solidFill>
+              </a:defRPr>
+            </a:pPr>
+            <a:r>
+              <a:t>CoalØmit</a:t>
             </a:r>
           </a:p>
           <a:p>
@@ -6862,7 +6874,7 @@
             <a:avLst/>
           </a:prstGeom>
           <a:solidFill>
-            <a:srgbClr val="060610"/>
+            <a:srgbClr val="121212"/>
           </a:solidFill>
           <a:ln>
             <a:noFill/>
@@ -6889,12 +6901,12 @@
             <a:pPr algn="r">
               <a:defRPr sz="1000">
                 <a:solidFill>
-                  <a:srgbClr val="8C91A0"/>
-                </a:solidFill>
-              </a:defRPr>
-            </a:pPr>
-            <a:r>
-              <a:t>CoalOmIT — Green AI Platform  |  Confidential Pitch Deck</a:t>
+                  <a:srgbClr val="D97706"/>
+                </a:solidFill>
+              </a:defRPr>
+            </a:pPr>
+            <a:r>
+              <a:t>CoalØmit — REDUCE NOW SUSTAIN FOREVER  |  REDUCE NOW SUSTAIN FOREVER</a:t>
             </a:r>
           </a:p>
         </p:txBody>
@@ -6914,11 +6926,11 @@
             <a:avLst/>
           </a:prstGeom>
           <a:solidFill>
-            <a:srgbClr val="0D0D1A"/>
+            <a:srgbClr val="1A1A1A"/>
           </a:solidFill>
           <a:ln>
             <a:solidFill>
-              <a:srgbClr val="1E2337"/>
+              <a:srgbClr val="B45A00"/>
             </a:solidFill>
           </a:ln>
         </p:spPr>
@@ -6943,7 +6955,7 @@
             <a:pPr algn="ctr">
               <a:defRPr b="1" sz="1800">
                 <a:solidFill>
-                  <a:srgbClr val="00D4FF"/>
+                  <a:srgbClr val="FF6E00"/>
                 </a:solidFill>
               </a:defRPr>
             </a:pPr>
@@ -6955,7 +6967,7 @@
             <a:pPr>
               <a:defRPr sz="1200">
                 <a:solidFill>
-                  <a:srgbClr val="E8E8F0"/>
+                  <a:srgbClr val="E5E5E5"/>
                 </a:solidFill>
               </a:defRPr>
             </a:pPr>
@@ -6967,7 +6979,7 @@
             <a:pPr>
               <a:defRPr sz="1200">
                 <a:solidFill>
-                  <a:srgbClr val="E8E8F0"/>
+                  <a:srgbClr val="E5E5E5"/>
                 </a:solidFill>
               </a:defRPr>
             </a:pPr>
@@ -6979,7 +6991,7 @@
             <a:pPr>
               <a:defRPr sz="1200">
                 <a:solidFill>
-                  <a:srgbClr val="E8E8F0"/>
+                  <a:srgbClr val="E5E5E5"/>
                 </a:solidFill>
               </a:defRPr>
             </a:pPr>
@@ -6991,7 +7003,7 @@
             <a:pPr>
               <a:defRPr sz="1200">
                 <a:solidFill>
-                  <a:srgbClr val="E8E8F0"/>
+                  <a:srgbClr val="E5E5E5"/>
                 </a:solidFill>
               </a:defRPr>
             </a:pPr>
@@ -7003,7 +7015,7 @@
             <a:pPr>
               <a:defRPr sz="1200">
                 <a:solidFill>
-                  <a:srgbClr val="E8E8F0"/>
+                  <a:srgbClr val="E5E5E5"/>
                 </a:solidFill>
               </a:defRPr>
             </a:pPr>
@@ -7028,11 +7040,11 @@
             <a:avLst/>
           </a:prstGeom>
           <a:solidFill>
-            <a:srgbClr val="0D0D1A"/>
+            <a:srgbClr val="1A1A1A"/>
           </a:solidFill>
           <a:ln>
             <a:solidFill>
-              <a:srgbClr val="1E2337"/>
+              <a:srgbClr val="B45A00"/>
             </a:solidFill>
           </a:ln>
         </p:spPr>
@@ -7057,7 +7069,7 @@
             <a:pPr algn="ctr">
               <a:defRPr b="1" sz="1800">
                 <a:solidFill>
-                  <a:srgbClr val="00D4FF"/>
+                  <a:srgbClr val="D97706"/>
                 </a:solidFill>
               </a:defRPr>
             </a:pPr>
@@ -7069,7 +7081,7 @@
             <a:pPr>
               <a:defRPr sz="1200">
                 <a:solidFill>
-                  <a:srgbClr val="E8E8F0"/>
+                  <a:srgbClr val="E5E5E5"/>
                 </a:solidFill>
               </a:defRPr>
             </a:pPr>
@@ -7081,7 +7093,7 @@
             <a:pPr>
               <a:defRPr sz="1200">
                 <a:solidFill>
-                  <a:srgbClr val="E8E8F0"/>
+                  <a:srgbClr val="E5E5E5"/>
                 </a:solidFill>
               </a:defRPr>
             </a:pPr>
@@ -7093,7 +7105,7 @@
             <a:pPr>
               <a:defRPr sz="1200">
                 <a:solidFill>
-                  <a:srgbClr val="E8E8F0"/>
+                  <a:srgbClr val="E5E5E5"/>
                 </a:solidFill>
               </a:defRPr>
             </a:pPr>
@@ -7105,7 +7117,7 @@
             <a:pPr>
               <a:defRPr sz="1200">
                 <a:solidFill>
-                  <a:srgbClr val="E8E8F0"/>
+                  <a:srgbClr val="E5E5E5"/>
                 </a:solidFill>
               </a:defRPr>
             </a:pPr>
@@ -7117,7 +7129,7 @@
             <a:pPr>
               <a:defRPr sz="1200">
                 <a:solidFill>
-                  <a:srgbClr val="E8E8F0"/>
+                  <a:srgbClr val="E5E5E5"/>
                 </a:solidFill>
               </a:defRPr>
             </a:pPr>
@@ -7195,7 +7207,7 @@
             <a:avLst/>
           </a:prstGeom>
           <a:solidFill>
-            <a:srgbClr val="060610"/>
+            <a:srgbClr val="121212"/>
           </a:solidFill>
           <a:ln>
             <a:noFill/>
@@ -7238,11 +7250,11 @@
             <a:avLst/>
           </a:prstGeom>
           <a:solidFill>
-            <a:srgbClr val="060610"/>
+            <a:srgbClr val="121212"/>
           </a:solidFill>
           <a:ln w="19050">
             <a:solidFill>
-              <a:srgbClr val="00FF88"/>
+              <a:srgbClr val="FF6E00"/>
             </a:solidFill>
           </a:ln>
         </p:spPr>
@@ -7283,7 +7295,7 @@
             <a:avLst/>
           </a:prstGeom>
           <a:solidFill>
-            <a:srgbClr val="00FF88"/>
+            <a:srgbClr val="FF6E00"/>
           </a:solidFill>
           <a:ln>
             <a:noFill/>
@@ -7310,12 +7322,12 @@
             <a:pPr algn="ctr">
               <a:defRPr b="1" sz="2200">
                 <a:solidFill>
-                  <a:srgbClr val="060610"/>
-                </a:solidFill>
-              </a:defRPr>
-            </a:pPr>
-            <a:r>
-              <a:t>Cø</a:t>
+                  <a:srgbClr val="121212"/>
+                </a:solidFill>
+              </a:defRPr>
+            </a:pPr>
+            <a:r>
+              <a:t>CØ</a:t>
             </a:r>
           </a:p>
         </p:txBody>
@@ -7345,12 +7357,12 @@
             <a:pPr>
               <a:defRPr b="1" sz="1400">
                 <a:solidFill>
-                  <a:srgbClr val="00FF88"/>
-                </a:solidFill>
-              </a:defRPr>
-            </a:pPr>
-            <a:r>
-              <a:t>CoalOmIT</a:t>
+                  <a:srgbClr val="FF6E00"/>
+                </a:solidFill>
+              </a:defRPr>
+            </a:pPr>
+            <a:r>
+              <a:t>CoalØmit</a:t>
             </a:r>
           </a:p>
           <a:p>
@@ -7382,7 +7394,7 @@
             <a:avLst/>
           </a:prstGeom>
           <a:solidFill>
-            <a:srgbClr val="060610"/>
+            <a:srgbClr val="121212"/>
           </a:solidFill>
           <a:ln>
             <a:noFill/>
@@ -7409,12 +7421,12 @@
             <a:pPr algn="r">
               <a:defRPr sz="1000">
                 <a:solidFill>
-                  <a:srgbClr val="8C91A0"/>
-                </a:solidFill>
-              </a:defRPr>
-            </a:pPr>
-            <a:r>
-              <a:t>CoalOmIT — Green AI Platform  |  Confidential Pitch Deck</a:t>
+                  <a:srgbClr val="D97706"/>
+                </a:solidFill>
+              </a:defRPr>
+            </a:pPr>
+            <a:r>
+              <a:t>CoalØmit — REDUCE NOW SUSTAIN FOREVER  |  REDUCE NOW SUSTAIN FOREVER</a:t>
             </a:r>
           </a:p>
         </p:txBody>
@@ -7444,7 +7456,7 @@
             <a:pPr>
               <a:defRPr b="1" sz="1400">
                 <a:solidFill>
-                  <a:srgbClr val="00FF88"/>
+                  <a:srgbClr val="FF6E00"/>
                 </a:solidFill>
               </a:defRPr>
             </a:pPr>
@@ -7456,7 +7468,7 @@
             <a:pPr>
               <a:defRPr sz="1100">
                 <a:solidFill>
-                  <a:srgbClr val="E8E8F0"/>
+                  <a:srgbClr val="E5E5E5"/>
                 </a:solidFill>
               </a:defRPr>
             </a:pPr>
@@ -7469,7 +7481,7 @@
             <a:pPr>
               <a:defRPr b="1" sz="1400">
                 <a:solidFill>
-                  <a:srgbClr val="00FF88"/>
+                  <a:srgbClr val="FF6E00"/>
                 </a:solidFill>
               </a:defRPr>
             </a:pPr>
@@ -7481,7 +7493,7 @@
             <a:pPr>
               <a:defRPr sz="1100">
                 <a:solidFill>
-                  <a:srgbClr val="E8E8F0"/>
+                  <a:srgbClr val="E5E5E5"/>
                 </a:solidFill>
               </a:defRPr>
             </a:pPr>
@@ -7494,7 +7506,7 @@
             <a:pPr>
               <a:defRPr b="1" sz="1400">
                 <a:solidFill>
-                  <a:srgbClr val="00FF88"/>
+                  <a:srgbClr val="FF6E00"/>
                 </a:solidFill>
               </a:defRPr>
             </a:pPr>
@@ -7506,7 +7518,7 @@
             <a:pPr>
               <a:defRPr sz="1100">
                 <a:solidFill>
-                  <a:srgbClr val="E8E8F0"/>
+                  <a:srgbClr val="E5E5E5"/>
                 </a:solidFill>
               </a:defRPr>
             </a:pPr>
@@ -7519,7 +7531,7 @@
             <a:pPr>
               <a:defRPr b="1" sz="1400">
                 <a:solidFill>
-                  <a:srgbClr val="00FF88"/>
+                  <a:srgbClr val="FF6E00"/>
                 </a:solidFill>
               </a:defRPr>
             </a:pPr>
@@ -7531,7 +7543,7 @@
             <a:pPr>
               <a:defRPr sz="1100">
                 <a:solidFill>
-                  <a:srgbClr val="E8E8F0"/>
+                  <a:srgbClr val="E5E5E5"/>
                 </a:solidFill>
               </a:defRPr>
             </a:pPr>
@@ -7557,11 +7569,11 @@
             <a:avLst/>
           </a:prstGeom>
           <a:solidFill>
-            <a:srgbClr val="0D0D1A"/>
+            <a:srgbClr val="1A1A1A"/>
           </a:solidFill>
           <a:ln w="19050">
             <a:solidFill>
-              <a:srgbClr val="00D4FF"/>
+              <a:srgbClr val="D97706"/>
             </a:solidFill>
           </a:ln>
         </p:spPr>
@@ -7586,7 +7598,7 @@
             <a:pPr algn="ctr">
               <a:defRPr b="1" sz="2200">
                 <a:solidFill>
-                  <a:srgbClr val="00D4FF"/>
+                  <a:srgbClr val="FF6E00"/>
                 </a:solidFill>
               </a:defRPr>
             </a:pPr>
@@ -7598,7 +7610,7 @@
             <a:pPr>
               <a:defRPr sz="1100">
                 <a:solidFill>
-                  <a:srgbClr val="E8E8F0"/>
+                  <a:srgbClr val="E5E5E5"/>
                 </a:solidFill>
               </a:defRPr>
             </a:pPr>
@@ -7610,7 +7622,7 @@
             <a:pPr>
               <a:defRPr sz="1100">
                 <a:solidFill>
-                  <a:srgbClr val="E8E8F0"/>
+                  <a:srgbClr val="E5E5E5"/>
                 </a:solidFill>
               </a:defRPr>
             </a:pPr>
@@ -7622,7 +7634,7 @@
             <a:pPr>
               <a:defRPr sz="1100">
                 <a:solidFill>
-                  <a:srgbClr val="E8E8F0"/>
+                  <a:srgbClr val="E5E5E5"/>
                 </a:solidFill>
               </a:defRPr>
             </a:pPr>
@@ -7634,7 +7646,7 @@
             <a:pPr>
               <a:defRPr sz="1100">
                 <a:solidFill>
-                  <a:srgbClr val="E8E8F0"/>
+                  <a:srgbClr val="E5E5E5"/>
                 </a:solidFill>
               </a:defRPr>
             </a:pPr>
@@ -7712,7 +7724,7 @@
             <a:avLst/>
           </a:prstGeom>
           <a:solidFill>
-            <a:srgbClr val="060610"/>
+            <a:srgbClr val="121212"/>
           </a:solidFill>
           <a:ln>
             <a:noFill/>
@@ -7755,11 +7767,11 @@
             <a:avLst/>
           </a:prstGeom>
           <a:solidFill>
-            <a:srgbClr val="060610"/>
+            <a:srgbClr val="121212"/>
           </a:solidFill>
           <a:ln w="19050">
             <a:solidFill>
-              <a:srgbClr val="00FF88"/>
+              <a:srgbClr val="FF6E00"/>
             </a:solidFill>
           </a:ln>
         </p:spPr>
@@ -7800,7 +7812,7 @@
             <a:avLst/>
           </a:prstGeom>
           <a:solidFill>
-            <a:srgbClr val="00FF88"/>
+            <a:srgbClr val="FF6E00"/>
           </a:solidFill>
           <a:ln>
             <a:noFill/>
@@ -7827,12 +7839,12 @@
             <a:pPr algn="ctr">
               <a:defRPr b="1" sz="2200">
                 <a:solidFill>
-                  <a:srgbClr val="060610"/>
-                </a:solidFill>
-              </a:defRPr>
-            </a:pPr>
-            <a:r>
-              <a:t>Cø</a:t>
+                  <a:srgbClr val="121212"/>
+                </a:solidFill>
+              </a:defRPr>
+            </a:pPr>
+            <a:r>
+              <a:t>CØ</a:t>
             </a:r>
           </a:p>
         </p:txBody>
@@ -7862,12 +7874,12 @@
             <a:pPr>
               <a:defRPr b="1" sz="1400">
                 <a:solidFill>
-                  <a:srgbClr val="00FF88"/>
-                </a:solidFill>
-              </a:defRPr>
-            </a:pPr>
-            <a:r>
-              <a:t>CoalOmIT</a:t>
+                  <a:srgbClr val="FF6E00"/>
+                </a:solidFill>
+              </a:defRPr>
+            </a:pPr>
+            <a:r>
+              <a:t>CoalØmit</a:t>
             </a:r>
           </a:p>
           <a:p>
@@ -7899,7 +7911,7 @@
             <a:avLst/>
           </a:prstGeom>
           <a:solidFill>
-            <a:srgbClr val="060610"/>
+            <a:srgbClr val="121212"/>
           </a:solidFill>
           <a:ln>
             <a:noFill/>
@@ -7926,12 +7938,12 @@
             <a:pPr algn="r">
               <a:defRPr sz="1000">
                 <a:solidFill>
-                  <a:srgbClr val="8C91A0"/>
-                </a:solidFill>
-              </a:defRPr>
-            </a:pPr>
-            <a:r>
-              <a:t>CoalOmIT — Green AI Platform  |  Confidential Pitch Deck</a:t>
+                  <a:srgbClr val="D97706"/>
+                </a:solidFill>
+              </a:defRPr>
+            </a:pPr>
+            <a:r>
+              <a:t>CoalØmit — REDUCE NOW SUSTAIN FOREVER  |  REDUCE NOW SUSTAIN FOREVER</a:t>
             </a:r>
           </a:p>
         </p:txBody>
@@ -7961,7 +7973,7 @@
             <a:pPr>
               <a:defRPr b="1" sz="1500">
                 <a:solidFill>
-                  <a:srgbClr val="00FF88"/>
+                  <a:srgbClr val="FF6E00"/>
                 </a:solidFill>
               </a:defRPr>
             </a:pPr>
@@ -7973,7 +7985,7 @@
             <a:pPr>
               <a:defRPr sz="1200">
                 <a:solidFill>
-                  <a:srgbClr val="E8E8F0"/>
+                  <a:srgbClr val="E5E5E5"/>
                 </a:solidFill>
               </a:defRPr>
             </a:pPr>
@@ -7986,7 +7998,7 @@
             <a:pPr>
               <a:defRPr b="1" sz="1500">
                 <a:solidFill>
-                  <a:srgbClr val="00FF88"/>
+                  <a:srgbClr val="FF6E00"/>
                 </a:solidFill>
               </a:defRPr>
             </a:pPr>
@@ -7998,7 +8010,7 @@
             <a:pPr>
               <a:defRPr sz="1200">
                 <a:solidFill>
-                  <a:srgbClr val="E8E8F0"/>
+                  <a:srgbClr val="E5E5E5"/>
                 </a:solidFill>
               </a:defRPr>
             </a:pPr>
@@ -8011,7 +8023,7 @@
             <a:pPr>
               <a:defRPr b="1" sz="1500">
                 <a:solidFill>
-                  <a:srgbClr val="00FF88"/>
+                  <a:srgbClr val="FF6E00"/>
                 </a:solidFill>
               </a:defRPr>
             </a:pPr>
@@ -8023,7 +8035,7 @@
             <a:pPr>
               <a:defRPr sz="1200">
                 <a:solidFill>
-                  <a:srgbClr val="E8E8F0"/>
+                  <a:srgbClr val="E5E5E5"/>
                 </a:solidFill>
               </a:defRPr>
             </a:pPr>
@@ -8036,7 +8048,7 @@
             <a:pPr>
               <a:defRPr b="1" sz="1500">
                 <a:solidFill>
-                  <a:srgbClr val="00FF88"/>
+                  <a:srgbClr val="FF6E00"/>
                 </a:solidFill>
               </a:defRPr>
             </a:pPr>
@@ -8048,7 +8060,7 @@
             <a:pPr>
               <a:defRPr sz="1200">
                 <a:solidFill>
-                  <a:srgbClr val="E8E8F0"/>
+                  <a:srgbClr val="E5E5E5"/>
                 </a:solidFill>
               </a:defRPr>
             </a:pPr>
@@ -8061,7 +8073,7 @@
             <a:pPr>
               <a:defRPr b="1" sz="1500">
                 <a:solidFill>
-                  <a:srgbClr val="00FF88"/>
+                  <a:srgbClr val="FF6E00"/>
                 </a:solidFill>
               </a:defRPr>
             </a:pPr>
@@ -8073,7 +8085,7 @@
             <a:pPr>
               <a:defRPr sz="1200">
                 <a:solidFill>
-                  <a:srgbClr val="E8E8F0"/>
+                  <a:srgbClr val="E5E5E5"/>
                 </a:solidFill>
               </a:defRPr>
             </a:pPr>
@@ -8117,7 +8129,7 @@
             <a:avLst/>
           </a:prstGeom>
           <a:solidFill>
-            <a:srgbClr val="060610"/>
+            <a:srgbClr val="121212"/>
           </a:solidFill>
           <a:ln>
             <a:noFill/>
@@ -8160,11 +8172,11 @@
             <a:avLst/>
           </a:prstGeom>
           <a:solidFill>
-            <a:srgbClr val="060610"/>
+            <a:srgbClr val="121212"/>
           </a:solidFill>
           <a:ln w="19050">
             <a:solidFill>
-              <a:srgbClr val="00FF88"/>
+              <a:srgbClr val="FF6E00"/>
             </a:solidFill>
           </a:ln>
         </p:spPr>
@@ -8205,7 +8217,7 @@
             <a:avLst/>
           </a:prstGeom>
           <a:solidFill>
-            <a:srgbClr val="00FF88"/>
+            <a:srgbClr val="FF6E00"/>
           </a:solidFill>
           <a:ln>
             <a:noFill/>
@@ -8232,12 +8244,12 @@
             <a:pPr algn="ctr">
               <a:defRPr b="1" sz="2200">
                 <a:solidFill>
-                  <a:srgbClr val="060610"/>
-                </a:solidFill>
-              </a:defRPr>
-            </a:pPr>
-            <a:r>
-              <a:t>Cø</a:t>
+                  <a:srgbClr val="121212"/>
+                </a:solidFill>
+              </a:defRPr>
+            </a:pPr>
+            <a:r>
+              <a:t>CØ</a:t>
             </a:r>
           </a:p>
         </p:txBody>
@@ -8267,12 +8279,12 @@
             <a:pPr>
               <a:defRPr b="1" sz="1400">
                 <a:solidFill>
-                  <a:srgbClr val="00FF88"/>
-                </a:solidFill>
-              </a:defRPr>
-            </a:pPr>
-            <a:r>
-              <a:t>CoalOmIT</a:t>
+                  <a:srgbClr val="FF6E00"/>
+                </a:solidFill>
+              </a:defRPr>
+            </a:pPr>
+            <a:r>
+              <a:t>CoalØmit</a:t>
             </a:r>
           </a:p>
           <a:p>
@@ -8304,7 +8316,7 @@
             <a:avLst/>
           </a:prstGeom>
           <a:solidFill>
-            <a:srgbClr val="060610"/>
+            <a:srgbClr val="121212"/>
           </a:solidFill>
           <a:ln>
             <a:noFill/>
@@ -8331,12 +8343,12 @@
             <a:pPr algn="r">
               <a:defRPr sz="1000">
                 <a:solidFill>
-                  <a:srgbClr val="8C91A0"/>
-                </a:solidFill>
-              </a:defRPr>
-            </a:pPr>
-            <a:r>
-              <a:t>CoalOmIT — Green AI Platform  |  Confidential Pitch Deck</a:t>
+                  <a:srgbClr val="D97706"/>
+                </a:solidFill>
+              </a:defRPr>
+            </a:pPr>
+            <a:r>
+              <a:t>CoalØmit — REDUCE NOW SUSTAIN FOREVER  |  REDUCE NOW SUSTAIN FOREVER</a:t>
             </a:r>
           </a:p>
         </p:txBody>
@@ -8374,7 +8386,7 @@
                       <a:pPr algn="ctr">
                         <a:defRPr b="1" sz="1300">
                           <a:solidFill>
-                            <a:srgbClr val="00FF88"/>
+                            <a:srgbClr val="FF6E00"/>
                           </a:solidFill>
                         </a:defRPr>
                       </a:pPr>
@@ -8385,7 +8397,7 @@
                   </a:txBody>
                   <a:tcPr>
                     <a:solidFill>
-                      <a:srgbClr val="141428"/>
+                      <a:srgbClr val="222222"/>
                     </a:solidFill>
                   </a:tcPr>
                 </a:tc>
@@ -8397,7 +8409,7 @@
                       <a:pPr algn="ctr">
                         <a:defRPr b="1" sz="1300">
                           <a:solidFill>
-                            <a:srgbClr val="00FF88"/>
+                            <a:srgbClr val="FF6E00"/>
                           </a:solidFill>
                         </a:defRPr>
                       </a:pPr>
@@ -8408,7 +8420,7 @@
                   </a:txBody>
                   <a:tcPr>
                     <a:solidFill>
-                      <a:srgbClr val="141428"/>
+                      <a:srgbClr val="222222"/>
                     </a:solidFill>
                   </a:tcPr>
                 </a:tc>
@@ -8420,18 +8432,18 @@
                       <a:pPr algn="ctr">
                         <a:defRPr b="1" sz="1300">
                           <a:solidFill>
-                            <a:srgbClr val="00FF88"/>
+                            <a:srgbClr val="FF6E00"/>
                           </a:solidFill>
                         </a:defRPr>
                       </a:pPr>
                       <a:r>
-                        <a:t>CoalOmIT (INT8 / INT4)</a:t>
+                        <a:t>CoalØmit (INT8 / INT4)</a:t>
                       </a:r>
                     </a:p>
                   </a:txBody>
                   <a:tcPr>
                     <a:solidFill>
-                      <a:srgbClr val="141428"/>
+                      <a:srgbClr val="222222"/>
                     </a:solidFill>
                   </a:tcPr>
                 </a:tc>
@@ -8443,7 +8455,7 @@
                       <a:pPr algn="ctr">
                         <a:defRPr b="1" sz="1300">
                           <a:solidFill>
-                            <a:srgbClr val="00FF88"/>
+                            <a:srgbClr val="FF6E00"/>
                           </a:solidFill>
                         </a:defRPr>
                       </a:pPr>
@@ -8454,7 +8466,7 @@
                   </a:txBody>
                   <a:tcPr>
                     <a:solidFill>
-                      <a:srgbClr val="141428"/>
+                      <a:srgbClr val="222222"/>
                     </a:solidFill>
                   </a:tcPr>
                 </a:tc>
@@ -8468,7 +8480,7 @@
                       <a:pPr>
                         <a:defRPr sz="1200">
                           <a:solidFill>
-                            <a:srgbClr val="E8E8F0"/>
+                            <a:srgbClr val="E5E5E5"/>
                           </a:solidFill>
                         </a:defRPr>
                       </a:pPr>
@@ -8479,7 +8491,7 @@
                   </a:txBody>
                   <a:tcPr>
                     <a:solidFill>
-                      <a:srgbClr val="0D0D1A"/>
+                      <a:srgbClr val="1A1A1A"/>
                     </a:solidFill>
                   </a:tcPr>
                 </a:tc>
@@ -8491,7 +8503,7 @@
                       <a:pPr algn="ctr">
                         <a:defRPr sz="1200">
                           <a:solidFill>
-                            <a:srgbClr val="E8E8F0"/>
+                            <a:srgbClr val="E5E5E5"/>
                           </a:solidFill>
                         </a:defRPr>
                       </a:pPr>
@@ -8502,7 +8514,7 @@
                   </a:txBody>
                   <a:tcPr>
                     <a:solidFill>
-                      <a:srgbClr val="0D0D1A"/>
+                      <a:srgbClr val="1A1A1A"/>
                     </a:solidFill>
                   </a:tcPr>
                 </a:tc>
@@ -8514,7 +8526,7 @@
                       <a:pPr algn="ctr">
                         <a:defRPr sz="1200">
                           <a:solidFill>
-                            <a:srgbClr val="FFFFFF"/>
+                            <a:srgbClr val="FF6E00"/>
                           </a:solidFill>
                         </a:defRPr>
                       </a:pPr>
@@ -8525,7 +8537,7 @@
                   </a:txBody>
                   <a:tcPr>
                     <a:solidFill>
-                      <a:srgbClr val="0D0D1A"/>
+                      <a:srgbClr val="1A1A1A"/>
                     </a:solidFill>
                   </a:tcPr>
                 </a:tc>
@@ -8537,7 +8549,7 @@
                       <a:pPr>
                         <a:defRPr sz="1200">
                           <a:solidFill>
-                            <a:srgbClr val="E8E8F0"/>
+                            <a:srgbClr val="E5E5E5"/>
                           </a:solidFill>
                         </a:defRPr>
                       </a:pPr>
@@ -8548,7 +8560,7 @@
                   </a:txBody>
                   <a:tcPr>
                     <a:solidFill>
-                      <a:srgbClr val="0D0D1A"/>
+                      <a:srgbClr val="1A1A1A"/>
                     </a:solidFill>
                   </a:tcPr>
                 </a:tc>
@@ -8562,7 +8574,7 @@
                       <a:pPr>
                         <a:defRPr sz="1200">
                           <a:solidFill>
-                            <a:srgbClr val="E8E8F0"/>
+                            <a:srgbClr val="E5E5E5"/>
                           </a:solidFill>
                         </a:defRPr>
                       </a:pPr>
@@ -8573,7 +8585,7 @@
                   </a:txBody>
                   <a:tcPr>
                     <a:solidFill>
-                      <a:srgbClr val="060610"/>
+                      <a:srgbClr val="121212"/>
                     </a:solidFill>
                   </a:tcPr>
                 </a:tc>
@@ -8585,7 +8597,7 @@
                       <a:pPr algn="ctr">
                         <a:defRPr sz="1200">
                           <a:solidFill>
-                            <a:srgbClr val="E8E8F0"/>
+                            <a:srgbClr val="E5E5E5"/>
                           </a:solidFill>
                         </a:defRPr>
                       </a:pPr>
@@ -8596,7 +8608,7 @@
                   </a:txBody>
                   <a:tcPr>
                     <a:solidFill>
-                      <a:srgbClr val="060610"/>
+                      <a:srgbClr val="121212"/>
                     </a:solidFill>
                   </a:tcPr>
                 </a:tc>
@@ -8608,7 +8620,7 @@
                       <a:pPr algn="ctr">
                         <a:defRPr sz="1200">
                           <a:solidFill>
-                            <a:srgbClr val="FFFFFF"/>
+                            <a:srgbClr val="FF6E00"/>
                           </a:solidFill>
                         </a:defRPr>
                       </a:pPr>
@@ -8619,7 +8631,7 @@
                   </a:txBody>
                   <a:tcPr>
                     <a:solidFill>
-                      <a:srgbClr val="060610"/>
+                      <a:srgbClr val="121212"/>
                     </a:solidFill>
                   </a:tcPr>
                 </a:tc>
@@ -8631,7 +8643,7 @@
                       <a:pPr>
                         <a:defRPr sz="1200">
                           <a:solidFill>
-                            <a:srgbClr val="E8E8F0"/>
+                            <a:srgbClr val="E5E5E5"/>
                           </a:solidFill>
                         </a:defRPr>
                       </a:pPr>
@@ -8642,7 +8654,7 @@
                   </a:txBody>
                   <a:tcPr>
                     <a:solidFill>
-                      <a:srgbClr val="060610"/>
+                      <a:srgbClr val="121212"/>
                     </a:solidFill>
                   </a:tcPr>
                 </a:tc>
@@ -8656,7 +8668,7 @@
                       <a:pPr>
                         <a:defRPr sz="1200">
                           <a:solidFill>
-                            <a:srgbClr val="E8E8F0"/>
+                            <a:srgbClr val="E5E5E5"/>
                           </a:solidFill>
                         </a:defRPr>
                       </a:pPr>
@@ -8667,7 +8679,7 @@
                   </a:txBody>
                   <a:tcPr>
                     <a:solidFill>
-                      <a:srgbClr val="0D0D1A"/>
+                      <a:srgbClr val="1A1A1A"/>
                     </a:solidFill>
                   </a:tcPr>
                 </a:tc>
@@ -8679,7 +8691,7 @@
                       <a:pPr algn="ctr">
                         <a:defRPr sz="1200">
                           <a:solidFill>
-                            <a:srgbClr val="E8E8F0"/>
+                            <a:srgbClr val="E5E5E5"/>
                           </a:solidFill>
                         </a:defRPr>
                       </a:pPr>
@@ -8690,7 +8702,7 @@
                   </a:txBody>
                   <a:tcPr>
                     <a:solidFill>
-                      <a:srgbClr val="0D0D1A"/>
+                      <a:srgbClr val="1A1A1A"/>
                     </a:solidFill>
                   </a:tcPr>
                 </a:tc>
@@ -8702,7 +8714,7 @@
                       <a:pPr algn="ctr">
                         <a:defRPr sz="1200">
                           <a:solidFill>
-                            <a:srgbClr val="FFFFFF"/>
+                            <a:srgbClr val="FF6E00"/>
                           </a:solidFill>
                         </a:defRPr>
                       </a:pPr>
@@ -8713,7 +8725,7 @@
                   </a:txBody>
                   <a:tcPr>
                     <a:solidFill>
-                      <a:srgbClr val="0D0D1A"/>
+                      <a:srgbClr val="1A1A1A"/>
                     </a:solidFill>
                   </a:tcPr>
                 </a:tc>
@@ -8725,7 +8737,7 @@
                       <a:pPr>
                         <a:defRPr sz="1200">
                           <a:solidFill>
-                            <a:srgbClr val="E8E8F0"/>
+                            <a:srgbClr val="E5E5E5"/>
                           </a:solidFill>
                         </a:defRPr>
                       </a:pPr>
@@ -8736,7 +8748,7 @@
                   </a:txBody>
                   <a:tcPr>
                     <a:solidFill>
-                      <a:srgbClr val="0D0D1A"/>
+                      <a:srgbClr val="1A1A1A"/>
                     </a:solidFill>
                   </a:tcPr>
                 </a:tc>
@@ -8778,7 +8790,7 @@
             <a:avLst/>
           </a:prstGeom>
           <a:solidFill>
-            <a:srgbClr val="060610"/>
+            <a:srgbClr val="121212"/>
           </a:solidFill>
           <a:ln>
             <a:noFill/>
@@ -8821,11 +8833,11 @@
             <a:avLst/>
           </a:prstGeom>
           <a:solidFill>
-            <a:srgbClr val="060610"/>
+            <a:srgbClr val="121212"/>
           </a:solidFill>
           <a:ln w="19050">
             <a:solidFill>
-              <a:srgbClr val="00FF88"/>
+              <a:srgbClr val="FF6E00"/>
             </a:solidFill>
           </a:ln>
         </p:spPr>
@@ -8866,7 +8878,7 @@
             <a:avLst/>
           </a:prstGeom>
           <a:solidFill>
-            <a:srgbClr val="00FF88"/>
+            <a:srgbClr val="FF6E00"/>
           </a:solidFill>
           <a:ln>
             <a:noFill/>
@@ -8893,12 +8905,12 @@
             <a:pPr algn="ctr">
               <a:defRPr b="1" sz="2200">
                 <a:solidFill>
-                  <a:srgbClr val="060610"/>
-                </a:solidFill>
-              </a:defRPr>
-            </a:pPr>
-            <a:r>
-              <a:t>Cø</a:t>
+                  <a:srgbClr val="121212"/>
+                </a:solidFill>
+              </a:defRPr>
+            </a:pPr>
+            <a:r>
+              <a:t>CØ</a:t>
             </a:r>
           </a:p>
         </p:txBody>
@@ -8928,12 +8940,12 @@
             <a:pPr>
               <a:defRPr b="1" sz="1400">
                 <a:solidFill>
-                  <a:srgbClr val="00FF88"/>
-                </a:solidFill>
-              </a:defRPr>
-            </a:pPr>
-            <a:r>
-              <a:t>CoalOmIT</a:t>
+                  <a:srgbClr val="FF6E00"/>
+                </a:solidFill>
+              </a:defRPr>
+            </a:pPr>
+            <a:r>
+              <a:t>CoalØmit</a:t>
             </a:r>
           </a:p>
           <a:p>
@@ -8965,7 +8977,7 @@
             <a:avLst/>
           </a:prstGeom>
           <a:solidFill>
-            <a:srgbClr val="060610"/>
+            <a:srgbClr val="121212"/>
           </a:solidFill>
           <a:ln>
             <a:noFill/>
@@ -8992,12 +9004,12 @@
             <a:pPr algn="r">
               <a:defRPr sz="1000">
                 <a:solidFill>
-                  <a:srgbClr val="8C91A0"/>
-                </a:solidFill>
-              </a:defRPr>
-            </a:pPr>
-            <a:r>
-              <a:t>CoalOmIT — Green AI Platform  |  Confidential Pitch Deck</a:t>
+                  <a:srgbClr val="D97706"/>
+                </a:solidFill>
+              </a:defRPr>
+            </a:pPr>
+            <a:r>
+              <a:t>CoalØmit — REDUCE NOW SUSTAIN FOREVER  |  REDUCE NOW SUSTAIN FOREVER</a:t>
             </a:r>
           </a:p>
         </p:txBody>
@@ -9017,11 +9029,11 @@
             <a:avLst/>
           </a:prstGeom>
           <a:solidFill>
-            <a:srgbClr val="0D0D1A"/>
+            <a:srgbClr val="1A1A1A"/>
           </a:solidFill>
           <a:ln w="25400">
             <a:solidFill>
-              <a:srgbClr val="00FF88"/>
+              <a:srgbClr val="FF6E00"/>
             </a:solidFill>
           </a:ln>
         </p:spPr>
@@ -9046,7 +9058,7 @@
             <a:pPr algn="ctr">
               <a:defRPr b="1" sz="2400">
                 <a:solidFill>
-                  <a:srgbClr val="00FF88"/>
+                  <a:srgbClr val="FF6E00"/>
                 </a:solidFill>
               </a:defRPr>
             </a:pPr>
@@ -9083,7 +9095,7 @@
             <a:pPr>
               <a:defRPr sz="1300">
                 <a:solidFill>
-                  <a:srgbClr val="E8E8F0"/>
+                  <a:srgbClr val="E5E5E5"/>
                 </a:solidFill>
               </a:defRPr>
             </a:pPr>
@@ -9116,11 +9128,11 @@
             <a:avLst/>
           </a:prstGeom>
           <a:solidFill>
-            <a:srgbClr val="0D0D1A"/>
+            <a:srgbClr val="1A1A1A"/>
           </a:solidFill>
           <a:ln w="25400">
             <a:solidFill>
-              <a:srgbClr val="00D4FF"/>
+              <a:srgbClr val="D97706"/>
             </a:solidFill>
           </a:ln>
         </p:spPr>
@@ -9145,7 +9157,7 @@
             <a:pPr algn="ctr">
               <a:defRPr b="1" sz="2400">
                 <a:solidFill>
-                  <a:srgbClr val="00D4FF"/>
+                  <a:srgbClr val="D97706"/>
                 </a:solidFill>
               </a:defRPr>
             </a:pPr>
@@ -9181,7 +9193,7 @@
             <a:pPr>
               <a:defRPr sz="1300">
                 <a:solidFill>
-                  <a:srgbClr val="E8E8F0"/>
+                  <a:srgbClr val="E5E5E5"/>
                 </a:solidFill>
               </a:defRPr>
             </a:pPr>
@@ -9232,7 +9244,7 @@
             <a:avLst/>
           </a:prstGeom>
           <a:solidFill>
-            <a:srgbClr val="060610"/>
+            <a:srgbClr val="121212"/>
           </a:solidFill>
           <a:ln>
             <a:noFill/>
@@ -9275,11 +9287,11 @@
             <a:avLst/>
           </a:prstGeom>
           <a:solidFill>
-            <a:srgbClr val="060610"/>
+            <a:srgbClr val="121212"/>
           </a:solidFill>
           <a:ln w="19050">
             <a:solidFill>
-              <a:srgbClr val="00FF88"/>
+              <a:srgbClr val="FF6E00"/>
             </a:solidFill>
           </a:ln>
         </p:spPr>
@@ -9320,7 +9332,7 @@
             <a:avLst/>
           </a:prstGeom>
           <a:solidFill>
-            <a:srgbClr val="00FF88"/>
+            <a:srgbClr val="FF6E00"/>
           </a:solidFill>
           <a:ln>
             <a:noFill/>
@@ -9347,12 +9359,12 @@
             <a:pPr algn="ctr">
               <a:defRPr b="1" sz="2200">
                 <a:solidFill>
-                  <a:srgbClr val="060610"/>
-                </a:solidFill>
-              </a:defRPr>
-            </a:pPr>
-            <a:r>
-              <a:t>Cø</a:t>
+                  <a:srgbClr val="121212"/>
+                </a:solidFill>
+              </a:defRPr>
+            </a:pPr>
+            <a:r>
+              <a:t>CØ</a:t>
             </a:r>
           </a:p>
         </p:txBody>
@@ -9382,12 +9394,12 @@
             <a:pPr>
               <a:defRPr b="1" sz="1400">
                 <a:solidFill>
-                  <a:srgbClr val="00FF88"/>
-                </a:solidFill>
-              </a:defRPr>
-            </a:pPr>
-            <a:r>
-              <a:t>CoalOmIT</a:t>
+                  <a:srgbClr val="FF6E00"/>
+                </a:solidFill>
+              </a:defRPr>
+            </a:pPr>
+            <a:r>
+              <a:t>CoalØmit</a:t>
             </a:r>
           </a:p>
           <a:p>
@@ -9399,7 +9411,7 @@
               </a:defRPr>
             </a:pPr>
             <a:r>
-              <a:t>Leveraging Technology — Legacy vs CoalOmIT</a:t>
+              <a:t>Leveraging Technology — Legacy vs CoalØmit</a:t>
             </a:r>
           </a:p>
         </p:txBody>
@@ -9419,7 +9431,7 @@
             <a:avLst/>
           </a:prstGeom>
           <a:solidFill>
-            <a:srgbClr val="060610"/>
+            <a:srgbClr val="121212"/>
           </a:solidFill>
           <a:ln>
             <a:noFill/>
@@ -9446,12 +9458,12 @@
             <a:pPr algn="r">
               <a:defRPr sz="1000">
                 <a:solidFill>
-                  <a:srgbClr val="8C91A0"/>
-                </a:solidFill>
-              </a:defRPr>
-            </a:pPr>
-            <a:r>
-              <a:t>CoalOmIT — Green AI Platform  |  Confidential Pitch Deck</a:t>
+                  <a:srgbClr val="D97706"/>
+                </a:solidFill>
+              </a:defRPr>
+            </a:pPr>
+            <a:r>
+              <a:t>CoalØmit — REDUCE NOW SUSTAIN FOREVER  |  REDUCE NOW SUSTAIN FOREVER</a:t>
             </a:r>
           </a:p>
         </p:txBody>
@@ -9488,7 +9500,7 @@
                       <a:pPr algn="ctr">
                         <a:defRPr b="1" sz="1300">
                           <a:solidFill>
-                            <a:srgbClr val="00FF88"/>
+                            <a:srgbClr val="FF6E00"/>
                           </a:solidFill>
                         </a:defRPr>
                       </a:pPr>
@@ -9499,7 +9511,7 @@
                   </a:txBody>
                   <a:tcPr>
                     <a:solidFill>
-                      <a:srgbClr val="141428"/>
+                      <a:srgbClr val="222222"/>
                     </a:solidFill>
                   </a:tcPr>
                 </a:tc>
@@ -9511,7 +9523,7 @@
                       <a:pPr algn="ctr">
                         <a:defRPr b="1" sz="1300">
                           <a:solidFill>
-                            <a:srgbClr val="00FF88"/>
+                            <a:srgbClr val="FF6E00"/>
                           </a:solidFill>
                         </a:defRPr>
                       </a:pPr>
@@ -9522,7 +9534,7 @@
                   </a:txBody>
                   <a:tcPr>
                     <a:solidFill>
-                      <a:srgbClr val="141428"/>
+                      <a:srgbClr val="222222"/>
                     </a:solidFill>
                   </a:tcPr>
                 </a:tc>
@@ -9534,18 +9546,18 @@
                       <a:pPr algn="ctr">
                         <a:defRPr b="1" sz="1300">
                           <a:solidFill>
-                            <a:srgbClr val="00FF88"/>
+                            <a:srgbClr val="FF6E00"/>
                           </a:solidFill>
                         </a:defRPr>
                       </a:pPr>
                       <a:r>
-                        <a:t>CoalOmIT Platform</a:t>
+                        <a:t>CoalØmit Platform</a:t>
                       </a:r>
                     </a:p>
                   </a:txBody>
                   <a:tcPr>
                     <a:solidFill>
-                      <a:srgbClr val="141428"/>
+                      <a:srgbClr val="222222"/>
                     </a:solidFill>
                   </a:tcPr>
                 </a:tc>
@@ -9559,7 +9571,7 @@
                       <a:pPr>
                         <a:defRPr sz="1100">
                           <a:solidFill>
-                            <a:srgbClr val="E8E8F0"/>
+                            <a:srgbClr val="E5E5E5"/>
                           </a:solidFill>
                         </a:defRPr>
                       </a:pPr>
@@ -9570,7 +9582,7 @@
                   </a:txBody>
                   <a:tcPr>
                     <a:solidFill>
-                      <a:srgbClr val="0D0D1A"/>
+                      <a:srgbClr val="1A1A1A"/>
                     </a:solidFill>
                   </a:tcPr>
                 </a:tc>
@@ -9582,7 +9594,7 @@
                       <a:pPr>
                         <a:defRPr sz="1100">
                           <a:solidFill>
-                            <a:srgbClr val="E8E8F0"/>
+                            <a:srgbClr val="E5E5E5"/>
                           </a:solidFill>
                         </a:defRPr>
                       </a:pPr>
@@ -9593,7 +9605,7 @@
                   </a:txBody>
                   <a:tcPr>
                     <a:solidFill>
-                      <a:srgbClr val="0D0D1A"/>
+                      <a:srgbClr val="1A1A1A"/>
                     </a:solidFill>
                   </a:tcPr>
                 </a:tc>
@@ -9605,7 +9617,7 @@
                       <a:pPr>
                         <a:defRPr sz="1100">
                           <a:solidFill>
-                            <a:srgbClr val="00FF88"/>
+                            <a:srgbClr val="FF6E00"/>
                           </a:solidFill>
                         </a:defRPr>
                       </a:pPr>
@@ -9616,7 +9628,7 @@
                   </a:txBody>
                   <a:tcPr>
                     <a:solidFill>
-                      <a:srgbClr val="0D0D1A"/>
+                      <a:srgbClr val="1A1A1A"/>
                     </a:solidFill>
                   </a:tcPr>
                 </a:tc>
@@ -9630,7 +9642,7 @@
                       <a:pPr>
                         <a:defRPr sz="1100">
                           <a:solidFill>
-                            <a:srgbClr val="E8E8F0"/>
+                            <a:srgbClr val="E5E5E5"/>
                           </a:solidFill>
                         </a:defRPr>
                       </a:pPr>
@@ -9641,7 +9653,7 @@
                   </a:txBody>
                   <a:tcPr>
                     <a:solidFill>
-                      <a:srgbClr val="060610"/>
+                      <a:srgbClr val="121212"/>
                     </a:solidFill>
                   </a:tcPr>
                 </a:tc>
@@ -9653,7 +9665,7 @@
                       <a:pPr>
                         <a:defRPr sz="1100">
                           <a:solidFill>
-                            <a:srgbClr val="E8E8F0"/>
+                            <a:srgbClr val="E5E5E5"/>
                           </a:solidFill>
                         </a:defRPr>
                       </a:pPr>
@@ -9664,7 +9676,7 @@
                   </a:txBody>
                   <a:tcPr>
                     <a:solidFill>
-                      <a:srgbClr val="060610"/>
+                      <a:srgbClr val="121212"/>
                     </a:solidFill>
                   </a:tcPr>
                 </a:tc>
@@ -9676,7 +9688,7 @@
                       <a:pPr>
                         <a:defRPr sz="1100">
                           <a:solidFill>
-                            <a:srgbClr val="00FF88"/>
+                            <a:srgbClr val="FF6E00"/>
                           </a:solidFill>
                         </a:defRPr>
                       </a:pPr>
@@ -9687,7 +9699,7 @@
                   </a:txBody>
                   <a:tcPr>
                     <a:solidFill>
-                      <a:srgbClr val="060610"/>
+                      <a:srgbClr val="121212"/>
                     </a:solidFill>
                   </a:tcPr>
                 </a:tc>
@@ -9701,7 +9713,7 @@
                       <a:pPr>
                         <a:defRPr sz="1100">
                           <a:solidFill>
-                            <a:srgbClr val="E8E8F0"/>
+                            <a:srgbClr val="E5E5E5"/>
                           </a:solidFill>
                         </a:defRPr>
                       </a:pPr>
@@ -9712,7 +9724,7 @@
                   </a:txBody>
                   <a:tcPr>
                     <a:solidFill>
-                      <a:srgbClr val="0D0D1A"/>
+                      <a:srgbClr val="1A1A1A"/>
                     </a:solidFill>
                   </a:tcPr>
                 </a:tc>
@@ -9724,7 +9736,7 @@
                       <a:pPr>
                         <a:defRPr sz="1100">
                           <a:solidFill>
-                            <a:srgbClr val="E8E8F0"/>
+                            <a:srgbClr val="E5E5E5"/>
                           </a:solidFill>
                         </a:defRPr>
                       </a:pPr>
@@ -9735,7 +9747,7 @@
                   </a:txBody>
                   <a:tcPr>
                     <a:solidFill>
-                      <a:srgbClr val="0D0D1A"/>
+                      <a:srgbClr val="1A1A1A"/>
                     </a:solidFill>
                   </a:tcPr>
                 </a:tc>
@@ -9747,7 +9759,7 @@
                       <a:pPr>
                         <a:defRPr sz="1100">
                           <a:solidFill>
-                            <a:srgbClr val="00FF88"/>
+                            <a:srgbClr val="FF6E00"/>
                           </a:solidFill>
                         </a:defRPr>
                       </a:pPr>
@@ -9758,7 +9770,7 @@
                   </a:txBody>
                   <a:tcPr>
                     <a:solidFill>
-                      <a:srgbClr val="0D0D1A"/>
+                      <a:srgbClr val="1A1A1A"/>
                     </a:solidFill>
                   </a:tcPr>
                 </a:tc>
@@ -9772,7 +9784,7 @@
                       <a:pPr>
                         <a:defRPr sz="1100">
                           <a:solidFill>
-                            <a:srgbClr val="E8E8F0"/>
+                            <a:srgbClr val="E5E5E5"/>
                           </a:solidFill>
                         </a:defRPr>
                       </a:pPr>
@@ -9783,7 +9795,7 @@
                   </a:txBody>
                   <a:tcPr>
                     <a:solidFill>
-                      <a:srgbClr val="060610"/>
+                      <a:srgbClr val="121212"/>
                     </a:solidFill>
                   </a:tcPr>
                 </a:tc>
@@ -9795,7 +9807,7 @@
                       <a:pPr>
                         <a:defRPr sz="1100">
                           <a:solidFill>
-                            <a:srgbClr val="E8E8F0"/>
+                            <a:srgbClr val="E5E5E5"/>
                           </a:solidFill>
                         </a:defRPr>
                       </a:pPr>
@@ -9806,7 +9818,7 @@
                   </a:txBody>
                   <a:tcPr>
                     <a:solidFill>
-                      <a:srgbClr val="060610"/>
+                      <a:srgbClr val="121212"/>
                     </a:solidFill>
                   </a:tcPr>
                 </a:tc>
@@ -9818,7 +9830,7 @@
                       <a:pPr>
                         <a:defRPr sz="1100">
                           <a:solidFill>
-                            <a:srgbClr val="00FF88"/>
+                            <a:srgbClr val="FF6E00"/>
                           </a:solidFill>
                         </a:defRPr>
                       </a:pPr>
@@ -9829,7 +9841,7 @@
                   </a:txBody>
                   <a:tcPr>
                     <a:solidFill>
-                      <a:srgbClr val="060610"/>
+                      <a:srgbClr val="121212"/>
                     </a:solidFill>
                   </a:tcPr>
                 </a:tc>
@@ -9843,7 +9855,7 @@
                       <a:pPr>
                         <a:defRPr sz="1100">
                           <a:solidFill>
-                            <a:srgbClr val="E8E8F0"/>
+                            <a:srgbClr val="E5E5E5"/>
                           </a:solidFill>
                         </a:defRPr>
                       </a:pPr>
@@ -9854,7 +9866,7 @@
                   </a:txBody>
                   <a:tcPr>
                     <a:solidFill>
-                      <a:srgbClr val="0D0D1A"/>
+                      <a:srgbClr val="1A1A1A"/>
                     </a:solidFill>
                   </a:tcPr>
                 </a:tc>
@@ -9866,7 +9878,7 @@
                       <a:pPr>
                         <a:defRPr sz="1100">
                           <a:solidFill>
-                            <a:srgbClr val="E8E8F0"/>
+                            <a:srgbClr val="E5E5E5"/>
                           </a:solidFill>
                         </a:defRPr>
                       </a:pPr>
@@ -9877,7 +9889,7 @@
                   </a:txBody>
                   <a:tcPr>
                     <a:solidFill>
-                      <a:srgbClr val="0D0D1A"/>
+                      <a:srgbClr val="1A1A1A"/>
                     </a:solidFill>
                   </a:tcPr>
                 </a:tc>
@@ -9889,7 +9901,7 @@
                       <a:pPr>
                         <a:defRPr sz="1100">
                           <a:solidFill>
-                            <a:srgbClr val="00FF88"/>
+                            <a:srgbClr val="FF6E00"/>
                           </a:solidFill>
                         </a:defRPr>
                       </a:pPr>
@@ -9900,7 +9912,7 @@
                   </a:txBody>
                   <a:tcPr>
                     <a:solidFill>
-                      <a:srgbClr val="0D0D1A"/>
+                      <a:srgbClr val="1A1A1A"/>
                     </a:solidFill>
                   </a:tcPr>
                 </a:tc>
@@ -9942,7 +9954,7 @@
             <a:avLst/>
           </a:prstGeom>
           <a:solidFill>
-            <a:srgbClr val="060610"/>
+            <a:srgbClr val="121212"/>
           </a:solidFill>
           <a:ln>
             <a:noFill/>
@@ -9985,11 +9997,11 @@
             <a:avLst/>
           </a:prstGeom>
           <a:solidFill>
-            <a:srgbClr val="060610"/>
+            <a:srgbClr val="121212"/>
           </a:solidFill>
           <a:ln w="19050">
             <a:solidFill>
-              <a:srgbClr val="00FF88"/>
+              <a:srgbClr val="FF6E00"/>
             </a:solidFill>
           </a:ln>
         </p:spPr>
@@ -10030,7 +10042,7 @@
             <a:avLst/>
           </a:prstGeom>
           <a:solidFill>
-            <a:srgbClr val="00FF88"/>
+            <a:srgbClr val="FF6E00"/>
           </a:solidFill>
           <a:ln>
             <a:noFill/>
@@ -10057,12 +10069,12 @@
             <a:pPr algn="ctr">
               <a:defRPr b="1" sz="2200">
                 <a:solidFill>
-                  <a:srgbClr val="060610"/>
-                </a:solidFill>
-              </a:defRPr>
-            </a:pPr>
-            <a:r>
-              <a:t>Cø</a:t>
+                  <a:srgbClr val="121212"/>
+                </a:solidFill>
+              </a:defRPr>
+            </a:pPr>
+            <a:r>
+              <a:t>CØ</a:t>
             </a:r>
           </a:p>
         </p:txBody>
@@ -10092,12 +10104,12 @@
             <a:pPr>
               <a:defRPr b="1" sz="1400">
                 <a:solidFill>
-                  <a:srgbClr val="00FF88"/>
-                </a:solidFill>
-              </a:defRPr>
-            </a:pPr>
-            <a:r>
-              <a:t>CoalOmIT</a:t>
+                  <a:srgbClr val="FF6E00"/>
+                </a:solidFill>
+              </a:defRPr>
+            </a:pPr>
+            <a:r>
+              <a:t>CoalØmit</a:t>
             </a:r>
           </a:p>
           <a:p>
@@ -10129,7 +10141,7 @@
             <a:avLst/>
           </a:prstGeom>
           <a:solidFill>
-            <a:srgbClr val="060610"/>
+            <a:srgbClr val="121212"/>
           </a:solidFill>
           <a:ln>
             <a:noFill/>
@@ -10156,12 +10168,12 @@
             <a:pPr algn="r">
               <a:defRPr sz="1000">
                 <a:solidFill>
-                  <a:srgbClr val="8C91A0"/>
-                </a:solidFill>
-              </a:defRPr>
-            </a:pPr>
-            <a:r>
-              <a:t>CoalOmIT — Green AI Platform  |  Confidential Pitch Deck</a:t>
+                  <a:srgbClr val="D97706"/>
+                </a:solidFill>
+              </a:defRPr>
+            </a:pPr>
+            <a:r>
+              <a:t>CoalØmit — REDUCE NOW SUSTAIN FOREVER  |  REDUCE NOW SUSTAIN FOREVER</a:t>
             </a:r>
           </a:p>
         </p:txBody>
@@ -10181,11 +10193,11 @@
             <a:avLst/>
           </a:prstGeom>
           <a:solidFill>
-            <a:srgbClr val="0D0D1A"/>
+            <a:srgbClr val="1A1A1A"/>
           </a:solidFill>
           <a:ln>
             <a:solidFill>
-              <a:srgbClr val="1E2337"/>
+              <a:srgbClr val="B45A00"/>
             </a:solidFill>
           </a:ln>
         </p:spPr>
@@ -10210,7 +10222,7 @@
             <a:pPr algn="ctr">
               <a:defRPr b="1" sz="1800">
                 <a:solidFill>
-                  <a:srgbClr val="00D4FF"/>
+                  <a:srgbClr val="FF6E00"/>
                 </a:solidFill>
               </a:defRPr>
             </a:pPr>
@@ -10222,7 +10234,7 @@
             <a:pPr>
               <a:defRPr sz="1300">
                 <a:solidFill>
-                  <a:srgbClr val="E8E8F0"/>
+                  <a:srgbClr val="E5E5E5"/>
                 </a:solidFill>
               </a:defRPr>
             </a:pPr>
@@ -10234,7 +10246,7 @@
             <a:pPr>
               <a:defRPr sz="1300">
                 <a:solidFill>
-                  <a:srgbClr val="E8E8F0"/>
+                  <a:srgbClr val="E5E5E5"/>
                 </a:solidFill>
               </a:defRPr>
             </a:pPr>
@@ -10246,7 +10258,7 @@
             <a:pPr>
               <a:defRPr sz="1300">
                 <a:solidFill>
-                  <a:srgbClr val="E8E8F0"/>
+                  <a:srgbClr val="E5E5E5"/>
                 </a:solidFill>
               </a:defRPr>
             </a:pPr>
@@ -10258,7 +10270,7 @@
             <a:pPr>
               <a:defRPr sz="1300">
                 <a:solidFill>
-                  <a:srgbClr val="E8E8F0"/>
+                  <a:srgbClr val="E5E5E5"/>
                 </a:solidFill>
               </a:defRPr>
             </a:pPr>
@@ -10270,7 +10282,7 @@
             <a:pPr>
               <a:defRPr sz="1300">
                 <a:solidFill>
-                  <a:srgbClr val="E8E8F0"/>
+                  <a:srgbClr val="E5E5E5"/>
                 </a:solidFill>
               </a:defRPr>
             </a:pPr>
@@ -10295,11 +10307,11 @@
             <a:avLst/>
           </a:prstGeom>
           <a:solidFill>
-            <a:srgbClr val="0D0D1A"/>
+            <a:srgbClr val="1A1A1A"/>
           </a:solidFill>
           <a:ln>
             <a:solidFill>
-              <a:srgbClr val="1E2337"/>
+              <a:srgbClr val="B45A00"/>
             </a:solidFill>
           </a:ln>
         </p:spPr>
@@ -10324,7 +10336,7 @@
             <a:pPr algn="ctr">
               <a:defRPr b="1" sz="1800">
                 <a:solidFill>
-                  <a:srgbClr val="00D4FF"/>
+                  <a:srgbClr val="D97706"/>
                 </a:solidFill>
               </a:defRPr>
             </a:pPr>
@@ -10336,7 +10348,7 @@
             <a:pPr>
               <a:defRPr sz="1300">
                 <a:solidFill>
-                  <a:srgbClr val="E8E8F0"/>
+                  <a:srgbClr val="E5E5E5"/>
                 </a:solidFill>
               </a:defRPr>
             </a:pPr>
@@ -10348,7 +10360,7 @@
             <a:pPr>
               <a:defRPr sz="1300">
                 <a:solidFill>
-                  <a:srgbClr val="E8E8F0"/>
+                  <a:srgbClr val="E5E5E5"/>
                 </a:solidFill>
               </a:defRPr>
             </a:pPr>
@@ -10360,7 +10372,7 @@
             <a:pPr>
               <a:defRPr sz="1300">
                 <a:solidFill>
-                  <a:srgbClr val="E8E8F0"/>
+                  <a:srgbClr val="E5E5E5"/>
                 </a:solidFill>
               </a:defRPr>
             </a:pPr>
@@ -10372,7 +10384,7 @@
             <a:pPr>
               <a:defRPr sz="1300">
                 <a:solidFill>
-                  <a:srgbClr val="E8E8F0"/>
+                  <a:srgbClr val="E5E5E5"/>
                 </a:solidFill>
               </a:defRPr>
             </a:pPr>
@@ -10384,7 +10396,7 @@
             <a:pPr>
               <a:defRPr sz="1300">
                 <a:solidFill>
-                  <a:srgbClr val="E8E8F0"/>
+                  <a:srgbClr val="E5E5E5"/>
                 </a:solidFill>
               </a:defRPr>
             </a:pPr>

</xml_diff>

<commit_message>
Fix README markdown syntax and sync pitch black amber orange theme
</commit_message>
<xml_diff>
--- a/CoalOmIT_Pitch_Deck.pptx
+++ b/CoalOmIT_Pitch_Deck.pptx
@@ -5,21 +5,21 @@
     <p:sldMasterId id="2147483648" r:id="rId1"/>
   </p:sldMasterIdLst>
   <p:sldIdLst>
-    <p:sldId id="256" r:id="rId7"/>
-    <p:sldId id="257" r:id="rId8"/>
-    <p:sldId id="258" r:id="rId9"/>
-    <p:sldId id="259" r:id="rId10"/>
-    <p:sldId id="260" r:id="rId11"/>
-    <p:sldId id="261" r:id="rId12"/>
-    <p:sldId id="262" r:id="rId13"/>
-    <p:sldId id="263" r:id="rId14"/>
-    <p:sldId id="264" r:id="rId15"/>
-    <p:sldId id="265" r:id="rId16"/>
-    <p:sldId id="266" r:id="rId17"/>
-    <p:sldId id="267" r:id="rId18"/>
-    <p:sldId id="268" r:id="rId19"/>
+    <p:sldId id="256" r:id="rId2"/>
+    <p:sldId id="257" r:id="rId3"/>
+    <p:sldId id="258" r:id="rId4"/>
+    <p:sldId id="259" r:id="rId5"/>
+    <p:sldId id="260" r:id="rId6"/>
+    <p:sldId id="261" r:id="rId7"/>
+    <p:sldId id="262" r:id="rId8"/>
+    <p:sldId id="263" r:id="rId9"/>
+    <p:sldId id="264" r:id="rId10"/>
+    <p:sldId id="265" r:id="rId11"/>
+    <p:sldId id="266" r:id="rId12"/>
+    <p:sldId id="267" r:id="rId13"/>
+    <p:sldId id="268" r:id="rId14"/>
   </p:sldIdLst>
-  <p:sldSz cx="12191695" cy="6858000" type="screen4x3"/>
+  <p:sldSz cx="12192000" cy="6858000"/>
   <p:notesSz cx="6858000" cy="9144000"/>
   <p:defaultTextStyle>
     <a:defPPr>
@@ -300,7 +300,7 @@
           <a:p>
             <a:fld id="{5BCAD085-E8A6-8845-BD4E-CB4CCA059FC4}" type="datetimeFigureOut">
               <a:rPr lang="en-US" smtClean="0"/>
-              <a:t>1/27/13</a:t>
+              <a:t>8/15/2026</a:t>
             </a:fld>
             <a:endParaRPr lang="en-US"/>
           </a:p>
@@ -470,7 +470,7 @@
           <a:p>
             <a:fld id="{5BCAD085-E8A6-8845-BD4E-CB4CCA059FC4}" type="datetimeFigureOut">
               <a:rPr lang="en-US" smtClean="0"/>
-              <a:t>1/27/13</a:t>
+              <a:t>8/15/2026</a:t>
             </a:fld>
             <a:endParaRPr lang="en-US"/>
           </a:p>
@@ -650,7 +650,7 @@
           <a:p>
             <a:fld id="{5BCAD085-E8A6-8845-BD4E-CB4CCA059FC4}" type="datetimeFigureOut">
               <a:rPr lang="en-US" smtClean="0"/>
-              <a:t>1/27/13</a:t>
+              <a:t>8/15/2026</a:t>
             </a:fld>
             <a:endParaRPr lang="en-US"/>
           </a:p>
@@ -820,7 +820,7 @@
           <a:p>
             <a:fld id="{5BCAD085-E8A6-8845-BD4E-CB4CCA059FC4}" type="datetimeFigureOut">
               <a:rPr lang="en-US" smtClean="0"/>
-              <a:t>1/27/13</a:t>
+              <a:t>8/15/2026</a:t>
             </a:fld>
             <a:endParaRPr lang="en-US"/>
           </a:p>
@@ -1066,7 +1066,7 @@
           <a:p>
             <a:fld id="{5BCAD085-E8A6-8845-BD4E-CB4CCA059FC4}" type="datetimeFigureOut">
               <a:rPr lang="en-US" smtClean="0"/>
-              <a:t>1/27/13</a:t>
+              <a:t>8/15/2026</a:t>
             </a:fld>
             <a:endParaRPr lang="en-US"/>
           </a:p>
@@ -1354,7 +1354,7 @@
           <a:p>
             <a:fld id="{5BCAD085-E8A6-8845-BD4E-CB4CCA059FC4}" type="datetimeFigureOut">
               <a:rPr lang="en-US" smtClean="0"/>
-              <a:t>1/27/13</a:t>
+              <a:t>8/15/2026</a:t>
             </a:fld>
             <a:endParaRPr lang="en-US"/>
           </a:p>
@@ -1776,7 +1776,7 @@
           <a:p>
             <a:fld id="{5BCAD085-E8A6-8845-BD4E-CB4CCA059FC4}" type="datetimeFigureOut">
               <a:rPr lang="en-US" smtClean="0"/>
-              <a:t>1/27/13</a:t>
+              <a:t>8/15/2026</a:t>
             </a:fld>
             <a:endParaRPr lang="en-US"/>
           </a:p>
@@ -1894,7 +1894,7 @@
           <a:p>
             <a:fld id="{5BCAD085-E8A6-8845-BD4E-CB4CCA059FC4}" type="datetimeFigureOut">
               <a:rPr lang="en-US" smtClean="0"/>
-              <a:t>1/27/13</a:t>
+              <a:t>8/15/2026</a:t>
             </a:fld>
             <a:endParaRPr lang="en-US"/>
           </a:p>
@@ -1989,7 +1989,7 @@
           <a:p>
             <a:fld id="{5BCAD085-E8A6-8845-BD4E-CB4CCA059FC4}" type="datetimeFigureOut">
               <a:rPr lang="en-US" smtClean="0"/>
-              <a:t>1/27/13</a:t>
+              <a:t>8/15/2026</a:t>
             </a:fld>
             <a:endParaRPr lang="en-US"/>
           </a:p>
@@ -2266,7 +2266,7 @@
           <a:p>
             <a:fld id="{5BCAD085-E8A6-8845-BD4E-CB4CCA059FC4}" type="datetimeFigureOut">
               <a:rPr lang="en-US" smtClean="0"/>
-              <a:t>1/27/13</a:t>
+              <a:t>8/15/2026</a:t>
             </a:fld>
             <a:endParaRPr lang="en-US"/>
           </a:p>
@@ -2519,7 +2519,7 @@
           <a:p>
             <a:fld id="{5BCAD085-E8A6-8845-BD4E-CB4CCA059FC4}" type="datetimeFigureOut">
               <a:rPr lang="en-US" smtClean="0"/>
-              <a:t>1/27/13</a:t>
+              <a:t>8/15/2026</a:t>
             </a:fld>
             <a:endParaRPr lang="en-US"/>
           </a:p>
@@ -2732,7 +2732,7 @@
           <a:p>
             <a:fld id="{5BCAD085-E8A6-8845-BD4E-CB4CCA059FC4}" type="datetimeFigureOut">
               <a:rPr lang="en-US" smtClean="0"/>
-              <a:t>1/27/13</a:t>
+              <a:t>8/15/2026</a:t>
             </a:fld>
             <a:endParaRPr lang="en-US"/>
           </a:p>
@@ -3091,7 +3091,7 @@
 </file>
 
 <file path=ppt/slides/slide1.xml><?xml version="1.0" encoding="utf-8"?>
-<p:sld xmlns:a="http://schemas.openxmlformats.org/drawingml/2006/main" xmlns:p="http://schemas.openxmlformats.org/presentationml/2006/main" xmlns:r="http://schemas.openxmlformats.org/officeDocument/2006/relationships">
+<p:sld xmlns:a="http://schemas.openxmlformats.org/drawingml/2006/main" xmlns:r="http://schemas.openxmlformats.org/officeDocument/2006/relationships" xmlns:p="http://schemas.openxmlformats.org/presentationml/2006/main">
   <p:cSld>
     <p:spTree>
       <p:nvGrpSpPr>
@@ -3099,7 +3099,14 @@
         <p:cNvGrpSpPr/>
         <p:nvPr/>
       </p:nvGrpSpPr>
-      <p:grpSpPr/>
+      <p:grpSpPr>
+        <a:xfrm>
+          <a:off x="0" y="0"/>
+          <a:ext cx="0" cy="0"/>
+          <a:chOff x="0" y="0"/>
+          <a:chExt cx="0" cy="0"/>
+        </a:xfrm>
+      </p:grpSpPr>
       <p:sp>
         <p:nvSpPr>
           <p:cNvPr id="2" name="Rectangle 1"/>
@@ -3140,6 +3147,7 @@
           <a:lstStyle/>
           <a:p>
             <a:pPr algn="ctr"/>
+            <a:endParaRPr/>
           </a:p>
         </p:txBody>
       </p:sp>
@@ -3185,6 +3193,7 @@
           <a:lstStyle/>
           <a:p>
             <a:pPr algn="ctr"/>
+            <a:endParaRPr/>
           </a:p>
         </p:txBody>
       </p:sp>
@@ -3211,7 +3220,7 @@
           <a:lstStyle/>
           <a:p>
             <a:pPr algn="ctr">
-              <a:defRPr b="1" sz="5400">
+              <a:defRPr sz="5400" b="1">
                 <a:solidFill>
                   <a:srgbClr val="FF6E00"/>
                 </a:solidFill>
@@ -3223,7 +3232,7 @@
           </a:p>
           <a:p>
             <a:pPr algn="ctr">
-              <a:defRPr b="1" sz="1600">
+              <a:defRPr sz="1600" b="1">
                 <a:solidFill>
                   <a:srgbClr val="E5E5E5"/>
                 </a:solidFill>
@@ -3258,7 +3267,7 @@
           <a:lstStyle/>
           <a:p>
             <a:pPr algn="ctr">
-              <a:defRPr b="1" sz="3800">
+              <a:defRPr sz="3800" b="1">
                 <a:solidFill>
                   <a:srgbClr val="FFFFFF"/>
                 </a:solidFill>
@@ -3339,11 +3348,18 @@
   <p:clrMapOvr>
     <a:masterClrMapping/>
   </p:clrMapOvr>
+  <p:timing>
+    <p:tnLst>
+      <p:par>
+        <p:cTn id="1" dur="indefinite" restart="never" nodeType="tmRoot"/>
+      </p:par>
+    </p:tnLst>
+  </p:timing>
 </p:sld>
 </file>
 
 <file path=ppt/slides/slide10.xml><?xml version="1.0" encoding="utf-8"?>
-<p:sld xmlns:a="http://schemas.openxmlformats.org/drawingml/2006/main" xmlns:p="http://schemas.openxmlformats.org/presentationml/2006/main" xmlns:r="http://schemas.openxmlformats.org/officeDocument/2006/relationships">
+<p:sld xmlns:a="http://schemas.openxmlformats.org/drawingml/2006/main" xmlns:r="http://schemas.openxmlformats.org/officeDocument/2006/relationships" xmlns:p="http://schemas.openxmlformats.org/presentationml/2006/main">
   <p:cSld>
     <p:spTree>
       <p:nvGrpSpPr>
@@ -3351,7 +3367,14 @@
         <p:cNvGrpSpPr/>
         <p:nvPr/>
       </p:nvGrpSpPr>
-      <p:grpSpPr/>
+      <p:grpSpPr>
+        <a:xfrm>
+          <a:off x="0" y="0"/>
+          <a:ext cx="0" cy="0"/>
+          <a:chOff x="0" y="0"/>
+          <a:chExt cx="0" cy="0"/>
+        </a:xfrm>
+      </p:grpSpPr>
       <p:sp>
         <p:nvSpPr>
           <p:cNvPr id="2" name="Rectangle 1"/>
@@ -3392,6 +3415,7 @@
           <a:lstStyle/>
           <a:p>
             <a:pPr algn="ctr"/>
+            <a:endParaRPr/>
           </a:p>
         </p:txBody>
       </p:sp>
@@ -3437,6 +3461,7 @@
           <a:lstStyle/>
           <a:p>
             <a:pPr algn="ctr"/>
+            <a:endParaRPr/>
           </a:p>
         </p:txBody>
       </p:sp>
@@ -3476,11 +3501,11 @@
           </a:fontRef>
         </p:style>
         <p:txBody>
-          <a:bodyPr rtlCol="0" anchor="ctr" wrap="square"/>
+          <a:bodyPr wrap="square" rtlCol="0" anchor="ctr"/>
           <a:lstStyle/>
           <a:p>
             <a:pPr algn="ctr">
-              <a:defRPr b="1" sz="2200">
+              <a:defRPr sz="2200" b="1">
                 <a:solidFill>
                   <a:srgbClr val="121212"/>
                 </a:solidFill>
@@ -3515,7 +3540,7 @@
           <a:lstStyle/>
           <a:p>
             <a:pPr>
-              <a:defRPr b="1" sz="1400">
+              <a:defRPr sz="1400" b="1">
                 <a:solidFill>
                   <a:srgbClr val="FF6E00"/>
                 </a:solidFill>
@@ -3527,7 +3552,7 @@
           </a:p>
           <a:p>
             <a:pPr>
-              <a:defRPr b="1" sz="2400">
+              <a:defRPr sz="2400" b="1">
                 <a:solidFill>
                   <a:srgbClr val="FFFFFF"/>
                 </a:solidFill>
@@ -3586,7 +3611,12 @@
               </a:defRPr>
             </a:pPr>
             <a:r>
-              <a:t>CoalØmit — REDUCE NOW SUSTAIN FOREVER  |  REDUCE NOW SUSTAIN FOREVER</a:t>
+              <a:rPr dirty="0" err="1"/>
+              <a:t>CoalØmit</a:t>
+            </a:r>
+            <a:r>
+              <a:rPr dirty="0"/>
+              <a:t> — REDUCE NOW SUSTAIN FOREVER  </a:t>
             </a:r>
           </a:p>
         </p:txBody>
@@ -3629,11 +3659,11 @@
           </a:fontRef>
         </p:style>
         <p:txBody>
-          <a:bodyPr rtlCol="0" anchor="ctr" wrap="square"/>
+          <a:bodyPr wrap="square" rtlCol="0" anchor="ctr"/>
           <a:lstStyle/>
           <a:p>
             <a:pPr algn="ctr">
-              <a:defRPr b="1" sz="3800">
+              <a:defRPr sz="3800" b="1">
                 <a:solidFill>
                   <a:srgbClr val="FF6E00"/>
                 </a:solidFill>
@@ -3645,7 +3675,7 @@
           </a:p>
           <a:p>
             <a:pPr algn="ctr">
-              <a:defRPr b="1" sz="1400">
+              <a:defRPr sz="1400" b="1">
                 <a:solidFill>
                   <a:srgbClr val="FFFFFF"/>
                 </a:solidFill>
@@ -3707,11 +3737,11 @@
           </a:fontRef>
         </p:style>
         <p:txBody>
-          <a:bodyPr rtlCol="0" anchor="ctr" wrap="square"/>
+          <a:bodyPr wrap="square" rtlCol="0" anchor="ctr"/>
           <a:lstStyle/>
           <a:p>
             <a:pPr algn="ctr">
-              <a:defRPr b="1" sz="3800">
+              <a:defRPr sz="3800" b="1">
                 <a:solidFill>
                   <a:srgbClr val="FF6E00"/>
                 </a:solidFill>
@@ -3723,7 +3753,7 @@
           </a:p>
           <a:p>
             <a:pPr algn="ctr">
-              <a:defRPr b="1" sz="1400">
+              <a:defRPr sz="1400" b="1">
                 <a:solidFill>
                   <a:srgbClr val="FFFFFF"/>
                 </a:solidFill>
@@ -3785,11 +3815,11 @@
           </a:fontRef>
         </p:style>
         <p:txBody>
-          <a:bodyPr rtlCol="0" anchor="ctr" wrap="square"/>
+          <a:bodyPr wrap="square" rtlCol="0" anchor="ctr"/>
           <a:lstStyle/>
           <a:p>
             <a:pPr algn="ctr">
-              <a:defRPr b="1" sz="3800">
+              <a:defRPr sz="3800" b="1">
                 <a:solidFill>
                   <a:srgbClr val="FF6E00"/>
                 </a:solidFill>
@@ -3801,7 +3831,7 @@
           </a:p>
           <a:p>
             <a:pPr algn="ctr">
-              <a:defRPr b="1" sz="1400">
+              <a:defRPr sz="1400" b="1">
                 <a:solidFill>
                   <a:srgbClr val="FFFFFF"/>
                 </a:solidFill>
@@ -3863,11 +3893,11 @@
           </a:fontRef>
         </p:style>
         <p:txBody>
-          <a:bodyPr rtlCol="0" anchor="ctr" wrap="square"/>
+          <a:bodyPr wrap="square" rtlCol="0" anchor="ctr"/>
           <a:lstStyle/>
           <a:p>
             <a:pPr algn="ctr">
-              <a:defRPr b="1" sz="3800">
+              <a:defRPr sz="3800" b="1">
                 <a:solidFill>
                   <a:srgbClr val="FF6E00"/>
                 </a:solidFill>
@@ -3879,7 +3909,7 @@
           </a:p>
           <a:p>
             <a:pPr algn="ctr">
-              <a:defRPr b="1" sz="1400">
+              <a:defRPr sz="1400" b="1">
                 <a:solidFill>
                   <a:srgbClr val="FFFFFF"/>
                 </a:solidFill>
@@ -3908,11 +3938,18 @@
   <p:clrMapOvr>
     <a:masterClrMapping/>
   </p:clrMapOvr>
+  <p:timing>
+    <p:tnLst>
+      <p:par>
+        <p:cTn id="1" dur="indefinite" restart="never" nodeType="tmRoot"/>
+      </p:par>
+    </p:tnLst>
+  </p:timing>
 </p:sld>
 </file>
 
 <file path=ppt/slides/slide11.xml><?xml version="1.0" encoding="utf-8"?>
-<p:sld xmlns:a="http://schemas.openxmlformats.org/drawingml/2006/main" xmlns:p="http://schemas.openxmlformats.org/presentationml/2006/main" xmlns:r="http://schemas.openxmlformats.org/officeDocument/2006/relationships">
+<p:sld xmlns:a="http://schemas.openxmlformats.org/drawingml/2006/main" xmlns:r="http://schemas.openxmlformats.org/officeDocument/2006/relationships" xmlns:p="http://schemas.openxmlformats.org/presentationml/2006/main">
   <p:cSld>
     <p:spTree>
       <p:nvGrpSpPr>
@@ -3920,7 +3957,14 @@
         <p:cNvGrpSpPr/>
         <p:nvPr/>
       </p:nvGrpSpPr>
-      <p:grpSpPr/>
+      <p:grpSpPr>
+        <a:xfrm>
+          <a:off x="0" y="0"/>
+          <a:ext cx="0" cy="0"/>
+          <a:chOff x="0" y="0"/>
+          <a:chExt cx="0" cy="0"/>
+        </a:xfrm>
+      </p:grpSpPr>
       <p:sp>
         <p:nvSpPr>
           <p:cNvPr id="2" name="Rectangle 1"/>
@@ -3961,6 +4005,7 @@
           <a:lstStyle/>
           <a:p>
             <a:pPr algn="ctr"/>
+            <a:endParaRPr/>
           </a:p>
         </p:txBody>
       </p:sp>
@@ -4006,6 +4051,7 @@
           <a:lstStyle/>
           <a:p>
             <a:pPr algn="ctr"/>
+            <a:endParaRPr/>
           </a:p>
         </p:txBody>
       </p:sp>
@@ -4045,11 +4091,11 @@
           </a:fontRef>
         </p:style>
         <p:txBody>
-          <a:bodyPr rtlCol="0" anchor="ctr" wrap="square"/>
+          <a:bodyPr wrap="square" rtlCol="0" anchor="ctr"/>
           <a:lstStyle/>
           <a:p>
             <a:pPr algn="ctr">
-              <a:defRPr b="1" sz="2200">
+              <a:defRPr sz="2200" b="1">
                 <a:solidFill>
                   <a:srgbClr val="121212"/>
                 </a:solidFill>
@@ -4084,7 +4130,7 @@
           <a:lstStyle/>
           <a:p>
             <a:pPr>
-              <a:defRPr b="1" sz="1400">
+              <a:defRPr sz="1400" b="1">
                 <a:solidFill>
                   <a:srgbClr val="FF6E00"/>
                 </a:solidFill>
@@ -4096,7 +4142,7 @@
           </a:p>
           <a:p>
             <a:pPr>
-              <a:defRPr b="1" sz="2400">
+              <a:defRPr sz="2400" b="1">
                 <a:solidFill>
                   <a:srgbClr val="FFFFFF"/>
                 </a:solidFill>
@@ -4155,8 +4201,18 @@
               </a:defRPr>
             </a:pPr>
             <a:r>
-              <a:t>CoalØmit — REDUCE NOW SUSTAIN FOREVER  |  REDUCE NOW SUSTAIN FOREVER</a:t>
-            </a:r>
+              <a:rPr dirty="0" err="1"/>
+              <a:t>CoalØmit</a:t>
+            </a:r>
+            <a:r>
+              <a:rPr dirty="0"/>
+              <a:t> — REDUCE NOW SUSTAIN </a:t>
+            </a:r>
+            <a:r>
+              <a:rPr dirty="0" smtClean="0"/>
+              <a:t>FOREVER</a:t>
+            </a:r>
+            <a:endParaRPr dirty="0"/>
           </a:p>
         </p:txBody>
       </p:sp>
@@ -4192,7 +4248,7 @@
                     <a:lstStyle/>
                     <a:p>
                       <a:pPr algn="ctr">
-                        <a:defRPr b="1" sz="1200">
+                        <a:defRPr sz="1200" b="1">
                           <a:solidFill>
                             <a:srgbClr val="FF6E00"/>
                           </a:solidFill>
@@ -4215,7 +4271,7 @@
                     <a:lstStyle/>
                     <a:p>
                       <a:pPr algn="ctr">
-                        <a:defRPr b="1" sz="1200">
+                        <a:defRPr sz="1200" b="1">
                           <a:solidFill>
                             <a:srgbClr val="FF6E00"/>
                           </a:solidFill>
@@ -4238,7 +4294,7 @@
                     <a:lstStyle/>
                     <a:p>
                       <a:pPr algn="ctr">
-                        <a:defRPr b="1" sz="1200">
+                        <a:defRPr sz="1200" b="1">
                           <a:solidFill>
                             <a:srgbClr val="FF6E00"/>
                           </a:solidFill>
@@ -4261,7 +4317,7 @@
                     <a:lstStyle/>
                     <a:p>
                       <a:pPr algn="ctr">
-                        <a:defRPr b="1" sz="1200">
+                        <a:defRPr sz="1200" b="1">
                           <a:solidFill>
                             <a:srgbClr val="FF6E00"/>
                           </a:solidFill>
@@ -4284,7 +4340,7 @@
                     <a:lstStyle/>
                     <a:p>
                       <a:pPr algn="ctr">
-                        <a:defRPr b="1" sz="1200">
+                        <a:defRPr sz="1200" b="1">
                           <a:solidFill>
                             <a:srgbClr val="FF6E00"/>
                           </a:solidFill>
@@ -4797,7 +4853,7 @@
           <a:lstStyle/>
           <a:p>
             <a:pPr>
-              <a:defRPr b="1" sz="1800">
+              <a:defRPr sz="1800" b="1">
                 <a:solidFill>
                   <a:srgbClr val="FF6E00"/>
                 </a:solidFill>
@@ -4809,7 +4865,7 @@
           </a:p>
           <a:p>
             <a:pPr>
-              <a:defRPr b="1" sz="1800">
+              <a:defRPr sz="1800" b="1">
                 <a:solidFill>
                   <a:srgbClr val="FF6E00"/>
                 </a:solidFill>
@@ -4826,11 +4882,18 @@
   <p:clrMapOvr>
     <a:masterClrMapping/>
   </p:clrMapOvr>
+  <p:timing>
+    <p:tnLst>
+      <p:par>
+        <p:cTn id="1" dur="indefinite" restart="never" nodeType="tmRoot"/>
+      </p:par>
+    </p:tnLst>
+  </p:timing>
 </p:sld>
 </file>
 
 <file path=ppt/slides/slide12.xml><?xml version="1.0" encoding="utf-8"?>
-<p:sld xmlns:a="http://schemas.openxmlformats.org/drawingml/2006/main" xmlns:p="http://schemas.openxmlformats.org/presentationml/2006/main" xmlns:r="http://schemas.openxmlformats.org/officeDocument/2006/relationships">
+<p:sld xmlns:a="http://schemas.openxmlformats.org/drawingml/2006/main" xmlns:r="http://schemas.openxmlformats.org/officeDocument/2006/relationships" xmlns:p="http://schemas.openxmlformats.org/presentationml/2006/main">
   <p:cSld>
     <p:spTree>
       <p:nvGrpSpPr>
@@ -4838,7 +4901,14 @@
         <p:cNvGrpSpPr/>
         <p:nvPr/>
       </p:nvGrpSpPr>
-      <p:grpSpPr/>
+      <p:grpSpPr>
+        <a:xfrm>
+          <a:off x="0" y="0"/>
+          <a:ext cx="0" cy="0"/>
+          <a:chOff x="0" y="0"/>
+          <a:chExt cx="0" cy="0"/>
+        </a:xfrm>
+      </p:grpSpPr>
       <p:sp>
         <p:nvSpPr>
           <p:cNvPr id="2" name="Rectangle 1"/>
@@ -4879,6 +4949,7 @@
           <a:lstStyle/>
           <a:p>
             <a:pPr algn="ctr"/>
+            <a:endParaRPr/>
           </a:p>
         </p:txBody>
       </p:sp>
@@ -4924,6 +4995,7 @@
           <a:lstStyle/>
           <a:p>
             <a:pPr algn="ctr"/>
+            <a:endParaRPr/>
           </a:p>
         </p:txBody>
       </p:sp>
@@ -4963,11 +5035,11 @@
           </a:fontRef>
         </p:style>
         <p:txBody>
-          <a:bodyPr rtlCol="0" anchor="ctr" wrap="square"/>
+          <a:bodyPr wrap="square" rtlCol="0" anchor="ctr"/>
           <a:lstStyle/>
           <a:p>
             <a:pPr algn="ctr">
-              <a:defRPr b="1" sz="2200">
+              <a:defRPr sz="2200" b="1">
                 <a:solidFill>
                   <a:srgbClr val="121212"/>
                 </a:solidFill>
@@ -5002,7 +5074,7 @@
           <a:lstStyle/>
           <a:p>
             <a:pPr>
-              <a:defRPr b="1" sz="1400">
+              <a:defRPr sz="1400" b="1">
                 <a:solidFill>
                   <a:srgbClr val="FF6E00"/>
                 </a:solidFill>
@@ -5014,7 +5086,7 @@
           </a:p>
           <a:p>
             <a:pPr>
-              <a:defRPr b="1" sz="2400">
+              <a:defRPr sz="2400" b="1">
                 <a:solidFill>
                   <a:srgbClr val="FFFFFF"/>
                 </a:solidFill>
@@ -5073,7 +5145,12 @@
               </a:defRPr>
             </a:pPr>
             <a:r>
-              <a:t>CoalØmit — REDUCE NOW SUSTAIN FOREVER  |  REDUCE NOW SUSTAIN FOREVER</a:t>
+              <a:rPr dirty="0" err="1"/>
+              <a:t>CoalØmit</a:t>
+            </a:r>
+            <a:r>
+              <a:rPr dirty="0"/>
+              <a:t> — REDUCE NOW SUSTAIN FOREVER  </a:t>
             </a:r>
           </a:p>
         </p:txBody>
@@ -5084,7 +5161,13 @@
           <p:cNvGraphicFramePr>
             <a:graphicFrameLocks noGrp="1"/>
           </p:cNvGraphicFramePr>
-          <p:nvPr/>
+          <p:nvPr>
+            <p:extLst>
+              <p:ext uri="{D42A27DB-BD31-4B8C-83A1-F6EECF244321}">
+                <p14:modId xmlns:p14="http://schemas.microsoft.com/office/powerpoint/2010/main" val="4028375311"/>
+              </p:ext>
+            </p:extLst>
+          </p:nvPr>
         </p:nvGraphicFramePr>
         <p:xfrm>
           <a:off x="731520" y="1463040"/>
@@ -5108,13 +5191,14 @@
                     <a:lstStyle/>
                     <a:p>
                       <a:pPr algn="ctr">
-                        <a:defRPr b="1" sz="1300">
+                        <a:defRPr sz="1300" b="1">
                           <a:solidFill>
                             <a:srgbClr val="FF6E00"/>
                           </a:solidFill>
                         </a:defRPr>
                       </a:pPr>
                       <a:r>
+                        <a:rPr sz="3200" dirty="0"/>
                         <a:t>Category</a:t>
                       </a:r>
                     </a:p>
@@ -5131,13 +5215,14 @@
                     <a:lstStyle/>
                     <a:p>
                       <a:pPr algn="ctr">
-                        <a:defRPr b="1" sz="1300">
+                        <a:defRPr sz="1300" b="1">
                           <a:solidFill>
                             <a:srgbClr val="FF6E00"/>
                           </a:solidFill>
                         </a:defRPr>
                       </a:pPr>
                       <a:r>
+                        <a:rPr sz="3200" dirty="0"/>
                         <a:t>Existing Competitors</a:t>
                       </a:r>
                     </a:p>
@@ -5154,14 +5239,19 @@
                     <a:lstStyle/>
                     <a:p>
                       <a:pPr algn="ctr">
-                        <a:defRPr b="1" sz="1300">
+                        <a:defRPr sz="1300" b="1">
                           <a:solidFill>
                             <a:srgbClr val="FF6E00"/>
                           </a:solidFill>
                         </a:defRPr>
                       </a:pPr>
                       <a:r>
-                        <a:t>CoalØmit Advantage</a:t>
+                        <a:rPr sz="3200" dirty="0" err="1"/>
+                        <a:t>CoalØmit</a:t>
+                      </a:r>
+                      <a:r>
+                        <a:rPr sz="3200" dirty="0"/>
+                        <a:t> Advantage</a:t>
                       </a:r>
                     </a:p>
                   </a:txBody>
@@ -5186,12 +5276,54 @@
                         </a:defRPr>
                       </a:pPr>
                       <a:r>
+                        <a:rPr sz="1600" dirty="0">
+                          <a:solidFill>
+                            <a:srgbClr val="EE4A00"/>
+                          </a:solidFill>
+                        </a:rPr>
                         <a:t>General Carbon Calculators</a:t>
                       </a:r>
                     </a:p>
                     <a:p>
                       <a:r>
-                        <a:t>(CodeCarbon, EcoLogITS)</a:t>
+                        <a:rPr sz="1600" dirty="0">
+                          <a:solidFill>
+                            <a:srgbClr val="EE4A00"/>
+                          </a:solidFill>
+                        </a:rPr>
+                        <a:t>(</a:t>
+                      </a:r>
+                      <a:r>
+                        <a:rPr sz="1600" dirty="0" err="1">
+                          <a:solidFill>
+                            <a:srgbClr val="EE4A00"/>
+                          </a:solidFill>
+                        </a:rPr>
+                        <a:t>CodeCarbon</a:t>
+                      </a:r>
+                      <a:r>
+                        <a:rPr sz="1600" dirty="0">
+                          <a:solidFill>
+                            <a:srgbClr val="EE4A00"/>
+                          </a:solidFill>
+                        </a:rPr>
+                        <a:t>, </a:t>
+                      </a:r>
+                      <a:r>
+                        <a:rPr sz="1600" dirty="0" err="1">
+                          <a:solidFill>
+                            <a:srgbClr val="EE4A00"/>
+                          </a:solidFill>
+                        </a:rPr>
+                        <a:t>EcoLogITS</a:t>
+                      </a:r>
+                      <a:r>
+                        <a:rPr sz="1600" dirty="0">
+                          <a:solidFill>
+                            <a:srgbClr val="EE4A00"/>
+                          </a:solidFill>
+                        </a:rPr>
+                        <a:t>)</a:t>
                       </a:r>
                     </a:p>
                   </a:txBody>
@@ -5214,16 +5346,31 @@
                         </a:defRPr>
                       </a:pPr>
                       <a:r>
+                        <a:rPr sz="1600" dirty="0">
+                          <a:solidFill>
+                            <a:srgbClr val="EE4A00"/>
+                          </a:solidFill>
+                        </a:rPr>
                         <a:t>• Pure emissions tracking only</a:t>
                       </a:r>
                     </a:p>
                     <a:p>
                       <a:r>
+                        <a:rPr sz="1600" dirty="0">
+                          <a:solidFill>
+                            <a:srgbClr val="EE4A00"/>
+                          </a:solidFill>
+                        </a:rPr>
                         <a:t>• No model compression capabilities</a:t>
                       </a:r>
                     </a:p>
                     <a:p>
                       <a:r>
+                        <a:rPr sz="1600" dirty="0">
+                          <a:solidFill>
+                            <a:srgbClr val="EE4A00"/>
+                          </a:solidFill>
+                        </a:rPr>
                         <a:t>• Static top-level estimations</a:t>
                       </a:r>
                     </a:p>
@@ -5247,16 +5394,31 @@
                         </a:defRPr>
                       </a:pPr>
                       <a:r>
+                        <a:rPr sz="1600">
+                          <a:solidFill>
+                            <a:srgbClr val="EE4A00"/>
+                          </a:solidFill>
+                        </a:rPr>
                         <a:t>• Combines carbon tracking + quantization</a:t>
                       </a:r>
                     </a:p>
                     <a:p>
                       <a:r>
+                        <a:rPr sz="1600">
+                          <a:solidFill>
+                            <a:srgbClr val="EE4A00"/>
+                          </a:solidFill>
+                        </a:rPr>
                         <a:t>• PyTorch native hardware FLOPs</a:t>
                       </a:r>
                     </a:p>
                     <a:p>
                       <a:r>
+                        <a:rPr sz="1600">
+                          <a:solidFill>
+                            <a:srgbClr val="EE4A00"/>
+                          </a:solidFill>
+                        </a:rPr>
                         <a:t>• Actionable CO₂ reduction engine</a:t>
                       </a:r>
                     </a:p>
@@ -5282,12 +5444,54 @@
                         </a:defRPr>
                       </a:pPr>
                       <a:r>
+                        <a:rPr sz="1600" dirty="0">
+                          <a:solidFill>
+                            <a:srgbClr val="EE4A00"/>
+                          </a:solidFill>
+                        </a:rPr>
                         <a:t>ML Experiment Trackers</a:t>
                       </a:r>
                     </a:p>
                     <a:p>
                       <a:r>
-                        <a:t>(WandB, MLflow)</a:t>
+                        <a:rPr sz="1600" dirty="0">
+                          <a:solidFill>
+                            <a:srgbClr val="EE4A00"/>
+                          </a:solidFill>
+                        </a:rPr>
+                        <a:t>(</a:t>
+                      </a:r>
+                      <a:r>
+                        <a:rPr sz="1600" dirty="0" err="1">
+                          <a:solidFill>
+                            <a:srgbClr val="EE4A00"/>
+                          </a:solidFill>
+                        </a:rPr>
+                        <a:t>WandB</a:t>
+                      </a:r>
+                      <a:r>
+                        <a:rPr sz="1600" dirty="0">
+                          <a:solidFill>
+                            <a:srgbClr val="EE4A00"/>
+                          </a:solidFill>
+                        </a:rPr>
+                        <a:t>, </a:t>
+                      </a:r>
+                      <a:r>
+                        <a:rPr sz="1600" dirty="0" err="1">
+                          <a:solidFill>
+                            <a:srgbClr val="EE4A00"/>
+                          </a:solidFill>
+                        </a:rPr>
+                        <a:t>MLflow</a:t>
+                      </a:r>
+                      <a:r>
+                        <a:rPr sz="1600" dirty="0">
+                          <a:solidFill>
+                            <a:srgbClr val="EE4A00"/>
+                          </a:solidFill>
+                        </a:rPr>
+                        <a:t>)</a:t>
                       </a:r>
                     </a:p>
                   </a:txBody>
@@ -5310,16 +5514,31 @@
                         </a:defRPr>
                       </a:pPr>
                       <a:r>
+                        <a:rPr sz="1600" dirty="0">
+                          <a:solidFill>
+                            <a:srgbClr val="EE4A00"/>
+                          </a:solidFill>
+                        </a:rPr>
                         <a:t>• Focuses on accuracy &amp; training loss</a:t>
                       </a:r>
                     </a:p>
                     <a:p>
                       <a:r>
+                        <a:rPr sz="1600" dirty="0">
+                          <a:solidFill>
+                            <a:srgbClr val="EE4A00"/>
+                          </a:solidFill>
+                        </a:rPr>
                         <a:t>• No built-in carbon grid intensity lookup</a:t>
                       </a:r>
                     </a:p>
                     <a:p>
                       <a:r>
+                        <a:rPr sz="1600" dirty="0">
+                          <a:solidFill>
+                            <a:srgbClr val="EE4A00"/>
+                          </a:solidFill>
+                        </a:rPr>
                         <a:t>• No automated PR carbon comments</a:t>
                       </a:r>
                     </a:p>
@@ -5343,16 +5562,31 @@
                         </a:defRPr>
                       </a:pPr>
                       <a:r>
+                        <a:rPr sz="1600">
+                          <a:solidFill>
+                            <a:srgbClr val="EE4A00"/>
+                          </a:solidFill>
+                        </a:rPr>
                         <a:t>• Dedicated green AI metrics</a:t>
                       </a:r>
                     </a:p>
                     <a:p>
                       <a:r>
+                        <a:rPr sz="1600">
+                          <a:solidFill>
+                            <a:srgbClr val="EE4A00"/>
+                          </a:solidFill>
+                        </a:rPr>
                         <a:t>• Automated GitHub Action PR bot</a:t>
                       </a:r>
                     </a:p>
                     <a:p>
                       <a:r>
+                        <a:rPr sz="1600">
+                          <a:solidFill>
+                            <a:srgbClr val="EE4A00"/>
+                          </a:solidFill>
+                        </a:rPr>
                         <a:t>• Pareto trade-off matrix per model</a:t>
                       </a:r>
                     </a:p>
@@ -5378,12 +5612,54 @@
                         </a:defRPr>
                       </a:pPr>
                       <a:r>
+                        <a:rPr sz="1600" dirty="0">
+                          <a:solidFill>
+                            <a:srgbClr val="EE4A00"/>
+                          </a:solidFill>
+                        </a:rPr>
                         <a:t>Enterprise ESG Platforms</a:t>
                       </a:r>
                     </a:p>
                     <a:p>
                       <a:r>
-                        <a:t>(Perspectium, Salesforce Net Zero)</a:t>
+                        <a:rPr sz="1600" dirty="0">
+                          <a:solidFill>
+                            <a:srgbClr val="EE4A00"/>
+                          </a:solidFill>
+                        </a:rPr>
+                        <a:t>(</a:t>
+                      </a:r>
+                      <a:r>
+                        <a:rPr sz="1600" dirty="0" err="1">
+                          <a:solidFill>
+                            <a:srgbClr val="EE4A00"/>
+                          </a:solidFill>
+                        </a:rPr>
+                        <a:t>Perspectium</a:t>
+                      </a:r>
+                      <a:r>
+                        <a:rPr sz="1600" dirty="0">
+                          <a:solidFill>
+                            <a:srgbClr val="EE4A00"/>
+                          </a:solidFill>
+                        </a:rPr>
+                        <a:t>, </a:t>
+                      </a:r>
+                      <a:r>
+                        <a:rPr sz="1600" dirty="0" err="1">
+                          <a:solidFill>
+                            <a:srgbClr val="EE4A00"/>
+                          </a:solidFill>
+                        </a:rPr>
+                        <a:t>Salesforce</a:t>
+                      </a:r>
+                      <a:r>
+                        <a:rPr sz="1600" dirty="0">
+                          <a:solidFill>
+                            <a:srgbClr val="EE4A00"/>
+                          </a:solidFill>
+                        </a:rPr>
+                        <a:t> Net Zero)</a:t>
                       </a:r>
                     </a:p>
                   </a:txBody>
@@ -5406,16 +5682,31 @@
                         </a:defRPr>
                       </a:pPr>
                       <a:r>
+                        <a:rPr sz="1600" dirty="0">
+                          <a:solidFill>
+                            <a:srgbClr val="EE4A00"/>
+                          </a:solidFill>
+                        </a:rPr>
                         <a:t>• Top-down annual estimates</a:t>
                       </a:r>
                     </a:p>
                     <a:p>
                       <a:r>
+                        <a:rPr sz="1600" dirty="0">
+                          <a:solidFill>
+                            <a:srgbClr val="EE4A00"/>
+                          </a:solidFill>
+                        </a:rPr>
                         <a:t>• No ML engineering visibility</a:t>
                       </a:r>
                     </a:p>
                     <a:p>
                       <a:r>
+                        <a:rPr sz="1600" dirty="0">
+                          <a:solidFill>
+                            <a:srgbClr val="EE4A00"/>
+                          </a:solidFill>
+                        </a:rPr>
                         <a:t>• High annual consulting costs</a:t>
                       </a:r>
                     </a:p>
@@ -5439,16 +5730,31 @@
                         </a:defRPr>
                       </a:pPr>
                       <a:r>
+                        <a:rPr sz="1600" dirty="0">
+                          <a:solidFill>
+                            <a:srgbClr val="EE4A00"/>
+                          </a:solidFill>
+                        </a:rPr>
                         <a:t>• Bottom-up engineering telemetry</a:t>
                       </a:r>
                     </a:p>
                     <a:p>
                       <a:r>
+                        <a:rPr sz="1600" dirty="0">
+                          <a:solidFill>
+                            <a:srgbClr val="EE4A00"/>
+                          </a:solidFill>
+                        </a:rPr>
                         <a:t>• Instant API exports for EU CSRD</a:t>
                       </a:r>
                     </a:p>
                     <a:p>
                       <a:r>
+                        <a:rPr sz="1600" dirty="0">
+                          <a:solidFill>
+                            <a:srgbClr val="EE4A00"/>
+                          </a:solidFill>
+                        </a:rPr>
                         <a:t>• Developer-native workflow integration</a:t>
                       </a:r>
                     </a:p>
@@ -5469,11 +5775,18 @@
   <p:clrMapOvr>
     <a:masterClrMapping/>
   </p:clrMapOvr>
+  <p:timing>
+    <p:tnLst>
+      <p:par>
+        <p:cTn id="1" dur="indefinite" restart="never" nodeType="tmRoot"/>
+      </p:par>
+    </p:tnLst>
+  </p:timing>
 </p:sld>
 </file>
 
 <file path=ppt/slides/slide13.xml><?xml version="1.0" encoding="utf-8"?>
-<p:sld xmlns:a="http://schemas.openxmlformats.org/drawingml/2006/main" xmlns:p="http://schemas.openxmlformats.org/presentationml/2006/main" xmlns:r="http://schemas.openxmlformats.org/officeDocument/2006/relationships">
+<p:sld xmlns:a="http://schemas.openxmlformats.org/drawingml/2006/main" xmlns:r="http://schemas.openxmlformats.org/officeDocument/2006/relationships" xmlns:p="http://schemas.openxmlformats.org/presentationml/2006/main">
   <p:cSld>
     <p:spTree>
       <p:nvGrpSpPr>
@@ -5481,7 +5794,14 @@
         <p:cNvGrpSpPr/>
         <p:nvPr/>
       </p:nvGrpSpPr>
-      <p:grpSpPr/>
+      <p:grpSpPr>
+        <a:xfrm>
+          <a:off x="0" y="0"/>
+          <a:ext cx="0" cy="0"/>
+          <a:chOff x="0" y="0"/>
+          <a:chExt cx="0" cy="0"/>
+        </a:xfrm>
+      </p:grpSpPr>
       <p:sp>
         <p:nvSpPr>
           <p:cNvPr id="2" name="Rectangle 1"/>
@@ -5490,7 +5810,7 @@
         </p:nvSpPr>
         <p:spPr>
           <a:xfrm>
-            <a:off x="0" y="0"/>
+            <a:off x="0" y="14288"/>
             <a:ext cx="12191695" cy="6858000"/>
           </a:xfrm>
           <a:prstGeom prst="rect">
@@ -5522,6 +5842,7 @@
           <a:lstStyle/>
           <a:p>
             <a:pPr algn="ctr"/>
+            <a:endParaRPr/>
           </a:p>
         </p:txBody>
       </p:sp>
@@ -5567,6 +5888,7 @@
           <a:lstStyle/>
           <a:p>
             <a:pPr algn="ctr"/>
+            <a:endParaRPr/>
           </a:p>
         </p:txBody>
       </p:sp>
@@ -5606,11 +5928,11 @@
           </a:fontRef>
         </p:style>
         <p:txBody>
-          <a:bodyPr rtlCol="0" anchor="ctr" wrap="square"/>
+          <a:bodyPr wrap="square" rtlCol="0" anchor="ctr"/>
           <a:lstStyle/>
           <a:p>
             <a:pPr algn="ctr">
-              <a:defRPr b="1" sz="2200">
+              <a:defRPr sz="2200" b="1">
                 <a:solidFill>
                   <a:srgbClr val="121212"/>
                 </a:solidFill>
@@ -5645,7 +5967,7 @@
           <a:lstStyle/>
           <a:p>
             <a:pPr>
-              <a:defRPr b="1" sz="1400">
+              <a:defRPr sz="1400" b="1">
                 <a:solidFill>
                   <a:srgbClr val="FF6E00"/>
                 </a:solidFill>
@@ -5657,7 +5979,7 @@
           </a:p>
           <a:p>
             <a:pPr>
-              <a:defRPr b="1" sz="2400">
+              <a:defRPr sz="2400" b="1">
                 <a:solidFill>
                   <a:srgbClr val="FFFFFF"/>
                 </a:solidFill>
@@ -5677,8 +5999,8 @@
         </p:nvSpPr>
         <p:spPr>
           <a:xfrm>
-            <a:off x="0" y="6492240"/>
-            <a:ext cx="12191695" cy="365760"/>
+            <a:off x="9055511" y="465219"/>
+            <a:ext cx="2900208" cy="365760"/>
           </a:xfrm>
           <a:prstGeom prst="rect">
             <a:avLst/>
@@ -5716,7 +6038,12 @@
               </a:defRPr>
             </a:pPr>
             <a:r>
-              <a:t>CoalØmit — REDUCE NOW SUSTAIN FOREVER  |  REDUCE NOW SUSTAIN FOREVER</a:t>
+              <a:rPr dirty="0" err="1"/>
+              <a:t>CoalØmit</a:t>
+            </a:r>
+            <a:r>
+              <a:rPr dirty="0"/>
+              <a:t> — REDUCE NOW SUSTAIN FOREVER  </a:t>
             </a:r>
           </a:p>
         </p:txBody>
@@ -5727,11 +6054,17 @@
           <p:cNvGraphicFramePr>
             <a:graphicFrameLocks noGrp="1"/>
           </p:cNvGraphicFramePr>
-          <p:nvPr/>
+          <p:nvPr>
+            <p:extLst>
+              <p:ext uri="{D42A27DB-BD31-4B8C-83A1-F6EECF244321}">
+                <p14:modId xmlns:p14="http://schemas.microsoft.com/office/powerpoint/2010/main" val="3278065211"/>
+              </p:ext>
+            </p:extLst>
+          </p:nvPr>
         </p:nvGraphicFramePr>
         <p:xfrm>
-          <a:off x="731520" y="1463040"/>
-          <a:ext cx="10728655" cy="4389120"/>
+          <a:off x="731519" y="1212913"/>
+          <a:ext cx="10728655" cy="5510784"/>
         </p:xfrm>
         <a:graphic>
           <a:graphicData uri="http://schemas.openxmlformats.org/drawingml/2006/table">
@@ -5751,13 +6084,14 @@
                     <a:lstStyle/>
                     <a:p>
                       <a:pPr algn="ctr">
-                        <a:defRPr b="1" sz="1300">
+                        <a:defRPr sz="1300" b="1">
                           <a:solidFill>
                             <a:srgbClr val="FF6E00"/>
                           </a:solidFill>
                         </a:defRPr>
                       </a:pPr>
                       <a:r>
+                        <a:rPr sz="2800" dirty="0"/>
                         <a:t>Timeline</a:t>
                       </a:r>
                     </a:p>
@@ -5774,13 +6108,14 @@
                     <a:lstStyle/>
                     <a:p>
                       <a:pPr algn="ctr">
-                        <a:defRPr b="1" sz="1300">
+                        <a:defRPr sz="1300" b="1">
                           <a:solidFill>
                             <a:srgbClr val="FF6E00"/>
                           </a:solidFill>
                         </a:defRPr>
                       </a:pPr>
                       <a:r>
+                        <a:rPr sz="2800" dirty="0"/>
                         <a:t>Product Milestones</a:t>
                       </a:r>
                     </a:p>
@@ -5797,13 +6132,14 @@
                     <a:lstStyle/>
                     <a:p>
                       <a:pPr algn="ctr">
-                        <a:defRPr b="1" sz="1300">
+                        <a:defRPr sz="1300" b="1">
                           <a:solidFill>
                             <a:srgbClr val="FF6E00"/>
                           </a:solidFill>
                         </a:defRPr>
                       </a:pPr>
                       <a:r>
+                        <a:rPr sz="2800" dirty="0"/>
                         <a:t>Business Milestones</a:t>
                       </a:r>
                     </a:p>
@@ -5829,6 +6165,11 @@
                         </a:defRPr>
                       </a:pPr>
                       <a:r>
+                        <a:rPr dirty="0">
+                          <a:solidFill>
+                            <a:schemeClr val="bg1"/>
+                          </a:solidFill>
+                        </a:rPr>
                         <a:t>Q1 2026</a:t>
                       </a:r>
                     </a:p>
@@ -5852,17 +6193,80 @@
                         </a:defRPr>
                       </a:pPr>
                       <a:r>
-                        <a:t>• Launch `cac-core` PyTorch FLOP counter</a:t>
+                        <a:rPr sz="1600" dirty="0">
+                          <a:solidFill>
+                            <a:schemeClr val="bg1"/>
+                          </a:solidFill>
+                        </a:rPr>
+                        <a:t>• Launch `</a:t>
+                      </a:r>
+                      <a:r>
+                        <a:rPr sz="1600" dirty="0" err="1">
+                          <a:solidFill>
+                            <a:schemeClr val="bg1"/>
+                          </a:solidFill>
+                        </a:rPr>
+                        <a:t>cac</a:t>
+                      </a:r>
+                      <a:r>
+                        <a:rPr sz="1600" dirty="0">
+                          <a:solidFill>
+                            <a:schemeClr val="bg1"/>
+                          </a:solidFill>
+                        </a:rPr>
+                        <a:t>-core` </a:t>
+                      </a:r>
+                      <a:r>
+                        <a:rPr sz="1600" dirty="0" err="1">
+                          <a:solidFill>
+                            <a:schemeClr val="bg1"/>
+                          </a:solidFill>
+                        </a:rPr>
+                        <a:t>PyTorch</a:t>
+                      </a:r>
+                      <a:r>
+                        <a:rPr sz="1600" dirty="0">
+                          <a:solidFill>
+                            <a:schemeClr val="bg1"/>
+                          </a:solidFill>
+                        </a:rPr>
+                        <a:t> FLOP counter</a:t>
                       </a:r>
                     </a:p>
                     <a:p>
                       <a:r>
+                        <a:rPr dirty="0">
+                          <a:solidFill>
+                            <a:schemeClr val="bg1"/>
+                          </a:solidFill>
+                        </a:rPr>
                         <a:t>• Map 35+ country power grid intensity datasets</a:t>
                       </a:r>
                     </a:p>
                     <a:p>
                       <a:r>
-                        <a:t>• Build `cac-cli` rich terminal table output</a:t>
+                        <a:rPr dirty="0">
+                          <a:solidFill>
+                            <a:schemeClr val="bg1"/>
+                          </a:solidFill>
+                        </a:rPr>
+                        <a:t>• Build `</a:t>
+                      </a:r>
+                      <a:r>
+                        <a:rPr dirty="0" err="1">
+                          <a:solidFill>
+                            <a:schemeClr val="bg1"/>
+                          </a:solidFill>
+                        </a:rPr>
+                        <a:t>cac</a:t>
+                      </a:r>
+                      <a:r>
+                        <a:rPr dirty="0">
+                          <a:solidFill>
+                            <a:schemeClr val="bg1"/>
+                          </a:solidFill>
+                        </a:rPr>
+                        <a:t>-cli` rich terminal table output</a:t>
                       </a:r>
                     </a:p>
                   </a:txBody>
@@ -5885,11 +6289,21 @@
                         </a:defRPr>
                       </a:pPr>
                       <a:r>
+                        <a:rPr sz="1600" dirty="0">
+                          <a:solidFill>
+                            <a:schemeClr val="bg1"/>
+                          </a:solidFill>
+                        </a:rPr>
                         <a:t>• Launch Apache 2.0 Open-Source repository</a:t>
                       </a:r>
                     </a:p>
                     <a:p>
                       <a:r>
+                        <a:rPr dirty="0">
+                          <a:solidFill>
+                            <a:schemeClr val="bg1"/>
+                          </a:solidFill>
+                        </a:rPr>
                         <a:t>• Build developer community &amp; initial contributors</a:t>
                       </a:r>
                     </a:p>
@@ -5915,6 +6329,11 @@
                         </a:defRPr>
                       </a:pPr>
                       <a:r>
+                        <a:rPr dirty="0">
+                          <a:solidFill>
+                            <a:schemeClr val="bg1"/>
+                          </a:solidFill>
+                        </a:rPr>
                         <a:t>Q2 2026</a:t>
                       </a:r>
                     </a:p>
@@ -5938,16 +6357,63 @@
                         </a:defRPr>
                       </a:pPr>
                       <a:r>
-                        <a:t>• Release `cac-action` GitHub Action PR bot</a:t>
+                        <a:rPr sz="1600" dirty="0">
+                          <a:solidFill>
+                            <a:schemeClr val="bg1"/>
+                          </a:solidFill>
+                        </a:rPr>
+                        <a:t>• Release `</a:t>
+                      </a:r>
+                      <a:r>
+                        <a:rPr sz="1600" dirty="0" err="1">
+                          <a:solidFill>
+                            <a:schemeClr val="bg1"/>
+                          </a:solidFill>
+                        </a:rPr>
+                        <a:t>cac</a:t>
+                      </a:r>
+                      <a:r>
+                        <a:rPr sz="1600" dirty="0">
+                          <a:solidFill>
+                            <a:schemeClr val="bg1"/>
+                          </a:solidFill>
+                        </a:rPr>
+                        <a:t>-action` </a:t>
+                      </a:r>
+                      <a:r>
+                        <a:rPr sz="1600" dirty="0" err="1">
+                          <a:solidFill>
+                            <a:schemeClr val="bg1"/>
+                          </a:solidFill>
+                        </a:rPr>
+                        <a:t>GitHub</a:t>
+                      </a:r>
+                      <a:r>
+                        <a:rPr sz="1600" dirty="0">
+                          <a:solidFill>
+                            <a:schemeClr val="bg1"/>
+                          </a:solidFill>
+                        </a:rPr>
+                        <a:t> Action PR bot</a:t>
                       </a:r>
                     </a:p>
                     <a:p>
                       <a:r>
+                        <a:rPr dirty="0">
+                          <a:solidFill>
+                            <a:schemeClr val="bg1"/>
+                          </a:solidFill>
+                        </a:rPr>
                         <a:t>• Support INT8 Dynamic &amp; INT4 Weight-Only</a:t>
                       </a:r>
                     </a:p>
                     <a:p>
                       <a:r>
+                        <a:rPr dirty="0">
+                          <a:solidFill>
+                            <a:schemeClr val="bg1"/>
+                          </a:solidFill>
+                        </a:rPr>
                         <a:t>• Add Markdown &amp; JSON report export formats</a:t>
                       </a:r>
                     </a:p>
@@ -5971,11 +6437,21 @@
                         </a:defRPr>
                       </a:pPr>
                       <a:r>
+                        <a:rPr sz="1600" dirty="0">
+                          <a:solidFill>
+                            <a:schemeClr val="bg1"/>
+                          </a:solidFill>
+                        </a:rPr>
                         <a:t>• Onboard top 20 open-source ML repositories</a:t>
                       </a:r>
                     </a:p>
                     <a:p>
                       <a:r>
+                        <a:rPr dirty="0">
+                          <a:solidFill>
+                            <a:schemeClr val="bg1"/>
+                          </a:solidFill>
+                        </a:rPr>
                         <a:t>• Initiate Enterprise Beta partner program</a:t>
                       </a:r>
                     </a:p>
@@ -6001,6 +6477,11 @@
                         </a:defRPr>
                       </a:pPr>
                       <a:r>
+                        <a:rPr>
+                          <a:solidFill>
+                            <a:schemeClr val="bg1"/>
+                          </a:solidFill>
+                        </a:rPr>
                         <a:t>Q3 2026</a:t>
                       </a:r>
                     </a:p>
@@ -6024,16 +6505,31 @@
                         </a:defRPr>
                       </a:pPr>
                       <a:r>
+                        <a:rPr sz="1600" dirty="0">
+                          <a:solidFill>
+                            <a:schemeClr val="bg1"/>
+                          </a:solidFill>
+                        </a:rPr>
                         <a:t>• Launch Cloud Hosted API for telemetry</a:t>
                       </a:r>
                     </a:p>
                     <a:p>
                       <a:r>
+                        <a:rPr dirty="0">
+                          <a:solidFill>
+                            <a:schemeClr val="bg1"/>
+                          </a:solidFill>
+                        </a:rPr>
                         <a:t>• Add live Electricity Maps API fallback</a:t>
                       </a:r>
                     </a:p>
                     <a:p>
                       <a:r>
+                        <a:rPr dirty="0">
+                          <a:solidFill>
+                            <a:schemeClr val="bg1"/>
+                          </a:solidFill>
+                        </a:rPr>
                         <a:t>• Develop EU CSRD compliance export module</a:t>
                       </a:r>
                     </a:p>
@@ -6057,11 +6553,37 @@
                         </a:defRPr>
                       </a:pPr>
                       <a:r>
-                        <a:t>• Launch Enterprise Paid Tier ($/node/mo)</a:t>
+                        <a:rPr sz="1600" dirty="0">
+                          <a:solidFill>
+                            <a:schemeClr val="bg1"/>
+                          </a:solidFill>
+                        </a:rPr>
+                        <a:t>• Launch Enterprise Paid Tier ($/node/</a:t>
+                      </a:r>
+                      <a:r>
+                        <a:rPr sz="1600" dirty="0" err="1">
+                          <a:solidFill>
+                            <a:schemeClr val="bg1"/>
+                          </a:solidFill>
+                        </a:rPr>
+                        <a:t>mo</a:t>
+                      </a:r>
+                      <a:r>
+                        <a:rPr sz="1600" dirty="0">
+                          <a:solidFill>
+                            <a:schemeClr val="bg1"/>
+                          </a:solidFill>
+                        </a:rPr>
+                        <a:t>)</a:t>
                       </a:r>
                     </a:p>
                     <a:p>
                       <a:r>
+                        <a:rPr dirty="0">
+                          <a:solidFill>
+                            <a:schemeClr val="bg1"/>
+                          </a:solidFill>
+                        </a:rPr>
                         <a:t>• Establish sales pipeline in EU &amp; North America</a:t>
                       </a:r>
                     </a:p>
@@ -6087,6 +6609,11 @@
                         </a:defRPr>
                       </a:pPr>
                       <a:r>
+                        <a:rPr>
+                          <a:solidFill>
+                            <a:schemeClr val="bg1"/>
+                          </a:solidFill>
+                        </a:rPr>
                         <a:t>Q4 2026</a:t>
                       </a:r>
                     </a:p>
@@ -6110,17 +6637,48 @@
                         </a:defRPr>
                       </a:pPr>
                       <a:r>
+                        <a:rPr sz="1600" dirty="0">
+                          <a:solidFill>
+                            <a:schemeClr val="bg1"/>
+                          </a:solidFill>
+                        </a:rPr>
                         <a:t>• Auto-Quantization Engine for LLMs</a:t>
                       </a:r>
                     </a:p>
                     <a:p>
                       <a:r>
+                        <a:rPr dirty="0">
+                          <a:solidFill>
+                            <a:schemeClr val="bg1"/>
+                          </a:solidFill>
+                        </a:rPr>
                         <a:t>• Multi-cloud cluster energy monitoring (AWS/GCP)</a:t>
                       </a:r>
                     </a:p>
                     <a:p>
                       <a:r>
-                        <a:t>• Real-time cloud cost vs CO₂ optimization</a:t>
+                        <a:rPr dirty="0">
+                          <a:solidFill>
+                            <a:schemeClr val="bg1"/>
+                          </a:solidFill>
+                        </a:rPr>
+                        <a:t>• Real-time cloud cost </a:t>
+                      </a:r>
+                      <a:r>
+                        <a:rPr dirty="0" err="1">
+                          <a:solidFill>
+                            <a:schemeClr val="bg1"/>
+                          </a:solidFill>
+                        </a:rPr>
+                        <a:t>vs</a:t>
+                      </a:r>
+                      <a:r>
+                        <a:rPr dirty="0">
+                          <a:solidFill>
+                            <a:schemeClr val="bg1"/>
+                          </a:solidFill>
+                        </a:rPr>
+                        <a:t> CO₂ optimization</a:t>
                       </a:r>
                     </a:p>
                   </a:txBody>
@@ -6143,11 +6701,21 @@
                         </a:defRPr>
                       </a:pPr>
                       <a:r>
+                        <a:rPr sz="1600" dirty="0">
+                          <a:solidFill>
+                            <a:schemeClr val="bg1"/>
+                          </a:solidFill>
+                        </a:rPr>
                         <a:t>• Scale to 100+ paying enterprise ML teams</a:t>
                       </a:r>
                     </a:p>
                     <a:p>
                       <a:r>
+                        <a:rPr dirty="0">
+                          <a:solidFill>
+                            <a:schemeClr val="bg1"/>
+                          </a:solidFill>
+                        </a:rPr>
                         <a:t>• Expand team in AI engineering &amp; ESG sales</a:t>
                       </a:r>
                     </a:p>
@@ -6168,11 +6736,18 @@
   <p:clrMapOvr>
     <a:masterClrMapping/>
   </p:clrMapOvr>
+  <p:timing>
+    <p:tnLst>
+      <p:par>
+        <p:cTn id="1" dur="indefinite" restart="never" nodeType="tmRoot"/>
+      </p:par>
+    </p:tnLst>
+  </p:timing>
 </p:sld>
 </file>
 
 <file path=ppt/slides/slide2.xml><?xml version="1.0" encoding="utf-8"?>
-<p:sld xmlns:a="http://schemas.openxmlformats.org/drawingml/2006/main" xmlns:p="http://schemas.openxmlformats.org/presentationml/2006/main" xmlns:r="http://schemas.openxmlformats.org/officeDocument/2006/relationships">
+<p:sld xmlns:a="http://schemas.openxmlformats.org/drawingml/2006/main" xmlns:r="http://schemas.openxmlformats.org/officeDocument/2006/relationships" xmlns:p="http://schemas.openxmlformats.org/presentationml/2006/main">
   <p:cSld>
     <p:spTree>
       <p:nvGrpSpPr>
@@ -6180,7 +6755,14 @@
         <p:cNvGrpSpPr/>
         <p:nvPr/>
       </p:nvGrpSpPr>
-      <p:grpSpPr/>
+      <p:grpSpPr>
+        <a:xfrm>
+          <a:off x="0" y="0"/>
+          <a:ext cx="0" cy="0"/>
+          <a:chOff x="0" y="0"/>
+          <a:chExt cx="0" cy="0"/>
+        </a:xfrm>
+      </p:grpSpPr>
       <p:sp>
         <p:nvSpPr>
           <p:cNvPr id="2" name="Rectangle 1"/>
@@ -6189,7 +6771,7 @@
         </p:nvSpPr>
         <p:spPr>
           <a:xfrm>
-            <a:off x="0" y="0"/>
+            <a:off x="-71438" y="14287"/>
             <a:ext cx="12191695" cy="6858000"/>
           </a:xfrm>
           <a:prstGeom prst="rect">
@@ -6221,6 +6803,7 @@
           <a:lstStyle/>
           <a:p>
             <a:pPr algn="ctr"/>
+            <a:endParaRPr/>
           </a:p>
         </p:txBody>
       </p:sp>
@@ -6266,6 +6849,7 @@
           <a:lstStyle/>
           <a:p>
             <a:pPr algn="ctr"/>
+            <a:endParaRPr/>
           </a:p>
         </p:txBody>
       </p:sp>
@@ -6305,11 +6889,11 @@
           </a:fontRef>
         </p:style>
         <p:txBody>
-          <a:bodyPr rtlCol="0" anchor="ctr" wrap="square"/>
+          <a:bodyPr wrap="square" rtlCol="0" anchor="ctr"/>
           <a:lstStyle/>
           <a:p>
             <a:pPr algn="ctr">
-              <a:defRPr b="1" sz="2200">
+              <a:defRPr sz="2200" b="1">
                 <a:solidFill>
                   <a:srgbClr val="121212"/>
                 </a:solidFill>
@@ -6344,7 +6928,7 @@
           <a:lstStyle/>
           <a:p>
             <a:pPr>
-              <a:defRPr b="1" sz="1400">
+              <a:defRPr sz="1400" b="1">
                 <a:solidFill>
                   <a:srgbClr val="FF6E00"/>
                 </a:solidFill>
@@ -6356,7 +6940,7 @@
           </a:p>
           <a:p>
             <a:pPr>
-              <a:defRPr b="1" sz="2400">
+              <a:defRPr sz="2400" b="1">
                 <a:solidFill>
                   <a:srgbClr val="FFFFFF"/>
                 </a:solidFill>
@@ -6415,8 +6999,18 @@
               </a:defRPr>
             </a:pPr>
             <a:r>
-              <a:t>CoalØmit — REDUCE NOW SUSTAIN FOREVER  |  REDUCE NOW SUSTAIN FOREVER</a:t>
-            </a:r>
+              <a:rPr dirty="0" err="1"/>
+              <a:t>CoalØmit</a:t>
+            </a:r>
+            <a:r>
+              <a:rPr dirty="0"/>
+              <a:t> — REDUCE NOW SUSTAIN </a:t>
+            </a:r>
+            <a:r>
+              <a:rPr dirty="0" smtClean="0"/>
+              <a:t>FOREVER</a:t>
+            </a:r>
+            <a:endParaRPr dirty="0"/>
           </a:p>
         </p:txBody>
       </p:sp>
@@ -6428,8 +7022,8 @@
         </p:nvSpPr>
         <p:spPr>
           <a:xfrm>
-            <a:off x="1371600" y="1463040"/>
-            <a:ext cx="4389120" cy="2103120"/>
+            <a:off x="1557340" y="1463040"/>
+            <a:ext cx="3643310" cy="2103120"/>
           </a:xfrm>
           <a:prstGeom prst="roundRect">
             <a:avLst/>
@@ -6482,8 +7076,8 @@
         </p:nvSpPr>
         <p:spPr>
           <a:xfrm>
-            <a:off x="1371600" y="3657600"/>
-            <a:ext cx="4389120" cy="2468880"/>
+            <a:off x="1184435" y="4968205"/>
+            <a:ext cx="4389120" cy="969496"/>
           </a:xfrm>
           <a:prstGeom prst="rect">
             <a:avLst/>
@@ -6497,42 +7091,84 @@
           <a:lstStyle/>
           <a:p>
             <a:pPr>
-              <a:defRPr b="1" sz="1800">
+              <a:defRPr sz="1800" b="1">
                 <a:solidFill>
                   <a:srgbClr val="FFFFFF"/>
                 </a:solidFill>
               </a:defRPr>
             </a:pPr>
             <a:r>
-              <a:t>Founder 1 Name</a:t>
-            </a:r>
+              <a:rPr lang="en-US" dirty="0" err="1" smtClean="0"/>
+              <a:t>Aayushi</a:t>
+            </a:r>
+            <a:r>
+              <a:rPr lang="en-US" dirty="0" smtClean="0"/>
+              <a:t> </a:t>
+            </a:r>
+            <a:r>
+              <a:rPr lang="en-US" dirty="0" err="1" smtClean="0"/>
+              <a:t>Agarwal</a:t>
+            </a:r>
+            <a:endParaRPr dirty="0"/>
           </a:p>
           <a:p>
             <a:pPr>
-              <a:defRPr b="1" sz="1300">
+              <a:defRPr sz="1300" b="1">
                 <a:solidFill>
                   <a:srgbClr val="FF6E00"/>
                 </a:solidFill>
               </a:defRPr>
             </a:pPr>
             <a:r>
-              <a:t>Co-Founder &amp; Lead Engineer</a:t>
-            </a:r>
+              <a:rPr dirty="0" smtClean="0"/>
+              <a:t>Founder</a:t>
+            </a:r>
+            <a:endParaRPr lang="en-US" dirty="0" smtClean="0"/>
           </a:p>
           <a:p>
             <a:pPr>
-              <a:defRPr sz="1200">
-                <a:solidFill>
-                  <a:srgbClr val="E5E5E5"/>
-                </a:solidFill>
-              </a:defRPr>
-            </a:pPr>
-            <a:r>
-              <a:t>• Undergraduate Student Engineer</a:t>
-            </a:r>
-            <a:br/>
-            <a:r>
-              <a:t>• Core Architecture &amp; AI Tooling Lead</a:t>
+              <a:defRPr sz="1300" b="1">
+                <a:solidFill>
+                  <a:srgbClr val="FF6E00"/>
+                </a:solidFill>
+              </a:defRPr>
+            </a:pPr>
+            <a:r>
+              <a:rPr dirty="0" smtClean="0"/>
+              <a:t>• </a:t>
+            </a:r>
+            <a:r>
+              <a:rPr lang="en-US" dirty="0"/>
+              <a:t>M</a:t>
+            </a:r>
+            <a:r>
+              <a:rPr lang="en-US" dirty="0" smtClean="0"/>
+              <a:t>echanical and mechatronics Engineering undergrad </a:t>
+            </a:r>
+          </a:p>
+          <a:p>
+            <a:pPr>
+              <a:defRPr sz="1300" b="1">
+                <a:solidFill>
+                  <a:srgbClr val="FF6E00"/>
+                </a:solidFill>
+              </a:defRPr>
+            </a:pPr>
+            <a:r>
+              <a:rPr dirty="0" smtClean="0"/>
+              <a:t>• </a:t>
+            </a:r>
+            <a:r>
+              <a:rPr lang="en-US" dirty="0" smtClean="0"/>
+              <a:t>Chief core </a:t>
+            </a:r>
+            <a:r>
+              <a:rPr dirty="0" smtClean="0"/>
+              <a:t>Architect </a:t>
+            </a:r>
+            <a:r>
+              <a:rPr dirty="0"/>
+              <a:t>&amp; AI Tooling Lead</a:t>
             </a:r>
           </a:p>
         </p:txBody>
@@ -6545,8 +7181,8 @@
         </p:nvSpPr>
         <p:spPr>
           <a:xfrm>
-            <a:off x="6400800" y="1463040"/>
-            <a:ext cx="4389120" cy="2103120"/>
+            <a:off x="6586537" y="1524478"/>
+            <a:ext cx="3686175" cy="2041682"/>
           </a:xfrm>
           <a:prstGeom prst="roundRect">
             <a:avLst/>
@@ -6586,6 +7222,7 @@
               </a:defRPr>
             </a:pPr>
             <a:r>
+              <a:rPr dirty="0"/>
               <a:t>[ Insert Founder 2 Photo ]</a:t>
             </a:r>
           </a:p>
@@ -6599,8 +7236,8 @@
         </p:nvSpPr>
         <p:spPr>
           <a:xfrm>
-            <a:off x="6400800" y="3657600"/>
-            <a:ext cx="4389120" cy="2468880"/>
+            <a:off x="6586537" y="4968205"/>
+            <a:ext cx="4389120" cy="969496"/>
           </a:xfrm>
           <a:prstGeom prst="rect">
             <a:avLst/>
@@ -6614,56 +7251,178 @@
           <a:lstStyle/>
           <a:p>
             <a:pPr>
-              <a:defRPr b="1" sz="1800">
+              <a:defRPr sz="1800" b="1">
                 <a:solidFill>
                   <a:srgbClr val="FFFFFF"/>
                 </a:solidFill>
               </a:defRPr>
             </a:pPr>
             <a:r>
-              <a:t>Founder 2 Name</a:t>
-            </a:r>
+              <a:rPr lang="en-US" dirty="0" err="1" smtClean="0"/>
+              <a:t>Piyush</a:t>
+            </a:r>
+            <a:r>
+              <a:rPr lang="en-US" dirty="0" smtClean="0"/>
+              <a:t> </a:t>
+            </a:r>
+            <a:r>
+              <a:rPr lang="en-US" dirty="0" err="1" smtClean="0"/>
+              <a:t>Soni</a:t>
+            </a:r>
+            <a:endParaRPr dirty="0"/>
           </a:p>
           <a:p>
             <a:pPr>
-              <a:defRPr b="1" sz="1300">
+              <a:defRPr sz="1300" b="1">
                 <a:solidFill>
                   <a:srgbClr val="FF6E00"/>
                 </a:solidFill>
               </a:defRPr>
             </a:pPr>
             <a:r>
-              <a:t>Co-Founder &amp; Systems Lead</a:t>
-            </a:r>
+              <a:rPr dirty="0" smtClean="0"/>
+              <a:t>Co-Founder</a:t>
+            </a:r>
+            <a:endParaRPr lang="en-US" dirty="0" smtClean="0"/>
           </a:p>
           <a:p>
             <a:pPr>
-              <a:defRPr sz="1200">
-                <a:solidFill>
-                  <a:srgbClr val="E5E5E5"/>
-                </a:solidFill>
-              </a:defRPr>
-            </a:pPr>
-            <a:r>
-              <a:t>• Undergraduate Student Engineer</a:t>
-            </a:r>
-            <a:br/>
-            <a:r>
-              <a:t>• Systems Architecture &amp; CI/CD Lead</a:t>
-            </a:r>
-          </a:p>
-        </p:txBody>
-      </p:sp>
+              <a:defRPr sz="1300" b="1">
+                <a:solidFill>
+                  <a:srgbClr val="FF6E00"/>
+                </a:solidFill>
+              </a:defRPr>
+            </a:pPr>
+            <a:r>
+              <a:rPr dirty="0" smtClean="0"/>
+              <a:t>• </a:t>
+            </a:r>
+            <a:r>
+              <a:rPr lang="en-US" dirty="0" smtClean="0"/>
+              <a:t>Computer science and engineering  undergrad</a:t>
+            </a:r>
+            <a:r>
+              <a:rPr dirty="0"/>
+              <a:t/>
+            </a:r>
+            <a:br>
+              <a:rPr dirty="0"/>
+            </a:br>
+            <a:r>
+              <a:rPr dirty="0"/>
+              <a:t>• </a:t>
+            </a:r>
+            <a:r>
+              <a:rPr lang="en-US" dirty="0" smtClean="0"/>
+              <a:t>Chief infrastructure Architect</a:t>
+            </a:r>
+            <a:endParaRPr dirty="0"/>
+          </a:p>
+        </p:txBody>
+      </p:sp>
+      <p:pic>
+        <p:nvPicPr>
+          <p:cNvPr id="12" name="Picture 11"/>
+          <p:cNvPicPr>
+            <a:picLocks noChangeAspect="1"/>
+          </p:cNvPicPr>
+          <p:nvPr/>
+        </p:nvPicPr>
+        <p:blipFill>
+          <a:blip r:embed="rId2">
+            <a:extLst>
+              <a:ext uri="{28A0092B-C50C-407E-A947-70E740481C1C}">
+                <a14:useLocalDpi xmlns:a14="http://schemas.microsoft.com/office/drawing/2010/main" val="0"/>
+              </a:ext>
+            </a:extLst>
+          </a:blip>
+          <a:stretch>
+            <a:fillRect/>
+          </a:stretch>
+        </p:blipFill>
+        <p:spPr>
+          <a:xfrm>
+            <a:off x="1184435" y="1122279"/>
+            <a:ext cx="4086107" cy="3579717"/>
+          </a:xfrm>
+          <a:prstGeom prst="roundRect">
+            <a:avLst>
+              <a:gd name="adj" fmla="val 8594"/>
+            </a:avLst>
+          </a:prstGeom>
+          <a:solidFill>
+            <a:srgbClr val="FFFFFF">
+              <a:shade val="85000"/>
+            </a:srgbClr>
+          </a:solidFill>
+          <a:ln>
+            <a:noFill/>
+          </a:ln>
+          <a:effectLst>
+            <a:reflection blurRad="12700" stA="38000" endPos="28000" dist="5000" dir="5400000" sy="-100000" algn="bl" rotWithShape="0"/>
+          </a:effectLst>
+        </p:spPr>
+      </p:pic>
+      <p:pic>
+        <p:nvPicPr>
+          <p:cNvPr id="14" name="Picture 13"/>
+          <p:cNvPicPr>
+            <a:picLocks noChangeAspect="1"/>
+          </p:cNvPicPr>
+          <p:nvPr/>
+        </p:nvPicPr>
+        <p:blipFill>
+          <a:blip r:embed="rId3">
+            <a:extLst>
+              <a:ext uri="{28A0092B-C50C-407E-A947-70E740481C1C}">
+                <a14:useLocalDpi xmlns:a14="http://schemas.microsoft.com/office/drawing/2010/main" val="0"/>
+              </a:ext>
+            </a:extLst>
+          </a:blip>
+          <a:stretch>
+            <a:fillRect/>
+          </a:stretch>
+        </p:blipFill>
+        <p:spPr>
+          <a:xfrm>
+            <a:off x="6586537" y="1122279"/>
+            <a:ext cx="4043363" cy="3508998"/>
+          </a:xfrm>
+          <a:prstGeom prst="roundRect">
+            <a:avLst>
+              <a:gd name="adj" fmla="val 8594"/>
+            </a:avLst>
+          </a:prstGeom>
+          <a:solidFill>
+            <a:srgbClr val="FFFFFF">
+              <a:shade val="85000"/>
+            </a:srgbClr>
+          </a:solidFill>
+          <a:ln>
+            <a:noFill/>
+          </a:ln>
+          <a:effectLst>
+            <a:reflection blurRad="12700" stA="38000" endPos="28000" dist="5000" dir="5400000" sy="-100000" algn="bl" rotWithShape="0"/>
+          </a:effectLst>
+        </p:spPr>
+      </p:pic>
     </p:spTree>
   </p:cSld>
   <p:clrMapOvr>
     <a:masterClrMapping/>
   </p:clrMapOvr>
+  <p:timing>
+    <p:tnLst>
+      <p:par>
+        <p:cTn id="1" dur="indefinite" restart="never" nodeType="tmRoot"/>
+      </p:par>
+    </p:tnLst>
+  </p:timing>
 </p:sld>
 </file>
 
 <file path=ppt/slides/slide3.xml><?xml version="1.0" encoding="utf-8"?>
-<p:sld xmlns:a="http://schemas.openxmlformats.org/drawingml/2006/main" xmlns:p="http://schemas.openxmlformats.org/presentationml/2006/main" xmlns:r="http://schemas.openxmlformats.org/officeDocument/2006/relationships">
+<p:sld xmlns:a="http://schemas.openxmlformats.org/drawingml/2006/main" xmlns:r="http://schemas.openxmlformats.org/officeDocument/2006/relationships" xmlns:p="http://schemas.openxmlformats.org/presentationml/2006/main">
   <p:cSld>
     <p:spTree>
       <p:nvGrpSpPr>
@@ -6671,7 +7430,14 @@
         <p:cNvGrpSpPr/>
         <p:nvPr/>
       </p:nvGrpSpPr>
-      <p:grpSpPr/>
+      <p:grpSpPr>
+        <a:xfrm>
+          <a:off x="0" y="0"/>
+          <a:ext cx="0" cy="0"/>
+          <a:chOff x="0" y="0"/>
+          <a:chExt cx="0" cy="0"/>
+        </a:xfrm>
+      </p:grpSpPr>
       <p:sp>
         <p:nvSpPr>
           <p:cNvPr id="2" name="Rectangle 1"/>
@@ -6712,6 +7478,7 @@
           <a:lstStyle/>
           <a:p>
             <a:pPr algn="ctr"/>
+            <a:endParaRPr/>
           </a:p>
         </p:txBody>
       </p:sp>
@@ -6757,6 +7524,7 @@
           <a:lstStyle/>
           <a:p>
             <a:pPr algn="ctr"/>
+            <a:endParaRPr/>
           </a:p>
         </p:txBody>
       </p:sp>
@@ -6796,11 +7564,11 @@
           </a:fontRef>
         </p:style>
         <p:txBody>
-          <a:bodyPr rtlCol="0" anchor="ctr" wrap="square"/>
+          <a:bodyPr wrap="square" rtlCol="0" anchor="ctr"/>
           <a:lstStyle/>
           <a:p>
             <a:pPr algn="ctr">
-              <a:defRPr b="1" sz="2200">
+              <a:defRPr sz="2200" b="1">
                 <a:solidFill>
                   <a:srgbClr val="121212"/>
                 </a:solidFill>
@@ -6835,7 +7603,7 @@
           <a:lstStyle/>
           <a:p>
             <a:pPr>
-              <a:defRPr b="1" sz="1400">
+              <a:defRPr sz="1400" b="1">
                 <a:solidFill>
                   <a:srgbClr val="FF6E00"/>
                 </a:solidFill>
@@ -6847,7 +7615,7 @@
           </a:p>
           <a:p>
             <a:pPr>
-              <a:defRPr b="1" sz="2400">
+              <a:defRPr sz="2400" b="1">
                 <a:solidFill>
                   <a:srgbClr val="FFFFFF"/>
                 </a:solidFill>
@@ -6906,8 +7674,14 @@
               </a:defRPr>
             </a:pPr>
             <a:r>
-              <a:t>CoalØmit — REDUCE NOW SUSTAIN FOREVER  |  REDUCE NOW SUSTAIN FOREVER</a:t>
-            </a:r>
+              <a:rPr dirty="0" err="1"/>
+              <a:t>CoalØmit</a:t>
+            </a:r>
+            <a:r>
+              <a:rPr dirty="0"/>
+              <a:t> — REDUCE NOW SUSTAIN FOREVER  </a:t>
+            </a:r>
+            <a:endParaRPr lang="en-US" dirty="0"/>
           </a:p>
         </p:txBody>
       </p:sp>
@@ -6949,11 +7723,11 @@
           </a:fontRef>
         </p:style>
         <p:txBody>
-          <a:bodyPr rtlCol="0" anchor="ctr" wrap="square"/>
+          <a:bodyPr wrap="square" rtlCol="0" anchor="ctr"/>
           <a:lstStyle/>
           <a:p>
             <a:pPr algn="ctr">
-              <a:defRPr b="1" sz="1800">
+              <a:defRPr sz="1800" b="1">
                 <a:solidFill>
                   <a:srgbClr val="FF6E00"/>
                 </a:solidFill>
@@ -7063,11 +7837,11 @@
           </a:fontRef>
         </p:style>
         <p:txBody>
-          <a:bodyPr rtlCol="0" anchor="ctr" wrap="square"/>
+          <a:bodyPr wrap="square" rtlCol="0" anchor="ctr"/>
           <a:lstStyle/>
           <a:p>
             <a:pPr algn="ctr">
-              <a:defRPr b="1" sz="1800">
+              <a:defRPr sz="1800" b="1">
                 <a:solidFill>
                   <a:srgbClr val="D97706"/>
                 </a:solidFill>
@@ -7162,7 +7936,7 @@
           <a:lstStyle/>
           <a:p>
             <a:pPr algn="ctr">
-              <a:defRPr b="1" sz="1600">
+              <a:defRPr sz="1600" b="1">
                 <a:solidFill>
                   <a:srgbClr val="FF5555"/>
                 </a:solidFill>
@@ -7179,11 +7953,18 @@
   <p:clrMapOvr>
     <a:masterClrMapping/>
   </p:clrMapOvr>
+  <p:timing>
+    <p:tnLst>
+      <p:par>
+        <p:cTn id="1" dur="indefinite" restart="never" nodeType="tmRoot"/>
+      </p:par>
+    </p:tnLst>
+  </p:timing>
 </p:sld>
 </file>
 
 <file path=ppt/slides/slide4.xml><?xml version="1.0" encoding="utf-8"?>
-<p:sld xmlns:a="http://schemas.openxmlformats.org/drawingml/2006/main" xmlns:p="http://schemas.openxmlformats.org/presentationml/2006/main" xmlns:r="http://schemas.openxmlformats.org/officeDocument/2006/relationships">
+<p:sld xmlns:a="http://schemas.openxmlformats.org/drawingml/2006/main" xmlns:r="http://schemas.openxmlformats.org/officeDocument/2006/relationships" xmlns:p="http://schemas.openxmlformats.org/presentationml/2006/main">
   <p:cSld>
     <p:spTree>
       <p:nvGrpSpPr>
@@ -7191,7 +7972,14 @@
         <p:cNvGrpSpPr/>
         <p:nvPr/>
       </p:nvGrpSpPr>
-      <p:grpSpPr/>
+      <p:grpSpPr>
+        <a:xfrm>
+          <a:off x="0" y="0"/>
+          <a:ext cx="0" cy="0"/>
+          <a:chOff x="0" y="0"/>
+          <a:chExt cx="0" cy="0"/>
+        </a:xfrm>
+      </p:grpSpPr>
       <p:sp>
         <p:nvSpPr>
           <p:cNvPr id="2" name="Rectangle 1"/>
@@ -7232,6 +8020,7 @@
           <a:lstStyle/>
           <a:p>
             <a:pPr algn="ctr"/>
+            <a:endParaRPr/>
           </a:p>
         </p:txBody>
       </p:sp>
@@ -7277,6 +8066,7 @@
           <a:lstStyle/>
           <a:p>
             <a:pPr algn="ctr"/>
+            <a:endParaRPr/>
           </a:p>
         </p:txBody>
       </p:sp>
@@ -7316,11 +8106,11 @@
           </a:fontRef>
         </p:style>
         <p:txBody>
-          <a:bodyPr rtlCol="0" anchor="ctr" wrap="square"/>
+          <a:bodyPr wrap="square" rtlCol="0" anchor="ctr"/>
           <a:lstStyle/>
           <a:p>
             <a:pPr algn="ctr">
-              <a:defRPr b="1" sz="2200">
+              <a:defRPr sz="2200" b="1">
                 <a:solidFill>
                   <a:srgbClr val="121212"/>
                 </a:solidFill>
@@ -7355,7 +8145,7 @@
           <a:lstStyle/>
           <a:p>
             <a:pPr>
-              <a:defRPr b="1" sz="1400">
+              <a:defRPr sz="1400" b="1">
                 <a:solidFill>
                   <a:srgbClr val="FF6E00"/>
                 </a:solidFill>
@@ -7367,7 +8157,7 @@
           </a:p>
           <a:p>
             <a:pPr>
-              <a:defRPr b="1" sz="2400">
+              <a:defRPr sz="2400" b="1">
                 <a:solidFill>
                   <a:srgbClr val="FFFFFF"/>
                 </a:solidFill>
@@ -7426,8 +8216,18 @@
               </a:defRPr>
             </a:pPr>
             <a:r>
-              <a:t>CoalØmit — REDUCE NOW SUSTAIN FOREVER  |  REDUCE NOW SUSTAIN FOREVER</a:t>
-            </a:r>
+              <a:rPr dirty="0" err="1"/>
+              <a:t>CoalØmit</a:t>
+            </a:r>
+            <a:r>
+              <a:rPr dirty="0"/>
+              <a:t> — REDUCE NOW SUSTAIN </a:t>
+            </a:r>
+            <a:r>
+              <a:rPr dirty="0" smtClean="0"/>
+              <a:t>FOREVER</a:t>
+            </a:r>
+            <a:endParaRPr dirty="0"/>
           </a:p>
         </p:txBody>
       </p:sp>
@@ -7454,7 +8254,7 @@
           <a:lstStyle/>
           <a:p>
             <a:pPr>
-              <a:defRPr b="1" sz="1400">
+              <a:defRPr sz="1400" b="1">
                 <a:solidFill>
                   <a:srgbClr val="FF6E00"/>
                 </a:solidFill>
@@ -7476,10 +8276,11 @@
               <a:t>Developer runs `cac run model.py --methods int8,int4`</a:t>
             </a:r>
             <a:br/>
+            <a:endParaRPr/>
           </a:p>
           <a:p>
             <a:pPr>
-              <a:defRPr b="1" sz="1400">
+              <a:defRPr sz="1400" b="1">
                 <a:solidFill>
                   <a:srgbClr val="FF6E00"/>
                 </a:solidFill>
@@ -7501,10 +8302,11 @@
               <a:t>PyTorch native FlopCounterMode profiles hardware energy</a:t>
             </a:r>
             <a:br/>
+            <a:endParaRPr/>
           </a:p>
           <a:p>
             <a:pPr>
-              <a:defRPr b="1" sz="1400">
+              <a:defRPr sz="1400" b="1">
                 <a:solidFill>
                   <a:srgbClr val="FF6E00"/>
                 </a:solidFill>
@@ -7526,10 +8328,11 @@
               <a:t>Energy mapped to monthly CO₂ across 35+ regional power grids</a:t>
             </a:r>
             <a:br/>
+            <a:endParaRPr/>
           </a:p>
           <a:p>
             <a:pPr>
-              <a:defRPr b="1" sz="1400">
+              <a:defRPr sz="1400" b="1">
                 <a:solidFill>
                   <a:srgbClr val="FF6E00"/>
                 </a:solidFill>
@@ -7551,6 +8354,7 @@
               <a:t>GitHub Action posts before/after carbon comparison on PRs</a:t>
             </a:r>
             <a:br/>
+            <a:endParaRPr/>
           </a:p>
         </p:txBody>
       </p:sp>
@@ -7592,11 +8396,11 @@
           </a:fontRef>
         </p:style>
         <p:txBody>
-          <a:bodyPr rtlCol="0" anchor="ctr" wrap="square"/>
+          <a:bodyPr wrap="square" rtlCol="0" anchor="ctr"/>
           <a:lstStyle/>
           <a:p>
             <a:pPr algn="ctr">
-              <a:defRPr b="1" sz="2200">
+              <a:defRPr sz="2200" b="1">
                 <a:solidFill>
                   <a:srgbClr val="FF6E00"/>
                 </a:solidFill>
@@ -7679,7 +8483,7 @@
           <a:lstStyle/>
           <a:p>
             <a:pPr algn="ctr">
-              <a:defRPr b="1" sz="1600">
+              <a:defRPr sz="1600" b="1">
                 <a:solidFill>
                   <a:srgbClr val="FF5555"/>
                 </a:solidFill>
@@ -7696,11 +8500,18 @@
   <p:clrMapOvr>
     <a:masterClrMapping/>
   </p:clrMapOvr>
+  <p:timing>
+    <p:tnLst>
+      <p:par>
+        <p:cTn id="1" dur="indefinite" restart="never" nodeType="tmRoot"/>
+      </p:par>
+    </p:tnLst>
+  </p:timing>
 </p:sld>
 </file>
 
 <file path=ppt/slides/slide5.xml><?xml version="1.0" encoding="utf-8"?>
-<p:sld xmlns:a="http://schemas.openxmlformats.org/drawingml/2006/main" xmlns:p="http://schemas.openxmlformats.org/presentationml/2006/main" xmlns:r="http://schemas.openxmlformats.org/officeDocument/2006/relationships">
+<p:sld xmlns:a="http://schemas.openxmlformats.org/drawingml/2006/main" xmlns:r="http://schemas.openxmlformats.org/officeDocument/2006/relationships" xmlns:p="http://schemas.openxmlformats.org/presentationml/2006/main">
   <p:cSld>
     <p:spTree>
       <p:nvGrpSpPr>
@@ -7708,7 +8519,14 @@
         <p:cNvGrpSpPr/>
         <p:nvPr/>
       </p:nvGrpSpPr>
-      <p:grpSpPr/>
+      <p:grpSpPr>
+        <a:xfrm>
+          <a:off x="0" y="0"/>
+          <a:ext cx="0" cy="0"/>
+          <a:chOff x="0" y="0"/>
+          <a:chExt cx="0" cy="0"/>
+        </a:xfrm>
+      </p:grpSpPr>
       <p:sp>
         <p:nvSpPr>
           <p:cNvPr id="2" name="Rectangle 1"/>
@@ -7749,6 +8567,7 @@
           <a:lstStyle/>
           <a:p>
             <a:pPr algn="ctr"/>
+            <a:endParaRPr/>
           </a:p>
         </p:txBody>
       </p:sp>
@@ -7794,6 +8613,7 @@
           <a:lstStyle/>
           <a:p>
             <a:pPr algn="ctr"/>
+            <a:endParaRPr/>
           </a:p>
         </p:txBody>
       </p:sp>
@@ -7833,11 +8653,11 @@
           </a:fontRef>
         </p:style>
         <p:txBody>
-          <a:bodyPr rtlCol="0" anchor="ctr" wrap="square"/>
+          <a:bodyPr wrap="square" rtlCol="0" anchor="ctr"/>
           <a:lstStyle/>
           <a:p>
             <a:pPr algn="ctr">
-              <a:defRPr b="1" sz="2200">
+              <a:defRPr sz="2200" b="1">
                 <a:solidFill>
                   <a:srgbClr val="121212"/>
                 </a:solidFill>
@@ -7872,7 +8692,7 @@
           <a:lstStyle/>
           <a:p>
             <a:pPr>
-              <a:defRPr b="1" sz="1400">
+              <a:defRPr sz="1400" b="1">
                 <a:solidFill>
                   <a:srgbClr val="FF6E00"/>
                 </a:solidFill>
@@ -7884,7 +8704,7 @@
           </a:p>
           <a:p>
             <a:pPr>
-              <a:defRPr b="1" sz="2400">
+              <a:defRPr sz="2400" b="1">
                 <a:solidFill>
                   <a:srgbClr val="FFFFFF"/>
                 </a:solidFill>
@@ -7943,7 +8763,20 @@
               </a:defRPr>
             </a:pPr>
             <a:r>
-              <a:t>CoalØmit — REDUCE NOW SUSTAIN FOREVER  |  REDUCE NOW SUSTAIN FOREVER</a:t>
+              <a:rPr dirty="0" err="1"/>
+              <a:t>CoalØmit</a:t>
+            </a:r>
+            <a:r>
+              <a:rPr dirty="0"/>
+              <a:t> — REDUCE NOW </a:t>
+            </a:r>
+            <a:r>
+              <a:rPr dirty="0" smtClean="0"/>
+              <a:t>SUSTAIN</a:t>
+            </a:r>
+            <a:r>
+              <a:rPr lang="en-US" dirty="0" smtClean="0"/>
+              <a:t> FOREVER</a:t>
             </a:r>
           </a:p>
         </p:txBody>
@@ -7971,7 +8804,7 @@
           <a:lstStyle/>
           <a:p>
             <a:pPr>
-              <a:defRPr b="1" sz="1500">
+              <a:defRPr sz="1500" b="1">
                 <a:solidFill>
                   <a:srgbClr val="FF6E00"/>
                 </a:solidFill>
@@ -7993,10 +8826,11 @@
               <a:t>    Accurately counts exact hardware FLOPs per inference without modifying model code.</a:t>
             </a:r>
             <a:br/>
+            <a:endParaRPr/>
           </a:p>
           <a:p>
             <a:pPr>
-              <a:defRPr b="1" sz="1500">
+              <a:defRPr sz="1500" b="1">
                 <a:solidFill>
                   <a:srgbClr val="FF6E00"/>
                 </a:solidFill>
@@ -8018,10 +8852,11 @@
               <a:t>    Supports FP32 Baseline, INT8 Dynamic, INT4 Weight-Only, AWQ, and GPTQ quantization backends.</a:t>
             </a:r>
             <a:br/>
+            <a:endParaRPr/>
           </a:p>
           <a:p>
             <a:pPr>
-              <a:defRPr b="1" sz="1500">
+              <a:defRPr sz="1500" b="1">
                 <a:solidFill>
                   <a:srgbClr val="FF6E00"/>
                 </a:solidFill>
@@ -8043,10 +8878,11 @@
               <a:t>    Pre-computed intensity metrics for 35+ country grids (gCO₂/kWh) with live Electricity Maps API fallback.</a:t>
             </a:r>
             <a:br/>
+            <a:endParaRPr/>
           </a:p>
           <a:p>
             <a:pPr>
-              <a:defRPr b="1" sz="1500">
+              <a:defRPr sz="1500" b="1">
                 <a:solidFill>
                   <a:srgbClr val="FF6E00"/>
                 </a:solidFill>
@@ -8068,10 +8904,11 @@
               <a:t>    GitHub Action container that posts detailed before/after carbon trade-off tables directly onto Pull Requests.</a:t>
             </a:r>
             <a:br/>
+            <a:endParaRPr/>
           </a:p>
           <a:p>
             <a:pPr>
-              <a:defRPr b="1" sz="1500">
+              <a:defRPr sz="1500" b="1">
                 <a:solidFill>
                   <a:srgbClr val="FF6E00"/>
                 </a:solidFill>
@@ -8093,6 +8930,7 @@
               <a:t>    Command-line tool producing color-coded terminal tables, Markdown reports, and JSON exports.</a:t>
             </a:r>
             <a:br/>
+            <a:endParaRPr/>
           </a:p>
         </p:txBody>
       </p:sp>
@@ -8101,11 +8939,18 @@
   <p:clrMapOvr>
     <a:masterClrMapping/>
   </p:clrMapOvr>
+  <p:timing>
+    <p:tnLst>
+      <p:par>
+        <p:cTn id="1" dur="indefinite" restart="never" nodeType="tmRoot"/>
+      </p:par>
+    </p:tnLst>
+  </p:timing>
 </p:sld>
 </file>
 
 <file path=ppt/slides/slide6.xml><?xml version="1.0" encoding="utf-8"?>
-<p:sld xmlns:a="http://schemas.openxmlformats.org/drawingml/2006/main" xmlns:p="http://schemas.openxmlformats.org/presentationml/2006/main" xmlns:r="http://schemas.openxmlformats.org/officeDocument/2006/relationships">
+<p:sld xmlns:a="http://schemas.openxmlformats.org/drawingml/2006/main" xmlns:r="http://schemas.openxmlformats.org/officeDocument/2006/relationships" xmlns:p="http://schemas.openxmlformats.org/presentationml/2006/main">
   <p:cSld>
     <p:spTree>
       <p:nvGrpSpPr>
@@ -8113,7 +8958,14 @@
         <p:cNvGrpSpPr/>
         <p:nvPr/>
       </p:nvGrpSpPr>
-      <p:grpSpPr/>
+      <p:grpSpPr>
+        <a:xfrm>
+          <a:off x="0" y="0"/>
+          <a:ext cx="0" cy="0"/>
+          <a:chOff x="0" y="0"/>
+          <a:chExt cx="0" cy="0"/>
+        </a:xfrm>
+      </p:grpSpPr>
       <p:sp>
         <p:nvSpPr>
           <p:cNvPr id="2" name="Rectangle 1"/>
@@ -8154,6 +9006,7 @@
           <a:lstStyle/>
           <a:p>
             <a:pPr algn="ctr"/>
+            <a:endParaRPr/>
           </a:p>
         </p:txBody>
       </p:sp>
@@ -8199,6 +9052,7 @@
           <a:lstStyle/>
           <a:p>
             <a:pPr algn="ctr"/>
+            <a:endParaRPr/>
           </a:p>
         </p:txBody>
       </p:sp>
@@ -8238,11 +9092,11 @@
           </a:fontRef>
         </p:style>
         <p:txBody>
-          <a:bodyPr rtlCol="0" anchor="ctr" wrap="square"/>
+          <a:bodyPr wrap="square" rtlCol="0" anchor="ctr"/>
           <a:lstStyle/>
           <a:p>
             <a:pPr algn="ctr">
-              <a:defRPr b="1" sz="2200">
+              <a:defRPr sz="2200" b="1">
                 <a:solidFill>
                   <a:srgbClr val="121212"/>
                 </a:solidFill>
@@ -8277,7 +9131,7 @@
           <a:lstStyle/>
           <a:p>
             <a:pPr>
-              <a:defRPr b="1" sz="1400">
+              <a:defRPr sz="1400" b="1">
                 <a:solidFill>
                   <a:srgbClr val="FF6E00"/>
                 </a:solidFill>
@@ -8289,7 +9143,7 @@
           </a:p>
           <a:p>
             <a:pPr>
-              <a:defRPr b="1" sz="2400">
+              <a:defRPr sz="2400" b="1">
                 <a:solidFill>
                   <a:srgbClr val="FFFFFF"/>
                 </a:solidFill>
@@ -8348,8 +9202,22 @@
               </a:defRPr>
             </a:pPr>
             <a:r>
-              <a:t>CoalØmit — REDUCE NOW SUSTAIN FOREVER  |  REDUCE NOW SUSTAIN FOREVER</a:t>
-            </a:r>
+              <a:rPr dirty="0" err="1"/>
+              <a:t>CoalØmit</a:t>
+            </a:r>
+            <a:r>
+              <a:rPr dirty="0"/>
+              <a:t> — REDUCE NOW </a:t>
+            </a:r>
+            <a:r>
+              <a:rPr dirty="0" smtClean="0"/>
+              <a:t>SUSTAIN</a:t>
+            </a:r>
+            <a:r>
+              <a:rPr lang="en-US" dirty="0" smtClean="0"/>
+              <a:t> FOREVER</a:t>
+            </a:r>
+            <a:endParaRPr dirty="0"/>
           </a:p>
         </p:txBody>
       </p:sp>
@@ -8384,7 +9252,7 @@
                     <a:lstStyle/>
                     <a:p>
                       <a:pPr algn="ctr">
-                        <a:defRPr b="1" sz="1300">
+                        <a:defRPr sz="1300" b="1">
                           <a:solidFill>
                             <a:srgbClr val="FF6E00"/>
                           </a:solidFill>
@@ -8407,7 +9275,7 @@
                     <a:lstStyle/>
                     <a:p>
                       <a:pPr algn="ctr">
-                        <a:defRPr b="1" sz="1300">
+                        <a:defRPr sz="1300" b="1">
                           <a:solidFill>
                             <a:srgbClr val="FF6E00"/>
                           </a:solidFill>
@@ -8430,7 +9298,7 @@
                     <a:lstStyle/>
                     <a:p>
                       <a:pPr algn="ctr">
-                        <a:defRPr b="1" sz="1300">
+                        <a:defRPr sz="1300" b="1">
                           <a:solidFill>
                             <a:srgbClr val="FF6E00"/>
                           </a:solidFill>
@@ -8453,7 +9321,7 @@
                     <a:lstStyle/>
                     <a:p>
                       <a:pPr algn="ctr">
-                        <a:defRPr b="1" sz="1300">
+                        <a:defRPr sz="1300" b="1">
                           <a:solidFill>
                             <a:srgbClr val="FF6E00"/>
                           </a:solidFill>
@@ -8762,11 +9630,18 @@
   <p:clrMapOvr>
     <a:masterClrMapping/>
   </p:clrMapOvr>
+  <p:timing>
+    <p:tnLst>
+      <p:par>
+        <p:cTn id="1" dur="indefinite" restart="never" nodeType="tmRoot"/>
+      </p:par>
+    </p:tnLst>
+  </p:timing>
 </p:sld>
 </file>
 
 <file path=ppt/slides/slide7.xml><?xml version="1.0" encoding="utf-8"?>
-<p:sld xmlns:a="http://schemas.openxmlformats.org/drawingml/2006/main" xmlns:p="http://schemas.openxmlformats.org/presentationml/2006/main" xmlns:r="http://schemas.openxmlformats.org/officeDocument/2006/relationships">
+<p:sld xmlns:a="http://schemas.openxmlformats.org/drawingml/2006/main" xmlns:r="http://schemas.openxmlformats.org/officeDocument/2006/relationships" xmlns:p="http://schemas.openxmlformats.org/presentationml/2006/main">
   <p:cSld>
     <p:spTree>
       <p:nvGrpSpPr>
@@ -8774,7 +9649,14 @@
         <p:cNvGrpSpPr/>
         <p:nvPr/>
       </p:nvGrpSpPr>
-      <p:grpSpPr/>
+      <p:grpSpPr>
+        <a:xfrm>
+          <a:off x="0" y="0"/>
+          <a:ext cx="0" cy="0"/>
+          <a:chOff x="0" y="0"/>
+          <a:chExt cx="0" cy="0"/>
+        </a:xfrm>
+      </p:grpSpPr>
       <p:sp>
         <p:nvSpPr>
           <p:cNvPr id="2" name="Rectangle 1"/>
@@ -8815,6 +9697,7 @@
           <a:lstStyle/>
           <a:p>
             <a:pPr algn="ctr"/>
+            <a:endParaRPr/>
           </a:p>
         </p:txBody>
       </p:sp>
@@ -8860,6 +9743,7 @@
           <a:lstStyle/>
           <a:p>
             <a:pPr algn="ctr"/>
+            <a:endParaRPr/>
           </a:p>
         </p:txBody>
       </p:sp>
@@ -8899,11 +9783,11 @@
           </a:fontRef>
         </p:style>
         <p:txBody>
-          <a:bodyPr rtlCol="0" anchor="ctr" wrap="square"/>
+          <a:bodyPr wrap="square" rtlCol="0" anchor="ctr"/>
           <a:lstStyle/>
           <a:p>
             <a:pPr algn="ctr">
-              <a:defRPr b="1" sz="2200">
+              <a:defRPr sz="2200" b="1">
                 <a:solidFill>
                   <a:srgbClr val="121212"/>
                 </a:solidFill>
@@ -8938,7 +9822,7 @@
           <a:lstStyle/>
           <a:p>
             <a:pPr>
-              <a:defRPr b="1" sz="1400">
+              <a:defRPr sz="1400" b="1">
                 <a:solidFill>
                   <a:srgbClr val="FF6E00"/>
                 </a:solidFill>
@@ -8950,7 +9834,7 @@
           </a:p>
           <a:p>
             <a:pPr>
-              <a:defRPr b="1" sz="2400">
+              <a:defRPr sz="2400" b="1">
                 <a:solidFill>
                   <a:srgbClr val="FFFFFF"/>
                 </a:solidFill>
@@ -9056,13 +9940,19 @@
           <a:lstStyle/>
           <a:p>
             <a:pPr algn="ctr">
-              <a:defRPr b="1" sz="2400">
+              <a:defRPr sz="2400" b="1">
                 <a:solidFill>
                   <a:srgbClr val="FF6E00"/>
                 </a:solidFill>
               </a:defRPr>
             </a:pPr>
+            <a:r>
+              <a:t/>
+            </a:r>
             <a:br/>
+            <a:r>
+              <a:t/>
+            </a:r>
             <a:br/>
             <a:r>
               <a:t>PRODUCT</a:t>
@@ -9155,12 +10045,15 @@
           <a:lstStyle/>
           <a:p>
             <a:pPr algn="ctr">
-              <a:defRPr b="1" sz="2400">
+              <a:defRPr sz="2400" b="1">
                 <a:solidFill>
                   <a:srgbClr val="D97706"/>
                 </a:solidFill>
               </a:defRPr>
             </a:pPr>
+            <a:r>
+              <a:t/>
+            </a:r>
             <a:br/>
             <a:r>
               <a:t>SERVICE</a:t>
@@ -9216,11 +10109,18 @@
   <p:clrMapOvr>
     <a:masterClrMapping/>
   </p:clrMapOvr>
+  <p:timing>
+    <p:tnLst>
+      <p:par>
+        <p:cTn id="1" dur="indefinite" restart="never" nodeType="tmRoot"/>
+      </p:par>
+    </p:tnLst>
+  </p:timing>
 </p:sld>
 </file>
 
 <file path=ppt/slides/slide8.xml><?xml version="1.0" encoding="utf-8"?>
-<p:sld xmlns:a="http://schemas.openxmlformats.org/drawingml/2006/main" xmlns:p="http://schemas.openxmlformats.org/presentationml/2006/main" xmlns:r="http://schemas.openxmlformats.org/officeDocument/2006/relationships">
+<p:sld xmlns:a="http://schemas.openxmlformats.org/drawingml/2006/main" xmlns:r="http://schemas.openxmlformats.org/officeDocument/2006/relationships" xmlns:p="http://schemas.openxmlformats.org/presentationml/2006/main">
   <p:cSld>
     <p:spTree>
       <p:nvGrpSpPr>
@@ -9228,7 +10128,14 @@
         <p:cNvGrpSpPr/>
         <p:nvPr/>
       </p:nvGrpSpPr>
-      <p:grpSpPr/>
+      <p:grpSpPr>
+        <a:xfrm>
+          <a:off x="0" y="0"/>
+          <a:ext cx="0" cy="0"/>
+          <a:chOff x="0" y="0"/>
+          <a:chExt cx="0" cy="0"/>
+        </a:xfrm>
+      </p:grpSpPr>
       <p:sp>
         <p:nvSpPr>
           <p:cNvPr id="2" name="Rectangle 1"/>
@@ -9269,6 +10176,7 @@
           <a:lstStyle/>
           <a:p>
             <a:pPr algn="ctr"/>
+            <a:endParaRPr/>
           </a:p>
         </p:txBody>
       </p:sp>
@@ -9314,6 +10222,7 @@
           <a:lstStyle/>
           <a:p>
             <a:pPr algn="ctr"/>
+            <a:endParaRPr/>
           </a:p>
         </p:txBody>
       </p:sp>
@@ -9353,11 +10262,11 @@
           </a:fontRef>
         </p:style>
         <p:txBody>
-          <a:bodyPr rtlCol="0" anchor="ctr" wrap="square"/>
+          <a:bodyPr wrap="square" rtlCol="0" anchor="ctr"/>
           <a:lstStyle/>
           <a:p>
             <a:pPr algn="ctr">
-              <a:defRPr b="1" sz="2200">
+              <a:defRPr sz="2200" b="1">
                 <a:solidFill>
                   <a:srgbClr val="121212"/>
                 </a:solidFill>
@@ -9392,7 +10301,7 @@
           <a:lstStyle/>
           <a:p>
             <a:pPr>
-              <a:defRPr b="1" sz="1400">
+              <a:defRPr sz="1400" b="1">
                 <a:solidFill>
                   <a:srgbClr val="FF6E00"/>
                 </a:solidFill>
@@ -9404,7 +10313,7 @@
           </a:p>
           <a:p>
             <a:pPr>
-              <a:defRPr b="1" sz="2400">
+              <a:defRPr sz="2400" b="1">
                 <a:solidFill>
                   <a:srgbClr val="FFFFFF"/>
                 </a:solidFill>
@@ -9498,7 +10407,7 @@
                     <a:lstStyle/>
                     <a:p>
                       <a:pPr algn="ctr">
-                        <a:defRPr b="1" sz="1300">
+                        <a:defRPr sz="1300" b="1">
                           <a:solidFill>
                             <a:srgbClr val="FF6E00"/>
                           </a:solidFill>
@@ -9521,7 +10430,7 @@
                     <a:lstStyle/>
                     <a:p>
                       <a:pPr algn="ctr">
-                        <a:defRPr b="1" sz="1300">
+                        <a:defRPr sz="1300" b="1">
                           <a:solidFill>
                             <a:srgbClr val="FF6E00"/>
                           </a:solidFill>
@@ -9544,7 +10453,7 @@
                     <a:lstStyle/>
                     <a:p>
                       <a:pPr algn="ctr">
-                        <a:defRPr b="1" sz="1300">
+                        <a:defRPr sz="1300" b="1">
                           <a:solidFill>
                             <a:srgbClr val="FF6E00"/>
                           </a:solidFill>
@@ -9926,11 +10835,18 @@
   <p:clrMapOvr>
     <a:masterClrMapping/>
   </p:clrMapOvr>
+  <p:timing>
+    <p:tnLst>
+      <p:par>
+        <p:cTn id="1" dur="indefinite" restart="never" nodeType="tmRoot"/>
+      </p:par>
+    </p:tnLst>
+  </p:timing>
 </p:sld>
 </file>
 
 <file path=ppt/slides/slide9.xml><?xml version="1.0" encoding="utf-8"?>
-<p:sld xmlns:a="http://schemas.openxmlformats.org/drawingml/2006/main" xmlns:p="http://schemas.openxmlformats.org/presentationml/2006/main" xmlns:r="http://schemas.openxmlformats.org/officeDocument/2006/relationships">
+<p:sld xmlns:a="http://schemas.openxmlformats.org/drawingml/2006/main" xmlns:r="http://schemas.openxmlformats.org/officeDocument/2006/relationships" xmlns:p="http://schemas.openxmlformats.org/presentationml/2006/main">
   <p:cSld>
     <p:spTree>
       <p:nvGrpSpPr>
@@ -9938,7 +10854,14 @@
         <p:cNvGrpSpPr/>
         <p:nvPr/>
       </p:nvGrpSpPr>
-      <p:grpSpPr/>
+      <p:grpSpPr>
+        <a:xfrm>
+          <a:off x="0" y="0"/>
+          <a:ext cx="0" cy="0"/>
+          <a:chOff x="0" y="0"/>
+          <a:chExt cx="0" cy="0"/>
+        </a:xfrm>
+      </p:grpSpPr>
       <p:sp>
         <p:nvSpPr>
           <p:cNvPr id="2" name="Rectangle 1"/>
@@ -9979,6 +10902,7 @@
           <a:lstStyle/>
           <a:p>
             <a:pPr algn="ctr"/>
+            <a:endParaRPr/>
           </a:p>
         </p:txBody>
       </p:sp>
@@ -10024,6 +10948,7 @@
           <a:lstStyle/>
           <a:p>
             <a:pPr algn="ctr"/>
+            <a:endParaRPr/>
           </a:p>
         </p:txBody>
       </p:sp>
@@ -10063,11 +10988,11 @@
           </a:fontRef>
         </p:style>
         <p:txBody>
-          <a:bodyPr rtlCol="0" anchor="ctr" wrap="square"/>
+          <a:bodyPr wrap="square" rtlCol="0" anchor="ctr"/>
           <a:lstStyle/>
           <a:p>
             <a:pPr algn="ctr">
-              <a:defRPr b="1" sz="2200">
+              <a:defRPr sz="2200" b="1">
                 <a:solidFill>
                   <a:srgbClr val="121212"/>
                 </a:solidFill>
@@ -10102,7 +11027,7 @@
           <a:lstStyle/>
           <a:p>
             <a:pPr>
-              <a:defRPr b="1" sz="1400">
+              <a:defRPr sz="1400" b="1">
                 <a:solidFill>
                   <a:srgbClr val="FF6E00"/>
                 </a:solidFill>
@@ -10114,7 +11039,7 @@
           </a:p>
           <a:p>
             <a:pPr>
-              <a:defRPr b="1" sz="2400">
+              <a:defRPr sz="2400" b="1">
                 <a:solidFill>
                   <a:srgbClr val="FFFFFF"/>
                 </a:solidFill>
@@ -10173,8 +11098,18 @@
               </a:defRPr>
             </a:pPr>
             <a:r>
-              <a:t>CoalØmit — REDUCE NOW SUSTAIN FOREVER  |  REDUCE NOW SUSTAIN FOREVER</a:t>
-            </a:r>
+              <a:rPr dirty="0" err="1"/>
+              <a:t>CoalØmit</a:t>
+            </a:r>
+            <a:r>
+              <a:rPr dirty="0"/>
+              <a:t> — REDUCE NOW SUSTAIN FOREVER  </a:t>
+            </a:r>
+            <a:r>
+              <a:rPr dirty="0" smtClean="0"/>
+              <a:t> </a:t>
+            </a:r>
+            <a:endParaRPr dirty="0"/>
           </a:p>
         </p:txBody>
       </p:sp>
@@ -10216,11 +11151,11 @@
           </a:fontRef>
         </p:style>
         <p:txBody>
-          <a:bodyPr rtlCol="0" anchor="ctr" wrap="square"/>
+          <a:bodyPr wrap="square" rtlCol="0" anchor="ctr"/>
           <a:lstStyle/>
           <a:p>
             <a:pPr algn="ctr">
-              <a:defRPr b="1" sz="1800">
+              <a:defRPr sz="1800" b="1">
                 <a:solidFill>
                   <a:srgbClr val="FF6E00"/>
                 </a:solidFill>
@@ -10330,11 +11265,11 @@
           </a:fontRef>
         </p:style>
         <p:txBody>
-          <a:bodyPr rtlCol="0" anchor="ctr" wrap="square"/>
+          <a:bodyPr wrap="square" rtlCol="0" anchor="ctr"/>
           <a:lstStyle/>
           <a:p>
             <a:pPr algn="ctr">
-              <a:defRPr b="1" sz="1800">
+              <a:defRPr sz="1800" b="1">
                 <a:solidFill>
                   <a:srgbClr val="D97706"/>
                 </a:solidFill>
@@ -10411,6 +11346,13 @@
   <p:clrMapOvr>
     <a:masterClrMapping/>
   </p:clrMapOvr>
+  <p:timing>
+    <p:tnLst>
+      <p:par>
+        <p:cTn id="1" dur="indefinite" restart="never" nodeType="tmRoot"/>
+      </p:par>
+    </p:tnLst>
+  </p:timing>
 </p:sld>
 </file>
 

</xml_diff>